<commit_message>
Harden final AI defense demo
</commit_message>
<xml_diff>
--- a/outputs/manual-20260526-apk-sbom-deck/presentations/apk-sbom-defense/output/apk-sbom-defense-deck.pptx
+++ b/outputs/manual-20260526-apk-sbom-deck/presentations/apk-sbom-defense/output/apk-sbom-defense-deck.pptx
@@ -2,24 +2,25 @@
 <file path=ppt/presentation.xml><?xml version="1.0" encoding="utf-8"?>
 <p:presentation xmlns:p="http://schemas.openxmlformats.org/presentationml/2006/main">
   <p:sldMasterIdLst>
-    <p:sldMasterId xmlns:r="http://schemas.openxmlformats.org/officeDocument/2006/relationships" id="2147483648" r:id="R7d7b4df4c0704d47"/>
+    <p:sldMasterId xmlns:r="http://schemas.openxmlformats.org/officeDocument/2006/relationships" id="2147483648" r:id="R3059b4b40014433d"/>
   </p:sldMasterIdLst>
   <p:notesMasterIdLst>
-    <p:notesMasterId xmlns:r="http://schemas.openxmlformats.org/officeDocument/2006/relationships" r:id="R5c9e5cdd3bce46bd"/>
+    <p:notesMasterId xmlns:r="http://schemas.openxmlformats.org/officeDocument/2006/relationships" r:id="Rcae0d0161bb444fc"/>
   </p:notesMasterIdLst>
   <p:sldIdLst>
-    <p:sldId xmlns:r="http://schemas.openxmlformats.org/officeDocument/2006/relationships" id="256" r:id="R87c9a4a8f9714444"/>
-    <p:sldId xmlns:r="http://schemas.openxmlformats.org/officeDocument/2006/relationships" id="257" r:id="R74e43c4db5344323"/>
-    <p:sldId xmlns:r="http://schemas.openxmlformats.org/officeDocument/2006/relationships" id="258" r:id="R45ab183e6df34f24"/>
-    <p:sldId xmlns:r="http://schemas.openxmlformats.org/officeDocument/2006/relationships" id="259" r:id="Rb6288d4a84804338"/>
-    <p:sldId xmlns:r="http://schemas.openxmlformats.org/officeDocument/2006/relationships" id="260" r:id="R8d31156393f446e9"/>
-    <p:sldId xmlns:r="http://schemas.openxmlformats.org/officeDocument/2006/relationships" id="261" r:id="R2b76fd3fb2ae42f6"/>
-    <p:sldId xmlns:r="http://schemas.openxmlformats.org/officeDocument/2006/relationships" id="262" r:id="Re77db0c9d6a84565"/>
-    <p:sldId xmlns:r="http://schemas.openxmlformats.org/officeDocument/2006/relationships" id="263" r:id="R905e41c7011f482f"/>
-    <p:sldId xmlns:r="http://schemas.openxmlformats.org/officeDocument/2006/relationships" id="264" r:id="R3c57738e0115451b"/>
-    <p:sldId xmlns:r="http://schemas.openxmlformats.org/officeDocument/2006/relationships" id="265" r:id="Rbd19e59798e64ea9"/>
-    <p:sldId xmlns:r="http://schemas.openxmlformats.org/officeDocument/2006/relationships" id="266" r:id="R3d55e77e84364b13"/>
-    <p:sldId xmlns:r="http://schemas.openxmlformats.org/officeDocument/2006/relationships" id="267" r:id="R46a01593d6ff48f7"/>
+    <p:sldId xmlns:r="http://schemas.openxmlformats.org/officeDocument/2006/relationships" id="256" r:id="Redaf0fa3d11b4a2e"/>
+    <p:sldId xmlns:r="http://schemas.openxmlformats.org/officeDocument/2006/relationships" id="257" r:id="R129f88ea8ddb4f70"/>
+    <p:sldId xmlns:r="http://schemas.openxmlformats.org/officeDocument/2006/relationships" id="258" r:id="Reba17a595235475e"/>
+    <p:sldId xmlns:r="http://schemas.openxmlformats.org/officeDocument/2006/relationships" id="259" r:id="R6deb98243a494022"/>
+    <p:sldId xmlns:r="http://schemas.openxmlformats.org/officeDocument/2006/relationships" id="260" r:id="R71ca76fe07c34393"/>
+    <p:sldId xmlns:r="http://schemas.openxmlformats.org/officeDocument/2006/relationships" id="261" r:id="R50f36123e9904de6"/>
+    <p:sldId xmlns:r="http://schemas.openxmlformats.org/officeDocument/2006/relationships" id="262" r:id="R528af67b615c4d48"/>
+    <p:sldId xmlns:r="http://schemas.openxmlformats.org/officeDocument/2006/relationships" id="263" r:id="Rc4fb040865494c8b"/>
+    <p:sldId xmlns:r="http://schemas.openxmlformats.org/officeDocument/2006/relationships" id="264" r:id="R85cdd492453f48ae"/>
+    <p:sldId xmlns:r="http://schemas.openxmlformats.org/officeDocument/2006/relationships" id="265" r:id="R213a94d66abe4fa0"/>
+    <p:sldId xmlns:r="http://schemas.openxmlformats.org/officeDocument/2006/relationships" id="266" r:id="R73a4fad819d54138"/>
+    <p:sldId xmlns:r="http://schemas.openxmlformats.org/officeDocument/2006/relationships" id="267" r:id="Rdff265c6edbe4acd"/>
+    <p:sldId xmlns:r="http://schemas.openxmlformats.org/officeDocument/2006/relationships" id="268" r:id="R19ee32e15d554d9c"/>
   </p:sldIdLst>
   <p:sldSz cx="12192000" cy="6858000"/>
   <p:notesSz cx="6858000" cy="9144000"/>
@@ -788,6 +789,76 @@
 </p:notes>
 </file>
 
+<file path=ppt/notesSlides/notesSlide13.xml><?xml version="1.0" encoding="utf-8"?>
+<p:notes xmlns:p="http://schemas.openxmlformats.org/presentationml/2006/main">
+  <p:cSld>
+    <p:spTree>
+      <p:nvGrpSpPr>
+        <p:cNvPr id="1" name=""/>
+        <p:cNvGrpSpPr/>
+        <p:nvPr/>
+      </p:nvGrpSpPr>
+      <p:grpSpPr>
+        <a:xfrm xmlns:a="http://schemas.openxmlformats.org/drawingml/2006/main"/>
+      </p:grpSpPr>
+      <p:sp>
+        <p:nvSpPr>
+          <p:cNvPr id="2" name="Slide Image Placeholder 1"/>
+          <p:cNvSpPr>
+            <a:spLocks xmlns:a="http://schemas.openxmlformats.org/drawingml/2006/main" noGrp="1"/>
+          </p:cNvSpPr>
+          <p:nvPr>
+            <p:ph type="sldImg" idx="0"/>
+          </p:nvPr>
+        </p:nvSpPr>
+        <p:spPr/>
+      </p:sp>
+      <p:sp>
+        <p:nvSpPr>
+          <p:cNvPr id="3" name="Notes Placeholder 2"/>
+          <p:cNvSpPr>
+            <a:spLocks xmlns:a="http://schemas.openxmlformats.org/drawingml/2006/main" noGrp="1"/>
+          </p:cNvSpPr>
+          <p:nvPr>
+            <p:ph type="body" idx="1"/>
+          </p:nvPr>
+        </p:nvSpPr>
+        <p:spPr/>
+        <p:txBody>
+          <a:bodyPr xmlns:a="http://schemas.openxmlformats.org/drawingml/2006/main"/>
+          <a:lstStyle xmlns:a="http://schemas.openxmlformats.org/drawingml/2006/main"/>
+          <a:p xmlns:a="http://schemas.openxmlformats.org/drawingml/2006/main">
+            <a:r>
+              <a:t>Present the AI layer as a guarded research contribution. The RandomForest is integrated for report-only suggestions. The MVP-safe Transformer is a stronger report-only risk-triage candidate. The raw-opcode negative result is retained honestly. Across the final clean and hard APK smoke, the AI section appears while selected versions, SBOM components, and vulnerability output remain unchanged.</a:t>
+            </a:r>
+          </a:p>
+        </p:txBody>
+      </p:sp>
+      <p:sp>
+        <p:nvSpPr>
+          <p:cNvPr id="4" name="Slide Number Placeholder 3"/>
+          <p:cNvSpPr>
+            <a:spLocks xmlns:a="http://schemas.openxmlformats.org/drawingml/2006/main" noGrp="1"/>
+          </p:cNvSpPr>
+          <p:nvPr>
+            <p:ph type="sldNum" idx="5"/>
+          </p:nvPr>
+        </p:nvSpPr>
+        <p:spPr/>
+        <p:txBody>
+          <a:bodyPr xmlns:a="http://schemas.openxmlformats.org/drawingml/2006/main"/>
+          <a:lstStyle xmlns:a="http://schemas.openxmlformats.org/drawingml/2006/main"/>
+          <a:p xmlns:a="http://schemas.openxmlformats.org/drawingml/2006/main"/>
+        </p:txBody>
+      </p:sp>
+    </p:spTree>
+  </p:cSld>
+  <p:clrMapOvr>
+    <a:masterClrMapping xmlns:a="http://schemas.openxmlformats.org/drawingml/2006/main"/>
+  </p:clrMapOvr>
+</p:notes>
+</file>
+
 <file path=ppt/notesSlides/notesSlide2.xml><?xml version="1.0" encoding="utf-8"?>
 <p:notes xmlns:p="http://schemas.openxmlformats.org/presentationml/2006/main">
   <p:cSld>
@@ -1386,7 +1457,7 @@
   </p:cSld>
   <p:clrMap bg1="lt1" tx1="dk1" bg2="lt2" tx2="dk2" accent1="accent1" accent2="accent2" accent3="accent3" accent4="accent4" accent5="accent5" accent6="accent6" hlink="hlink" folHlink="folHlink"/>
   <p:sldLayoutIdLst>
-    <p:sldLayoutId xmlns:r="http://schemas.openxmlformats.org/officeDocument/2006/relationships" id="2147483649" r:id="R4d4ee5c56d9548a0"/>
+    <p:sldLayoutId xmlns:r="http://schemas.openxmlformats.org/officeDocument/2006/relationships" id="2147483649" r:id="Rccdc2dd81e924d92"/>
   </p:sldLayoutIdLst>
   <p:txStyles>
     <p:titleStyle>
@@ -1937,7 +2008,7 @@
           <p:cNvPr id="1" name="">
             <a:extLst xmlns:a="http://schemas.openxmlformats.org/drawingml/2006/main">
               <a:ext uri="{FF2B5EF4-FFF2-40B4-BE49-F238E27FC236}">
-                <a16:creationId xmlns:a16="http://schemas.microsoft.com/office/drawing/2014/main" id="{1AECBFAC-F6B6-45C1-A9D0-32201177BB7B}"/>
+                <a16:creationId xmlns:a16="http://schemas.microsoft.com/office/drawing/2014/main" id="{4274007A-2F23-4657-A4EE-039BBF3D5C50}"/>
               </a:ext>
             </a:extLst>
           </p:cNvPr>
@@ -1968,7 +2039,7 @@
           <p:cNvPr id="2" name="">
             <a:extLst xmlns:a="http://schemas.openxmlformats.org/drawingml/2006/main">
               <a:ext uri="{FF2B5EF4-FFF2-40B4-BE49-F238E27FC236}">
-                <a16:creationId xmlns:a16="http://schemas.microsoft.com/office/drawing/2014/main" id="{1E2CAACB-34D4-4912-8137-7FF15E3309E6}"/>
+                <a16:creationId xmlns:a16="http://schemas.microsoft.com/office/drawing/2014/main" id="{3B305FA4-A0BE-42CF-B673-FC00CD9CB1E8}"/>
               </a:ext>
             </a:extLst>
           </p:cNvPr>
@@ -2024,7 +2095,7 @@
           <p:cNvPr id="3" name="">
             <a:extLst xmlns:a="http://schemas.openxmlformats.org/drawingml/2006/main">
               <a:ext uri="{FF2B5EF4-FFF2-40B4-BE49-F238E27FC236}">
-                <a16:creationId xmlns:a16="http://schemas.microsoft.com/office/drawing/2014/main" id="{0EBDC102-C464-40DC-833D-316FDEB24F29}"/>
+                <a16:creationId xmlns:a16="http://schemas.microsoft.com/office/drawing/2014/main" id="{3E717B87-81E3-48A6-B58C-25AEC0ED8413}"/>
               </a:ext>
             </a:extLst>
           </p:cNvPr>
@@ -2080,7 +2151,7 @@
           <p:cNvPr id="4" name="">
             <a:extLst xmlns:a="http://schemas.openxmlformats.org/drawingml/2006/main">
               <a:ext uri="{FF2B5EF4-FFF2-40B4-BE49-F238E27FC236}">
-                <a16:creationId xmlns:a16="http://schemas.microsoft.com/office/drawing/2014/main" id="{753238B7-3651-450D-8850-266EC8666D95}"/>
+                <a16:creationId xmlns:a16="http://schemas.microsoft.com/office/drawing/2014/main" id="{94545419-7D26-4267-8B58-71A1A29F532C}"/>
               </a:ext>
             </a:extLst>
           </p:cNvPr>
@@ -2136,7 +2207,7 @@
           <p:cNvPr id="5" name="">
             <a:extLst xmlns:a="http://schemas.openxmlformats.org/drawingml/2006/main">
               <a:ext uri="{FF2B5EF4-FFF2-40B4-BE49-F238E27FC236}">
-                <a16:creationId xmlns:a16="http://schemas.microsoft.com/office/drawing/2014/main" id="{6669A831-5E9D-4AB8-8A28-2FB0220E5141}"/>
+                <a16:creationId xmlns:a16="http://schemas.microsoft.com/office/drawing/2014/main" id="{E24A0AC7-C557-41C5-AB79-472B9B820832}"/>
               </a:ext>
             </a:extLst>
           </p:cNvPr>
@@ -2169,7 +2240,7 @@
           <p:cNvPr id="6" name="">
             <a:extLst xmlns:a="http://schemas.openxmlformats.org/drawingml/2006/main">
               <a:ext uri="{FF2B5EF4-FFF2-40B4-BE49-F238E27FC236}">
-                <a16:creationId xmlns:a16="http://schemas.microsoft.com/office/drawing/2014/main" id="{17806DFE-56A5-46D5-BAC5-045802D9C09D}"/>
+                <a16:creationId xmlns:a16="http://schemas.microsoft.com/office/drawing/2014/main" id="{FA94DA14-A474-4B55-BE8E-00B369EDF09F}"/>
               </a:ext>
             </a:extLst>
           </p:cNvPr>
@@ -2225,7 +2296,7 @@
           <p:cNvPr id="7" name="">
             <a:extLst xmlns:a="http://schemas.openxmlformats.org/drawingml/2006/main">
               <a:ext uri="{FF2B5EF4-FFF2-40B4-BE49-F238E27FC236}">
-                <a16:creationId xmlns:a16="http://schemas.microsoft.com/office/drawing/2014/main" id="{D7E28DE0-C725-493F-BE1D-7BC3105D5DA1}"/>
+                <a16:creationId xmlns:a16="http://schemas.microsoft.com/office/drawing/2014/main" id="{20EE8376-DEBA-423C-B842-F68FFB9D6A93}"/>
               </a:ext>
             </a:extLst>
           </p:cNvPr>
@@ -2281,7 +2352,7 @@
           <p:cNvPr id="8" name="">
             <a:extLst xmlns:a="http://schemas.openxmlformats.org/drawingml/2006/main">
               <a:ext uri="{FF2B5EF4-FFF2-40B4-BE49-F238E27FC236}">
-                <a16:creationId xmlns:a16="http://schemas.microsoft.com/office/drawing/2014/main" id="{20311024-26ED-421F-B51C-2A8ACDE551D5}"/>
+                <a16:creationId xmlns:a16="http://schemas.microsoft.com/office/drawing/2014/main" id="{D9ABDAD4-C40E-47B5-98B5-108F25DBF273}"/>
               </a:ext>
             </a:extLst>
           </p:cNvPr>
@@ -2314,7 +2385,7 @@
           <p:cNvPr id="9" name="">
             <a:extLst xmlns:a="http://schemas.openxmlformats.org/drawingml/2006/main">
               <a:ext uri="{FF2B5EF4-FFF2-40B4-BE49-F238E27FC236}">
-                <a16:creationId xmlns:a16="http://schemas.microsoft.com/office/drawing/2014/main" id="{CA9D5F40-BB92-40C7-8C41-AB81CD02921D}"/>
+                <a16:creationId xmlns:a16="http://schemas.microsoft.com/office/drawing/2014/main" id="{F68698EF-769E-4224-A593-6DEA6AE108A4}"/>
               </a:ext>
             </a:extLst>
           </p:cNvPr>
@@ -2370,7 +2441,7 @@
           <p:cNvPr id="10" name="">
             <a:extLst xmlns:a="http://schemas.openxmlformats.org/drawingml/2006/main">
               <a:ext uri="{FF2B5EF4-FFF2-40B4-BE49-F238E27FC236}">
-                <a16:creationId xmlns:a16="http://schemas.microsoft.com/office/drawing/2014/main" id="{1AC1FF04-0FCD-4FF2-93EE-0609FE26700A}"/>
+                <a16:creationId xmlns:a16="http://schemas.microsoft.com/office/drawing/2014/main" id="{68A97E1A-1883-4ADA-B54B-C625F4F4E3B6}"/>
               </a:ext>
             </a:extLst>
           </p:cNvPr>
@@ -2426,7 +2497,7 @@
           <p:cNvPr id="11" name="">
             <a:extLst xmlns:a="http://schemas.openxmlformats.org/drawingml/2006/main">
               <a:ext uri="{FF2B5EF4-FFF2-40B4-BE49-F238E27FC236}">
-                <a16:creationId xmlns:a16="http://schemas.microsoft.com/office/drawing/2014/main" id="{1699F112-BD6A-4CA8-BA6B-DDFA3ADBFCB3}"/>
+                <a16:creationId xmlns:a16="http://schemas.microsoft.com/office/drawing/2014/main" id="{8D61C4F6-541D-4A29-88B6-2EFD4DB8E193}"/>
               </a:ext>
             </a:extLst>
           </p:cNvPr>
@@ -2459,7 +2530,7 @@
           <p:cNvPr id="12" name="">
             <a:extLst xmlns:a="http://schemas.openxmlformats.org/drawingml/2006/main">
               <a:ext uri="{FF2B5EF4-FFF2-40B4-BE49-F238E27FC236}">
-                <a16:creationId xmlns:a16="http://schemas.microsoft.com/office/drawing/2014/main" id="{94750BB3-3E5C-4937-A71F-B05C6BA17002}"/>
+                <a16:creationId xmlns:a16="http://schemas.microsoft.com/office/drawing/2014/main" id="{63B13159-7442-4FC3-842C-3320F861AA52}"/>
               </a:ext>
             </a:extLst>
           </p:cNvPr>
@@ -2515,7 +2586,7 @@
           <p:cNvPr id="13" name="">
             <a:extLst xmlns:a="http://schemas.openxmlformats.org/drawingml/2006/main">
               <a:ext uri="{FF2B5EF4-FFF2-40B4-BE49-F238E27FC236}">
-                <a16:creationId xmlns:a16="http://schemas.microsoft.com/office/drawing/2014/main" id="{2AFB28D4-1F7A-4CCE-9957-45334CFF89F3}"/>
+                <a16:creationId xmlns:a16="http://schemas.microsoft.com/office/drawing/2014/main" id="{5A715D0A-A9DC-4ED7-8CE3-CF292B820792}"/>
               </a:ext>
             </a:extLst>
           </p:cNvPr>
@@ -2571,7 +2642,7 @@
           <p:cNvPr id="14" name="">
             <a:extLst xmlns:a="http://schemas.openxmlformats.org/drawingml/2006/main">
               <a:ext uri="{FF2B5EF4-FFF2-40B4-BE49-F238E27FC236}">
-                <a16:creationId xmlns:a16="http://schemas.microsoft.com/office/drawing/2014/main" id="{EFE0B234-D547-4295-8183-F659D46290C0}"/>
+                <a16:creationId xmlns:a16="http://schemas.microsoft.com/office/drawing/2014/main" id="{AE63CBB3-7678-43D2-B685-C59537F659AE}"/>
               </a:ext>
             </a:extLst>
           </p:cNvPr>
@@ -2604,7 +2675,7 @@
           <p:cNvPr id="15" name="">
             <a:extLst xmlns:a="http://schemas.openxmlformats.org/drawingml/2006/main">
               <a:ext uri="{FF2B5EF4-FFF2-40B4-BE49-F238E27FC236}">
-                <a16:creationId xmlns:a16="http://schemas.microsoft.com/office/drawing/2014/main" id="{7AB376E4-4CA8-4932-9EF6-B011CC3E1E78}"/>
+                <a16:creationId xmlns:a16="http://schemas.microsoft.com/office/drawing/2014/main" id="{059D0121-5292-4EAE-ADC6-D6C408C6F785}"/>
               </a:ext>
             </a:extLst>
           </p:cNvPr>
@@ -2660,7 +2731,7 @@
           <p:cNvPr id="16" name="">
             <a:extLst xmlns:a="http://schemas.openxmlformats.org/drawingml/2006/main">
               <a:ext uri="{FF2B5EF4-FFF2-40B4-BE49-F238E27FC236}">
-                <a16:creationId xmlns:a16="http://schemas.microsoft.com/office/drawing/2014/main" id="{8729274A-6EBE-4654-83F9-FA9CF5703A28}"/>
+                <a16:creationId xmlns:a16="http://schemas.microsoft.com/office/drawing/2014/main" id="{9D30F84A-E3BD-49B7-BA7D-CE5FFF369FE5}"/>
               </a:ext>
             </a:extLst>
           </p:cNvPr>
@@ -2716,7 +2787,7 @@
           <p:cNvPr id="17" name="">
             <a:extLst xmlns:a="http://schemas.openxmlformats.org/drawingml/2006/main">
               <a:ext uri="{FF2B5EF4-FFF2-40B4-BE49-F238E27FC236}">
-                <a16:creationId xmlns:a16="http://schemas.microsoft.com/office/drawing/2014/main" id="{8E1C0C16-B0C4-477F-A149-92DD693AD950}"/>
+                <a16:creationId xmlns:a16="http://schemas.microsoft.com/office/drawing/2014/main" id="{35A5BCBA-6915-4411-99DA-AAA905F57C48}"/>
               </a:ext>
             </a:extLst>
           </p:cNvPr>
@@ -2749,7 +2820,7 @@
           <p:cNvPr id="18" name="">
             <a:extLst xmlns:a="http://schemas.openxmlformats.org/drawingml/2006/main">
               <a:ext uri="{FF2B5EF4-FFF2-40B4-BE49-F238E27FC236}">
-                <a16:creationId xmlns:a16="http://schemas.microsoft.com/office/drawing/2014/main" id="{34297DC9-1765-49FF-A34B-B9E32EA6E2A9}"/>
+                <a16:creationId xmlns:a16="http://schemas.microsoft.com/office/drawing/2014/main" id="{15D86031-C21D-41AC-B2B4-12AF99AC5B75}"/>
               </a:ext>
             </a:extLst>
           </p:cNvPr>
@@ -2805,7 +2876,7 @@
           <p:cNvPr id="19" name="">
             <a:extLst xmlns:a="http://schemas.openxmlformats.org/drawingml/2006/main">
               <a:ext uri="{FF2B5EF4-FFF2-40B4-BE49-F238E27FC236}">
-                <a16:creationId xmlns:a16="http://schemas.microsoft.com/office/drawing/2014/main" id="{A77F6846-2527-433B-A5E9-9D143BE80446}"/>
+                <a16:creationId xmlns:a16="http://schemas.microsoft.com/office/drawing/2014/main" id="{BFDC8024-E237-466B-AFC6-DB6F8CB370E0}"/>
               </a:ext>
             </a:extLst>
           </p:cNvPr>
@@ -2838,7 +2909,7 @@
           <p:cNvPr id="20" name="">
             <a:extLst xmlns:a="http://schemas.openxmlformats.org/drawingml/2006/main">
               <a:ext uri="{FF2B5EF4-FFF2-40B4-BE49-F238E27FC236}">
-                <a16:creationId xmlns:a16="http://schemas.microsoft.com/office/drawing/2014/main" id="{E1CFD2A5-448C-4107-8E44-50FF15F71C99}"/>
+                <a16:creationId xmlns:a16="http://schemas.microsoft.com/office/drawing/2014/main" id="{959F070D-61BA-4238-9574-6322391C41DE}"/>
               </a:ext>
             </a:extLst>
           </p:cNvPr>
@@ -2894,7 +2965,7 @@
           <p:cNvPr id="21" name="">
             <a:extLst xmlns:a="http://schemas.openxmlformats.org/drawingml/2006/main">
               <a:ext uri="{FF2B5EF4-FFF2-40B4-BE49-F238E27FC236}">
-                <a16:creationId xmlns:a16="http://schemas.microsoft.com/office/drawing/2014/main" id="{22D9C622-A72F-4CEC-BEDA-C219E2D17CB5}"/>
+                <a16:creationId xmlns:a16="http://schemas.microsoft.com/office/drawing/2014/main" id="{983AECD3-1524-4BD3-A008-9D1FA45BDA37}"/>
               </a:ext>
             </a:extLst>
           </p:cNvPr>
@@ -2950,7 +3021,7 @@
           <p:cNvPr id="22" name="">
             <a:extLst xmlns:a="http://schemas.openxmlformats.org/drawingml/2006/main">
               <a:ext uri="{FF2B5EF4-FFF2-40B4-BE49-F238E27FC236}">
-                <a16:creationId xmlns:a16="http://schemas.microsoft.com/office/drawing/2014/main" id="{356154E9-0FB4-4667-94BD-38D11DFB1180}"/>
+                <a16:creationId xmlns:a16="http://schemas.microsoft.com/office/drawing/2014/main" id="{DBCD06E8-3407-45EF-B525-F406141C22BF}"/>
               </a:ext>
             </a:extLst>
           </p:cNvPr>
@@ -2983,7 +3054,7 @@
           <p:cNvPr id="23" name="">
             <a:extLst xmlns:a="http://schemas.openxmlformats.org/drawingml/2006/main">
               <a:ext uri="{FF2B5EF4-FFF2-40B4-BE49-F238E27FC236}">
-                <a16:creationId xmlns:a16="http://schemas.microsoft.com/office/drawing/2014/main" id="{BE144F45-2B5B-4467-9A17-C7633CB70BC4}"/>
+                <a16:creationId xmlns:a16="http://schemas.microsoft.com/office/drawing/2014/main" id="{399824A7-4BEE-4314-A0E0-DDB81FDFFE54}"/>
               </a:ext>
             </a:extLst>
           </p:cNvPr>
@@ -3039,7 +3110,7 @@
           <p:cNvPr id="24" name="">
             <a:extLst xmlns:a="http://schemas.openxmlformats.org/drawingml/2006/main">
               <a:ext uri="{FF2B5EF4-FFF2-40B4-BE49-F238E27FC236}">
-                <a16:creationId xmlns:a16="http://schemas.microsoft.com/office/drawing/2014/main" id="{99CC1868-716C-4A92-BB9C-52DF88601242}"/>
+                <a16:creationId xmlns:a16="http://schemas.microsoft.com/office/drawing/2014/main" id="{2FF6F580-466D-4DE0-997C-87BF6F3779B3}"/>
               </a:ext>
             </a:extLst>
           </p:cNvPr>
@@ -3095,7 +3166,7 @@
           <p:cNvPr id="25" name="">
             <a:extLst xmlns:a="http://schemas.openxmlformats.org/drawingml/2006/main">
               <a:ext uri="{FF2B5EF4-FFF2-40B4-BE49-F238E27FC236}">
-                <a16:creationId xmlns:a16="http://schemas.microsoft.com/office/drawing/2014/main" id="{4C4D150B-4FA4-4F72-8339-FD1F4E28AA30}"/>
+                <a16:creationId xmlns:a16="http://schemas.microsoft.com/office/drawing/2014/main" id="{47BD9EE2-A456-47F3-8908-6CD0A84E9E9C}"/>
               </a:ext>
             </a:extLst>
           </p:cNvPr>
@@ -3128,7 +3199,7 @@
           <p:cNvPr id="26" name="">
             <a:extLst xmlns:a="http://schemas.openxmlformats.org/drawingml/2006/main">
               <a:ext uri="{FF2B5EF4-FFF2-40B4-BE49-F238E27FC236}">
-                <a16:creationId xmlns:a16="http://schemas.microsoft.com/office/drawing/2014/main" id="{5083B967-DD82-4E67-8D37-1D2ACF0530AF}"/>
+                <a16:creationId xmlns:a16="http://schemas.microsoft.com/office/drawing/2014/main" id="{6C9A0FD7-EE83-41D1-9290-E216DE555A3D}"/>
               </a:ext>
             </a:extLst>
           </p:cNvPr>
@@ -3184,7 +3255,7 @@
           <p:cNvPr id="27" name="">
             <a:extLst xmlns:a="http://schemas.openxmlformats.org/drawingml/2006/main">
               <a:ext uri="{FF2B5EF4-FFF2-40B4-BE49-F238E27FC236}">
-                <a16:creationId xmlns:a16="http://schemas.microsoft.com/office/drawing/2014/main" id="{3FF084B6-D463-467F-974C-D2800CA92DD5}"/>
+                <a16:creationId xmlns:a16="http://schemas.microsoft.com/office/drawing/2014/main" id="{D9CA91A5-464C-4374-BE10-5255878BFA25}"/>
               </a:ext>
             </a:extLst>
           </p:cNvPr>
@@ -3240,7 +3311,7 @@
           <p:cNvPr id="28" name="">
             <a:extLst xmlns:a="http://schemas.openxmlformats.org/drawingml/2006/main">
               <a:ext uri="{FF2B5EF4-FFF2-40B4-BE49-F238E27FC236}">
-                <a16:creationId xmlns:a16="http://schemas.microsoft.com/office/drawing/2014/main" id="{AD5E405E-D185-455F-82DA-7798BF25CD58}"/>
+                <a16:creationId xmlns:a16="http://schemas.microsoft.com/office/drawing/2014/main" id="{916A57AE-9514-4EF7-8AD3-2AC97F5783A0}"/>
               </a:ext>
             </a:extLst>
           </p:cNvPr>
@@ -3296,7 +3367,7 @@
           <p:cNvPr id="29" name="">
             <a:extLst xmlns:a="http://schemas.openxmlformats.org/drawingml/2006/main">
               <a:ext uri="{FF2B5EF4-FFF2-40B4-BE49-F238E27FC236}">
-                <a16:creationId xmlns:a16="http://schemas.microsoft.com/office/drawing/2014/main" id="{6B45BDCF-7E83-417A-BF8C-76650C83723F}"/>
+                <a16:creationId xmlns:a16="http://schemas.microsoft.com/office/drawing/2014/main" id="{EF13E4FF-C85D-437D-8227-63D9143D4E44}"/>
               </a:ext>
             </a:extLst>
           </p:cNvPr>
@@ -3350,7 +3421,7 @@
     </p:spTree>
     <p:extLst>
       <p:ext uri="{BB962C8B-B14F-4D97-AF65-F5344CB8AC3E}">
-        <p14:creationId xmlns:p14="http://schemas.microsoft.com/office/powerpoint/2010/main" val="2128946018"/>
+        <p14:creationId xmlns:p14="http://schemas.microsoft.com/office/powerpoint/2010/main" val="480517291"/>
       </p:ext>
     </p:extLst>
   </p:cSld>
@@ -3381,7 +3452,7 @@
           <p:cNvPr id="1" name="">
             <a:extLst xmlns:a="http://schemas.openxmlformats.org/drawingml/2006/main">
               <a:ext uri="{FF2B5EF4-FFF2-40B4-BE49-F238E27FC236}">
-                <a16:creationId xmlns:a16="http://schemas.microsoft.com/office/drawing/2014/main" id="{98FACB8F-C233-4021-A4AE-F02CD8B7E340}"/>
+                <a16:creationId xmlns:a16="http://schemas.microsoft.com/office/drawing/2014/main" id="{9936925C-E851-4AB8-8378-82D821B5B11F}"/>
               </a:ext>
             </a:extLst>
           </p:cNvPr>
@@ -3437,7 +3508,7 @@
           <p:cNvPr id="2" name="">
             <a:extLst xmlns:a="http://schemas.openxmlformats.org/drawingml/2006/main">
               <a:ext uri="{FF2B5EF4-FFF2-40B4-BE49-F238E27FC236}">
-                <a16:creationId xmlns:a16="http://schemas.microsoft.com/office/drawing/2014/main" id="{FF531877-AE70-4970-8532-1D79CAEAADB1}"/>
+                <a16:creationId xmlns:a16="http://schemas.microsoft.com/office/drawing/2014/main" id="{163DBCE9-4322-4212-B1E6-072466DBA39D}"/>
               </a:ext>
             </a:extLst>
           </p:cNvPr>
@@ -3493,7 +3564,7 @@
           <p:cNvPr id="3" name="">
             <a:extLst xmlns:a="http://schemas.openxmlformats.org/drawingml/2006/main">
               <a:ext uri="{FF2B5EF4-FFF2-40B4-BE49-F238E27FC236}">
-                <a16:creationId xmlns:a16="http://schemas.microsoft.com/office/drawing/2014/main" id="{FC3FE914-3279-4062-A06E-7785F8D4E17A}"/>
+                <a16:creationId xmlns:a16="http://schemas.microsoft.com/office/drawing/2014/main" id="{270846C4-BC70-46BE-A2BB-D31B5094FD3A}"/>
               </a:ext>
             </a:extLst>
           </p:cNvPr>
@@ -3549,7 +3620,7 @@
           <p:cNvPr id="4" name="rule">
             <a:extLst xmlns:a="http://schemas.openxmlformats.org/drawingml/2006/main">
               <a:ext uri="{FF2B5EF4-FFF2-40B4-BE49-F238E27FC236}">
-                <a16:creationId xmlns:a16="http://schemas.microsoft.com/office/drawing/2014/main" id="{D2E416ED-E597-4EB8-A4EA-60E1ECB9109D}"/>
+                <a16:creationId xmlns:a16="http://schemas.microsoft.com/office/drawing/2014/main" id="{911A8B2A-4D57-4079-A5B8-524CC445D0E9}"/>
               </a:ext>
             </a:extLst>
           </p:cNvPr>
@@ -3580,7 +3651,7 @@
           <p:cNvPr id="5" name="">
             <a:extLst xmlns:a="http://schemas.openxmlformats.org/drawingml/2006/main">
               <a:ext uri="{FF2B5EF4-FFF2-40B4-BE49-F238E27FC236}">
-                <a16:creationId xmlns:a16="http://schemas.microsoft.com/office/drawing/2014/main" id="{964AA60B-67A4-475F-8B1E-8D98FF2E6D11}"/>
+                <a16:creationId xmlns:a16="http://schemas.microsoft.com/office/drawing/2014/main" id="{28ADBF55-EC39-4E2A-9660-30B449CA2DE5}"/>
               </a:ext>
             </a:extLst>
           </p:cNvPr>
@@ -3613,7 +3684,7 @@
           <p:cNvPr id="6" name="">
             <a:extLst xmlns:a="http://schemas.openxmlformats.org/drawingml/2006/main">
               <a:ext uri="{FF2B5EF4-FFF2-40B4-BE49-F238E27FC236}">
-                <a16:creationId xmlns:a16="http://schemas.microsoft.com/office/drawing/2014/main" id="{C194EFF6-6B02-4B31-959A-83CCC61773E1}"/>
+                <a16:creationId xmlns:a16="http://schemas.microsoft.com/office/drawing/2014/main" id="{0A814548-8AAD-40A1-B002-B18F81ED0E3C}"/>
               </a:ext>
             </a:extLst>
           </p:cNvPr>
@@ -3669,7 +3740,7 @@
           <p:cNvPr id="7" name="">
             <a:extLst xmlns:a="http://schemas.openxmlformats.org/drawingml/2006/main">
               <a:ext uri="{FF2B5EF4-FFF2-40B4-BE49-F238E27FC236}">
-                <a16:creationId xmlns:a16="http://schemas.microsoft.com/office/drawing/2014/main" id="{4AF27211-EF09-4970-BD89-4BB47BEEFA5B}"/>
+                <a16:creationId xmlns:a16="http://schemas.microsoft.com/office/drawing/2014/main" id="{A1841115-E7E4-41D1-84AC-0014BAAF2941}"/>
               </a:ext>
             </a:extLst>
           </p:cNvPr>
@@ -3702,7 +3773,7 @@
           <p:cNvPr id="8" name="">
             <a:extLst xmlns:a="http://schemas.openxmlformats.org/drawingml/2006/main">
               <a:ext uri="{FF2B5EF4-FFF2-40B4-BE49-F238E27FC236}">
-                <a16:creationId xmlns:a16="http://schemas.microsoft.com/office/drawing/2014/main" id="{373A84CE-8EB1-4C49-B503-01AF6BDD0C12}"/>
+                <a16:creationId xmlns:a16="http://schemas.microsoft.com/office/drawing/2014/main" id="{D46048F8-6637-4B92-BD0C-406742423846}"/>
               </a:ext>
             </a:extLst>
           </p:cNvPr>
@@ -3758,7 +3829,7 @@
           <p:cNvPr id="9" name="">
             <a:extLst xmlns:a="http://schemas.openxmlformats.org/drawingml/2006/main">
               <a:ext uri="{FF2B5EF4-FFF2-40B4-BE49-F238E27FC236}">
-                <a16:creationId xmlns:a16="http://schemas.microsoft.com/office/drawing/2014/main" id="{6C50FB3D-5681-46D1-A0E1-115E16F2955B}"/>
+                <a16:creationId xmlns:a16="http://schemas.microsoft.com/office/drawing/2014/main" id="{DC773489-5A8A-463A-BC0D-FC176D1D6E37}"/>
               </a:ext>
             </a:extLst>
           </p:cNvPr>
@@ -3791,7 +3862,7 @@
           <p:cNvPr id="10" name="">
             <a:extLst xmlns:a="http://schemas.openxmlformats.org/drawingml/2006/main">
               <a:ext uri="{FF2B5EF4-FFF2-40B4-BE49-F238E27FC236}">
-                <a16:creationId xmlns:a16="http://schemas.microsoft.com/office/drawing/2014/main" id="{7B88CEEE-6A6F-4F9E-9890-60B748489E0A}"/>
+                <a16:creationId xmlns:a16="http://schemas.microsoft.com/office/drawing/2014/main" id="{0FA43859-30C2-4632-81B3-3DE40CD6B065}"/>
               </a:ext>
             </a:extLst>
           </p:cNvPr>
@@ -3847,7 +3918,7 @@
           <p:cNvPr id="11" name="">
             <a:extLst xmlns:a="http://schemas.openxmlformats.org/drawingml/2006/main">
               <a:ext uri="{FF2B5EF4-FFF2-40B4-BE49-F238E27FC236}">
-                <a16:creationId xmlns:a16="http://schemas.microsoft.com/office/drawing/2014/main" id="{48EE1EC8-9CAD-408E-B5AD-2B273885C0E8}"/>
+                <a16:creationId xmlns:a16="http://schemas.microsoft.com/office/drawing/2014/main" id="{82B53AE2-D1E9-4EA8-A1EC-29954C20CCA4}"/>
               </a:ext>
             </a:extLst>
           </p:cNvPr>
@@ -3880,7 +3951,7 @@
           <p:cNvPr id="12" name="">
             <a:extLst xmlns:a="http://schemas.openxmlformats.org/drawingml/2006/main">
               <a:ext uri="{FF2B5EF4-FFF2-40B4-BE49-F238E27FC236}">
-                <a16:creationId xmlns:a16="http://schemas.microsoft.com/office/drawing/2014/main" id="{8BE8C8B6-699B-494B-A1C4-7CA3D1F565C0}"/>
+                <a16:creationId xmlns:a16="http://schemas.microsoft.com/office/drawing/2014/main" id="{E355A32D-548C-43C0-B163-0154110C3931}"/>
               </a:ext>
             </a:extLst>
           </p:cNvPr>
@@ -3936,7 +4007,7 @@
           <p:cNvPr id="13" name="">
             <a:extLst xmlns:a="http://schemas.openxmlformats.org/drawingml/2006/main">
               <a:ext uri="{FF2B5EF4-FFF2-40B4-BE49-F238E27FC236}">
-                <a16:creationId xmlns:a16="http://schemas.microsoft.com/office/drawing/2014/main" id="{4D2ABF3A-4FAB-49CF-94E0-DA036B8EB780}"/>
+                <a16:creationId xmlns:a16="http://schemas.microsoft.com/office/drawing/2014/main" id="{E6D7A929-95EB-4FE5-867C-8CA47BC91E07}"/>
               </a:ext>
             </a:extLst>
           </p:cNvPr>
@@ -3969,7 +4040,7 @@
           <p:cNvPr id="14" name="">
             <a:extLst xmlns:a="http://schemas.openxmlformats.org/drawingml/2006/main">
               <a:ext uri="{FF2B5EF4-FFF2-40B4-BE49-F238E27FC236}">
-                <a16:creationId xmlns:a16="http://schemas.microsoft.com/office/drawing/2014/main" id="{ED204716-7512-46B5-9322-0356E0AC6041}"/>
+                <a16:creationId xmlns:a16="http://schemas.microsoft.com/office/drawing/2014/main" id="{536EC76F-E3FD-47E5-816C-5DB1AE2FEAF7}"/>
               </a:ext>
             </a:extLst>
           </p:cNvPr>
@@ -4025,7 +4096,7 @@
           <p:cNvPr id="15" name="">
             <a:extLst xmlns:a="http://schemas.openxmlformats.org/drawingml/2006/main">
               <a:ext uri="{FF2B5EF4-FFF2-40B4-BE49-F238E27FC236}">
-                <a16:creationId xmlns:a16="http://schemas.microsoft.com/office/drawing/2014/main" id="{92EDE4BB-61F8-4416-B4A1-BE8C6FDE88C1}"/>
+                <a16:creationId xmlns:a16="http://schemas.microsoft.com/office/drawing/2014/main" id="{ADE7E2C0-54C8-4E7D-8010-3E785A85DC0C}"/>
               </a:ext>
             </a:extLst>
           </p:cNvPr>
@@ -4058,7 +4129,7 @@
           <p:cNvPr id="16" name="">
             <a:extLst xmlns:a="http://schemas.openxmlformats.org/drawingml/2006/main">
               <a:ext uri="{FF2B5EF4-FFF2-40B4-BE49-F238E27FC236}">
-                <a16:creationId xmlns:a16="http://schemas.microsoft.com/office/drawing/2014/main" id="{49D33209-5306-48D9-97A0-B1271D0DFEFE}"/>
+                <a16:creationId xmlns:a16="http://schemas.microsoft.com/office/drawing/2014/main" id="{15D73DF0-9BC3-4530-A04A-AAE7046F5B68}"/>
               </a:ext>
             </a:extLst>
           </p:cNvPr>
@@ -4114,7 +4185,7 @@
           <p:cNvPr id="17" name="">
             <a:extLst xmlns:a="http://schemas.openxmlformats.org/drawingml/2006/main">
               <a:ext uri="{FF2B5EF4-FFF2-40B4-BE49-F238E27FC236}">
-                <a16:creationId xmlns:a16="http://schemas.microsoft.com/office/drawing/2014/main" id="{5017185A-3B6E-4BF6-B71B-3A907DC338BA}"/>
+                <a16:creationId xmlns:a16="http://schemas.microsoft.com/office/drawing/2014/main" id="{F150782C-7CB7-45EF-9358-5C9C9D6A3C5E}"/>
               </a:ext>
             </a:extLst>
           </p:cNvPr>
@@ -4147,7 +4218,7 @@
           <p:cNvPr id="18" name="">
             <a:extLst xmlns:a="http://schemas.openxmlformats.org/drawingml/2006/main">
               <a:ext uri="{FF2B5EF4-FFF2-40B4-BE49-F238E27FC236}">
-                <a16:creationId xmlns:a16="http://schemas.microsoft.com/office/drawing/2014/main" id="{EFBDE6CD-94A3-4D19-A633-C5605C2C19B2}"/>
+                <a16:creationId xmlns:a16="http://schemas.microsoft.com/office/drawing/2014/main" id="{B600A8F8-3CCE-4A14-920D-96E2F7972D47}"/>
               </a:ext>
             </a:extLst>
           </p:cNvPr>
@@ -4203,7 +4274,7 @@
           <p:cNvPr id="19" name="">
             <a:extLst xmlns:a="http://schemas.openxmlformats.org/drawingml/2006/main">
               <a:ext uri="{FF2B5EF4-FFF2-40B4-BE49-F238E27FC236}">
-                <a16:creationId xmlns:a16="http://schemas.microsoft.com/office/drawing/2014/main" id="{F9390F1D-3B4F-49A8-BEF0-563A05B109AB}"/>
+                <a16:creationId xmlns:a16="http://schemas.microsoft.com/office/drawing/2014/main" id="{1409F058-80C4-4602-AF18-BA38966184A2}"/>
               </a:ext>
             </a:extLst>
           </p:cNvPr>
@@ -4236,7 +4307,7 @@
           <p:cNvPr id="20" name="">
             <a:extLst xmlns:a="http://schemas.openxmlformats.org/drawingml/2006/main">
               <a:ext uri="{FF2B5EF4-FFF2-40B4-BE49-F238E27FC236}">
-                <a16:creationId xmlns:a16="http://schemas.microsoft.com/office/drawing/2014/main" id="{FB3C7E99-A70A-48BB-A23D-BEC080625405}"/>
+                <a16:creationId xmlns:a16="http://schemas.microsoft.com/office/drawing/2014/main" id="{BEFF8C52-250F-4EE0-A011-C088787B23BA}"/>
               </a:ext>
             </a:extLst>
           </p:cNvPr>
@@ -4292,7 +4363,7 @@
           <p:cNvPr id="21" name="">
             <a:extLst xmlns:a="http://schemas.openxmlformats.org/drawingml/2006/main">
               <a:ext uri="{FF2B5EF4-FFF2-40B4-BE49-F238E27FC236}">
-                <a16:creationId xmlns:a16="http://schemas.microsoft.com/office/drawing/2014/main" id="{9E10CE77-EB0D-4021-9FD3-6F0473C17463}"/>
+                <a16:creationId xmlns:a16="http://schemas.microsoft.com/office/drawing/2014/main" id="{B491417A-03D3-4E8B-997D-B5F86A967117}"/>
               </a:ext>
             </a:extLst>
           </p:cNvPr>
@@ -4325,7 +4396,7 @@
           <p:cNvPr id="22" name="">
             <a:extLst xmlns:a="http://schemas.openxmlformats.org/drawingml/2006/main">
               <a:ext uri="{FF2B5EF4-FFF2-40B4-BE49-F238E27FC236}">
-                <a16:creationId xmlns:a16="http://schemas.microsoft.com/office/drawing/2014/main" id="{F24EEEA3-03F4-4D10-A9DE-A521ADDB8CD0}"/>
+                <a16:creationId xmlns:a16="http://schemas.microsoft.com/office/drawing/2014/main" id="{095CE431-A337-4761-BADB-49C7BB629D9A}"/>
               </a:ext>
             </a:extLst>
           </p:cNvPr>
@@ -4381,7 +4452,7 @@
           <p:cNvPr id="23" name="">
             <a:extLst xmlns:a="http://schemas.openxmlformats.org/drawingml/2006/main">
               <a:ext uri="{FF2B5EF4-FFF2-40B4-BE49-F238E27FC236}">
-                <a16:creationId xmlns:a16="http://schemas.microsoft.com/office/drawing/2014/main" id="{5EE3A81F-ADA0-4498-BB8D-41E3AD004344}"/>
+                <a16:creationId xmlns:a16="http://schemas.microsoft.com/office/drawing/2014/main" id="{25C53912-151B-4750-9032-7D228D801635}"/>
               </a:ext>
             </a:extLst>
           </p:cNvPr>
@@ -4414,7 +4485,7 @@
           <p:cNvPr id="24" name="">
             <a:extLst xmlns:a="http://schemas.openxmlformats.org/drawingml/2006/main">
               <a:ext uri="{FF2B5EF4-FFF2-40B4-BE49-F238E27FC236}">
-                <a16:creationId xmlns:a16="http://schemas.microsoft.com/office/drawing/2014/main" id="{9DA0D945-E4E1-472F-8DF4-EDEAE4B223DC}"/>
+                <a16:creationId xmlns:a16="http://schemas.microsoft.com/office/drawing/2014/main" id="{33B3C5FB-70C6-4D1D-A3E6-CE93F4C2E808}"/>
               </a:ext>
             </a:extLst>
           </p:cNvPr>
@@ -4470,7 +4541,7 @@
           <p:cNvPr id="25" name="">
             <a:extLst xmlns:a="http://schemas.openxmlformats.org/drawingml/2006/main">
               <a:ext uri="{FF2B5EF4-FFF2-40B4-BE49-F238E27FC236}">
-                <a16:creationId xmlns:a16="http://schemas.microsoft.com/office/drawing/2014/main" id="{DF6EBCAB-599C-468E-AD1B-0EFDB8C5FF77}"/>
+                <a16:creationId xmlns:a16="http://schemas.microsoft.com/office/drawing/2014/main" id="{3DAEDC10-1E85-45D2-9925-2C86AC3FCC1C}"/>
               </a:ext>
             </a:extLst>
           </p:cNvPr>
@@ -4503,7 +4574,7 @@
           <p:cNvPr id="26" name="">
             <a:extLst xmlns:a="http://schemas.openxmlformats.org/drawingml/2006/main">
               <a:ext uri="{FF2B5EF4-FFF2-40B4-BE49-F238E27FC236}">
-                <a16:creationId xmlns:a16="http://schemas.microsoft.com/office/drawing/2014/main" id="{272AD6E0-A1D8-4210-A2D9-34F7F8EFE209}"/>
+                <a16:creationId xmlns:a16="http://schemas.microsoft.com/office/drawing/2014/main" id="{FDF5B9F9-568F-4F09-A75D-CBAF1A364B66}"/>
               </a:ext>
             </a:extLst>
           </p:cNvPr>
@@ -4559,7 +4630,7 @@
           <p:cNvPr id="27" name="">
             <a:extLst xmlns:a="http://schemas.openxmlformats.org/drawingml/2006/main">
               <a:ext uri="{FF2B5EF4-FFF2-40B4-BE49-F238E27FC236}">
-                <a16:creationId xmlns:a16="http://schemas.microsoft.com/office/drawing/2014/main" id="{6EED4405-2825-4ACB-97BE-42E4B34A97D3}"/>
+                <a16:creationId xmlns:a16="http://schemas.microsoft.com/office/drawing/2014/main" id="{C9B5E79A-85BF-46A6-99AF-426CE3270279}"/>
               </a:ext>
             </a:extLst>
           </p:cNvPr>
@@ -4592,7 +4663,7 @@
           <p:cNvPr id="28" name="">
             <a:extLst xmlns:a="http://schemas.openxmlformats.org/drawingml/2006/main">
               <a:ext uri="{FF2B5EF4-FFF2-40B4-BE49-F238E27FC236}">
-                <a16:creationId xmlns:a16="http://schemas.microsoft.com/office/drawing/2014/main" id="{B3600AF7-2A6C-4579-9C3E-3769EE2A237F}"/>
+                <a16:creationId xmlns:a16="http://schemas.microsoft.com/office/drawing/2014/main" id="{AB0EE81A-1861-4E2A-8072-AE2155792D12}"/>
               </a:ext>
             </a:extLst>
           </p:cNvPr>
@@ -4648,7 +4719,7 @@
           <p:cNvPr id="29" name="">
             <a:extLst xmlns:a="http://schemas.openxmlformats.org/drawingml/2006/main">
               <a:ext uri="{FF2B5EF4-FFF2-40B4-BE49-F238E27FC236}">
-                <a16:creationId xmlns:a16="http://schemas.microsoft.com/office/drawing/2014/main" id="{000912E0-9F0B-4450-A544-82266DD0EF84}"/>
+                <a16:creationId xmlns:a16="http://schemas.microsoft.com/office/drawing/2014/main" id="{2F0D2A36-301B-4CA9-9668-4910F0584B2D}"/>
               </a:ext>
             </a:extLst>
           </p:cNvPr>
@@ -4704,7 +4775,7 @@
           <p:cNvPr id="30" name="">
             <a:extLst xmlns:a="http://schemas.openxmlformats.org/drawingml/2006/main">
               <a:ext uri="{FF2B5EF4-FFF2-40B4-BE49-F238E27FC236}">
-                <a16:creationId xmlns:a16="http://schemas.microsoft.com/office/drawing/2014/main" id="{6610FFC0-AB5B-4666-A4E8-87B175B6DB40}"/>
+                <a16:creationId xmlns:a16="http://schemas.microsoft.com/office/drawing/2014/main" id="{A0B6ECDD-4678-45FB-AD5D-2F416689365F}"/>
               </a:ext>
             </a:extLst>
           </p:cNvPr>
@@ -4758,7 +4829,7 @@
     </p:spTree>
     <p:extLst>
       <p:ext uri="{BB962C8B-B14F-4D97-AF65-F5344CB8AC3E}">
-        <p14:creationId xmlns:p14="http://schemas.microsoft.com/office/powerpoint/2010/main" val="1730382497"/>
+        <p14:creationId xmlns:p14="http://schemas.microsoft.com/office/powerpoint/2010/main" val="1089197376"/>
       </p:ext>
     </p:extLst>
   </p:cSld>
@@ -4789,7 +4860,7 @@
           <p:cNvPr id="1" name="">
             <a:extLst xmlns:a="http://schemas.openxmlformats.org/drawingml/2006/main">
               <a:ext uri="{FF2B5EF4-FFF2-40B4-BE49-F238E27FC236}">
-                <a16:creationId xmlns:a16="http://schemas.microsoft.com/office/drawing/2014/main" id="{E73CA066-C7F4-479C-AB1C-B7DDC350BB54}"/>
+                <a16:creationId xmlns:a16="http://schemas.microsoft.com/office/drawing/2014/main" id="{5C9C053C-C33D-42C9-884A-E4F5BD5948B7}"/>
               </a:ext>
             </a:extLst>
           </p:cNvPr>
@@ -4845,7 +4916,7 @@
           <p:cNvPr id="2" name="">
             <a:extLst xmlns:a="http://schemas.openxmlformats.org/drawingml/2006/main">
               <a:ext uri="{FF2B5EF4-FFF2-40B4-BE49-F238E27FC236}">
-                <a16:creationId xmlns:a16="http://schemas.microsoft.com/office/drawing/2014/main" id="{B9F4B7DC-1962-463D-81A8-5E4A57A6669B}"/>
+                <a16:creationId xmlns:a16="http://schemas.microsoft.com/office/drawing/2014/main" id="{DF7CF0ED-FE9D-44C4-A55B-1BC357D6CFE8}"/>
               </a:ext>
             </a:extLst>
           </p:cNvPr>
@@ -4901,7 +4972,7 @@
           <p:cNvPr id="3" name="">
             <a:extLst xmlns:a="http://schemas.openxmlformats.org/drawingml/2006/main">
               <a:ext uri="{FF2B5EF4-FFF2-40B4-BE49-F238E27FC236}">
-                <a16:creationId xmlns:a16="http://schemas.microsoft.com/office/drawing/2014/main" id="{F0779F9D-BCF9-4D96-87C0-D5F29A56063A}"/>
+                <a16:creationId xmlns:a16="http://schemas.microsoft.com/office/drawing/2014/main" id="{57A83193-3D56-4565-A797-6CF84FF3D2E5}"/>
               </a:ext>
             </a:extLst>
           </p:cNvPr>
@@ -4957,7 +5028,7 @@
           <p:cNvPr id="4" name="rule">
             <a:extLst xmlns:a="http://schemas.openxmlformats.org/drawingml/2006/main">
               <a:ext uri="{FF2B5EF4-FFF2-40B4-BE49-F238E27FC236}">
-                <a16:creationId xmlns:a16="http://schemas.microsoft.com/office/drawing/2014/main" id="{29DEB0FF-8CDC-4D8D-B739-4EB6523571EA}"/>
+                <a16:creationId xmlns:a16="http://schemas.microsoft.com/office/drawing/2014/main" id="{AC9FF703-93F2-4383-B38C-02791CA00BB9}"/>
               </a:ext>
             </a:extLst>
           </p:cNvPr>
@@ -4988,7 +5059,7 @@
           <p:cNvPr id="5" name="">
             <a:extLst xmlns:a="http://schemas.openxmlformats.org/drawingml/2006/main">
               <a:ext uri="{FF2B5EF4-FFF2-40B4-BE49-F238E27FC236}">
-                <a16:creationId xmlns:a16="http://schemas.microsoft.com/office/drawing/2014/main" id="{D9B80507-9E2C-4062-A431-712CB099B2FD}"/>
+                <a16:creationId xmlns:a16="http://schemas.microsoft.com/office/drawing/2014/main" id="{89248291-CD21-4FFD-9FC7-23EE51AFFD9A}"/>
               </a:ext>
             </a:extLst>
           </p:cNvPr>
@@ -5021,7 +5092,7 @@
           <p:cNvPr id="6" name="">
             <a:extLst xmlns:a="http://schemas.openxmlformats.org/drawingml/2006/main">
               <a:ext uri="{FF2B5EF4-FFF2-40B4-BE49-F238E27FC236}">
-                <a16:creationId xmlns:a16="http://schemas.microsoft.com/office/drawing/2014/main" id="{B38A5D42-2660-4AF3-B53A-E5A5A5429C4B}"/>
+                <a16:creationId xmlns:a16="http://schemas.microsoft.com/office/drawing/2014/main" id="{9BB2DB8D-B948-44B1-B8F7-B28CC46A6ED0}"/>
               </a:ext>
             </a:extLst>
           </p:cNvPr>
@@ -5077,7 +5148,7 @@
           <p:cNvPr id="7" name="">
             <a:extLst xmlns:a="http://schemas.openxmlformats.org/drawingml/2006/main">
               <a:ext uri="{FF2B5EF4-FFF2-40B4-BE49-F238E27FC236}">
-                <a16:creationId xmlns:a16="http://schemas.microsoft.com/office/drawing/2014/main" id="{3559688A-4B63-43AA-A09B-46D1A11A8278}"/>
+                <a16:creationId xmlns:a16="http://schemas.microsoft.com/office/drawing/2014/main" id="{6D77C367-3CFB-4082-903E-FA280B670D4F}"/>
               </a:ext>
             </a:extLst>
           </p:cNvPr>
@@ -5202,7 +5273,7 @@
           <p:cNvPr id="8" name="">
             <a:extLst xmlns:a="http://schemas.openxmlformats.org/drawingml/2006/main">
               <a:ext uri="{FF2B5EF4-FFF2-40B4-BE49-F238E27FC236}">
-                <a16:creationId xmlns:a16="http://schemas.microsoft.com/office/drawing/2014/main" id="{28787800-8D73-4370-A56B-ECBFE3F0E8B1}"/>
+                <a16:creationId xmlns:a16="http://schemas.microsoft.com/office/drawing/2014/main" id="{11AE362E-53E5-4B74-9874-9FFA1A65BE50}"/>
               </a:ext>
             </a:extLst>
           </p:cNvPr>
@@ -5235,7 +5306,7 @@
           <p:cNvPr id="9" name="">
             <a:extLst xmlns:a="http://schemas.openxmlformats.org/drawingml/2006/main">
               <a:ext uri="{FF2B5EF4-FFF2-40B4-BE49-F238E27FC236}">
-                <a16:creationId xmlns:a16="http://schemas.microsoft.com/office/drawing/2014/main" id="{F6627D2A-8C09-4BAF-A9B4-BA003B466BEB}"/>
+                <a16:creationId xmlns:a16="http://schemas.microsoft.com/office/drawing/2014/main" id="{884735D5-70F6-4C7D-A6D8-02717593A9C2}"/>
               </a:ext>
             </a:extLst>
           </p:cNvPr>
@@ -5291,7 +5362,7 @@
           <p:cNvPr id="10" name="">
             <a:extLst xmlns:a="http://schemas.openxmlformats.org/drawingml/2006/main">
               <a:ext uri="{FF2B5EF4-FFF2-40B4-BE49-F238E27FC236}">
-                <a16:creationId xmlns:a16="http://schemas.microsoft.com/office/drawing/2014/main" id="{54D4A693-FF7C-480C-9556-8A70CE3D833A}"/>
+                <a16:creationId xmlns:a16="http://schemas.microsoft.com/office/drawing/2014/main" id="{125AE86D-8428-4EE3-89ED-D1F94A592DE7}"/>
               </a:ext>
             </a:extLst>
           </p:cNvPr>
@@ -5416,7 +5487,7 @@
           <p:cNvPr id="11" name="">
             <a:extLst xmlns:a="http://schemas.openxmlformats.org/drawingml/2006/main">
               <a:ext uri="{FF2B5EF4-FFF2-40B4-BE49-F238E27FC236}">
-                <a16:creationId xmlns:a16="http://schemas.microsoft.com/office/drawing/2014/main" id="{06C1D15D-E9EA-4419-BE9D-5E584D04B0B2}"/>
+                <a16:creationId xmlns:a16="http://schemas.microsoft.com/office/drawing/2014/main" id="{95DF576D-CE13-4B79-996D-290E5A638020}"/>
               </a:ext>
             </a:extLst>
           </p:cNvPr>
@@ -5449,7 +5520,7 @@
           <p:cNvPr id="12" name="">
             <a:extLst xmlns:a="http://schemas.openxmlformats.org/drawingml/2006/main">
               <a:ext uri="{FF2B5EF4-FFF2-40B4-BE49-F238E27FC236}">
-                <a16:creationId xmlns:a16="http://schemas.microsoft.com/office/drawing/2014/main" id="{C5EBFD70-EF33-4CAD-87F7-92FE15110068}"/>
+                <a16:creationId xmlns:a16="http://schemas.microsoft.com/office/drawing/2014/main" id="{66BC79B0-F587-4711-9CB2-C6DF2B99EF77}"/>
               </a:ext>
             </a:extLst>
           </p:cNvPr>
@@ -5505,7 +5576,7 @@
           <p:cNvPr id="13" name="">
             <a:extLst xmlns:a="http://schemas.openxmlformats.org/drawingml/2006/main">
               <a:ext uri="{FF2B5EF4-FFF2-40B4-BE49-F238E27FC236}">
-                <a16:creationId xmlns:a16="http://schemas.microsoft.com/office/drawing/2014/main" id="{C93F5419-E4B5-44B4-87F2-16B832387D35}"/>
+                <a16:creationId xmlns:a16="http://schemas.microsoft.com/office/drawing/2014/main" id="{F607C12C-0A40-4BEC-920A-988408A3304F}"/>
               </a:ext>
             </a:extLst>
           </p:cNvPr>
@@ -5653,7 +5724,7 @@
           <p:cNvPr id="14" name="">
             <a:extLst xmlns:a="http://schemas.openxmlformats.org/drawingml/2006/main">
               <a:ext uri="{FF2B5EF4-FFF2-40B4-BE49-F238E27FC236}">
-                <a16:creationId xmlns:a16="http://schemas.microsoft.com/office/drawing/2014/main" id="{C192486B-6BED-435E-A314-0A3164185DDE}"/>
+                <a16:creationId xmlns:a16="http://schemas.microsoft.com/office/drawing/2014/main" id="{9D8F9E14-18C1-458E-A181-DF3F22095106}"/>
               </a:ext>
             </a:extLst>
           </p:cNvPr>
@@ -5709,7 +5780,7 @@
           <p:cNvPr id="15" name="">
             <a:extLst xmlns:a="http://schemas.openxmlformats.org/drawingml/2006/main">
               <a:ext uri="{FF2B5EF4-FFF2-40B4-BE49-F238E27FC236}">
-                <a16:creationId xmlns:a16="http://schemas.microsoft.com/office/drawing/2014/main" id="{014E9A11-6082-4BCA-99BB-015254227C80}"/>
+                <a16:creationId xmlns:a16="http://schemas.microsoft.com/office/drawing/2014/main" id="{4F28A25B-136B-40F5-BCBC-E7F0B959FF45}"/>
               </a:ext>
             </a:extLst>
           </p:cNvPr>
@@ -5763,7 +5834,7 @@
     </p:spTree>
     <p:extLst>
       <p:ext uri="{BB962C8B-B14F-4D97-AF65-F5344CB8AC3E}">
-        <p14:creationId xmlns:p14="http://schemas.microsoft.com/office/powerpoint/2010/main" val="1146612577"/>
+        <p14:creationId xmlns:p14="http://schemas.microsoft.com/office/powerpoint/2010/main" val="126429394"/>
       </p:ext>
     </p:extLst>
   </p:cSld>
@@ -5794,7 +5865,7 @@
           <p:cNvPr id="1" name="">
             <a:extLst xmlns:a="http://schemas.openxmlformats.org/drawingml/2006/main">
               <a:ext uri="{FF2B5EF4-FFF2-40B4-BE49-F238E27FC236}">
-                <a16:creationId xmlns:a16="http://schemas.microsoft.com/office/drawing/2014/main" id="{E5155102-F7D3-4259-9B24-0AD96657C7E5}"/>
+                <a16:creationId xmlns:a16="http://schemas.microsoft.com/office/drawing/2014/main" id="{2ECBF7DC-799C-4214-BA97-220456403396}"/>
               </a:ext>
             </a:extLst>
           </p:cNvPr>
@@ -5850,7 +5921,7 @@
           <p:cNvPr id="2" name="">
             <a:extLst xmlns:a="http://schemas.openxmlformats.org/drawingml/2006/main">
               <a:ext uri="{FF2B5EF4-FFF2-40B4-BE49-F238E27FC236}">
-                <a16:creationId xmlns:a16="http://schemas.microsoft.com/office/drawing/2014/main" id="{189A4F4C-08CA-4258-BFC4-FE542DC408CF}"/>
+                <a16:creationId xmlns:a16="http://schemas.microsoft.com/office/drawing/2014/main" id="{64BE9BD2-3DBE-43B2-A7F4-9C3DE7178282}"/>
               </a:ext>
             </a:extLst>
           </p:cNvPr>
@@ -5906,7 +5977,7 @@
           <p:cNvPr id="3" name="">
             <a:extLst xmlns:a="http://schemas.openxmlformats.org/drawingml/2006/main">
               <a:ext uri="{FF2B5EF4-FFF2-40B4-BE49-F238E27FC236}">
-                <a16:creationId xmlns:a16="http://schemas.microsoft.com/office/drawing/2014/main" id="{EB4CA6D8-FF00-4677-AA9F-5E5D73AF9C34}"/>
+                <a16:creationId xmlns:a16="http://schemas.microsoft.com/office/drawing/2014/main" id="{F10EAC9A-FFCC-48DD-A1E9-100C04275999}"/>
               </a:ext>
             </a:extLst>
           </p:cNvPr>
@@ -5962,7 +6033,7 @@
           <p:cNvPr id="4" name="rule">
             <a:extLst xmlns:a="http://schemas.openxmlformats.org/drawingml/2006/main">
               <a:ext uri="{FF2B5EF4-FFF2-40B4-BE49-F238E27FC236}">
-                <a16:creationId xmlns:a16="http://schemas.microsoft.com/office/drawing/2014/main" id="{4FFE1922-A924-4CB4-9FD6-673062F3AA94}"/>
+                <a16:creationId xmlns:a16="http://schemas.microsoft.com/office/drawing/2014/main" id="{0858CA81-F9EF-467B-BCCF-F36743DDDE2C}"/>
               </a:ext>
             </a:extLst>
           </p:cNvPr>
@@ -5993,7 +6064,7 @@
           <p:cNvPr id="5" name="">
             <a:extLst xmlns:a="http://schemas.openxmlformats.org/drawingml/2006/main">
               <a:ext uri="{FF2B5EF4-FFF2-40B4-BE49-F238E27FC236}">
-                <a16:creationId xmlns:a16="http://schemas.microsoft.com/office/drawing/2014/main" id="{1463FF5E-09DB-4A6F-8A2B-DEC6666BE619}"/>
+                <a16:creationId xmlns:a16="http://schemas.microsoft.com/office/drawing/2014/main" id="{32C5FAE5-C934-4897-B9C9-E3EF6BAC3F49}"/>
               </a:ext>
             </a:extLst>
           </p:cNvPr>
@@ -6026,7 +6097,7 @@
           <p:cNvPr id="6" name="">
             <a:extLst xmlns:a="http://schemas.openxmlformats.org/drawingml/2006/main">
               <a:ext uri="{FF2B5EF4-FFF2-40B4-BE49-F238E27FC236}">
-                <a16:creationId xmlns:a16="http://schemas.microsoft.com/office/drawing/2014/main" id="{01A8483A-3216-4DBE-A7EF-BAD1898ED05D}"/>
+                <a16:creationId xmlns:a16="http://schemas.microsoft.com/office/drawing/2014/main" id="{5DBE814D-1B9D-4029-91BA-C2270EF3636F}"/>
               </a:ext>
             </a:extLst>
           </p:cNvPr>
@@ -6082,7 +6153,7 @@
           <p:cNvPr id="7" name="">
             <a:extLst xmlns:a="http://schemas.openxmlformats.org/drawingml/2006/main">
               <a:ext uri="{FF2B5EF4-FFF2-40B4-BE49-F238E27FC236}">
-                <a16:creationId xmlns:a16="http://schemas.microsoft.com/office/drawing/2014/main" id="{343449EE-8FFF-4676-93EF-6EE9950B6709}"/>
+                <a16:creationId xmlns:a16="http://schemas.microsoft.com/office/drawing/2014/main" id="{FA41EC9B-83D4-40E6-A6BD-661D2507BB35}"/>
               </a:ext>
             </a:extLst>
           </p:cNvPr>
@@ -6253,7 +6324,7 @@
           <p:cNvPr id="8" name="">
             <a:extLst xmlns:a="http://schemas.openxmlformats.org/drawingml/2006/main">
               <a:ext uri="{FF2B5EF4-FFF2-40B4-BE49-F238E27FC236}">
-                <a16:creationId xmlns:a16="http://schemas.microsoft.com/office/drawing/2014/main" id="{5968CFAE-ABC1-4424-8841-B37FFB359C30}"/>
+                <a16:creationId xmlns:a16="http://schemas.microsoft.com/office/drawing/2014/main" id="{8992A3BE-EB0E-475C-B95D-AF595FBD6D79}"/>
               </a:ext>
             </a:extLst>
           </p:cNvPr>
@@ -6286,7 +6357,7 @@
           <p:cNvPr id="9" name="">
             <a:extLst xmlns:a="http://schemas.openxmlformats.org/drawingml/2006/main">
               <a:ext uri="{FF2B5EF4-FFF2-40B4-BE49-F238E27FC236}">
-                <a16:creationId xmlns:a16="http://schemas.microsoft.com/office/drawing/2014/main" id="{87A96471-35FE-4525-ACFB-82AC2B19CF80}"/>
+                <a16:creationId xmlns:a16="http://schemas.microsoft.com/office/drawing/2014/main" id="{3862F358-D6C3-41C8-B409-162CFE1260D9}"/>
               </a:ext>
             </a:extLst>
           </p:cNvPr>
@@ -6342,7 +6413,7 @@
           <p:cNvPr id="10" name="">
             <a:extLst xmlns:a="http://schemas.openxmlformats.org/drawingml/2006/main">
               <a:ext uri="{FF2B5EF4-FFF2-40B4-BE49-F238E27FC236}">
-                <a16:creationId xmlns:a16="http://schemas.microsoft.com/office/drawing/2014/main" id="{93FACDA1-D6E1-440C-A537-B979DE1D3071}"/>
+                <a16:creationId xmlns:a16="http://schemas.microsoft.com/office/drawing/2014/main" id="{25E539B8-014B-4B37-ADEF-1CEF814B2473}"/>
               </a:ext>
             </a:extLst>
           </p:cNvPr>
@@ -6490,7 +6561,7 @@
           <p:cNvPr id="11" name="">
             <a:extLst xmlns:a="http://schemas.openxmlformats.org/drawingml/2006/main">
               <a:ext uri="{FF2B5EF4-FFF2-40B4-BE49-F238E27FC236}">
-                <a16:creationId xmlns:a16="http://schemas.microsoft.com/office/drawing/2014/main" id="{6CC6372D-A36E-4484-B766-A6DAD98BAD19}"/>
+                <a16:creationId xmlns:a16="http://schemas.microsoft.com/office/drawing/2014/main" id="{35187DDD-3774-4289-9729-B92E506A2718}"/>
               </a:ext>
             </a:extLst>
           </p:cNvPr>
@@ -6546,7 +6617,7 @@
           <p:cNvPr id="12" name="">
             <a:extLst xmlns:a="http://schemas.openxmlformats.org/drawingml/2006/main">
               <a:ext uri="{FF2B5EF4-FFF2-40B4-BE49-F238E27FC236}">
-                <a16:creationId xmlns:a16="http://schemas.microsoft.com/office/drawing/2014/main" id="{C30AF0E1-9FD4-49B5-846F-D98B032AA4AF}"/>
+                <a16:creationId xmlns:a16="http://schemas.microsoft.com/office/drawing/2014/main" id="{B794EDE3-647F-46AF-A998-1AA568775ECD}"/>
               </a:ext>
             </a:extLst>
           </p:cNvPr>
@@ -6600,7 +6671,1355 @@
     </p:spTree>
     <p:extLst>
       <p:ext uri="{BB962C8B-B14F-4D97-AF65-F5344CB8AC3E}">
-        <p14:creationId xmlns:p14="http://schemas.microsoft.com/office/powerpoint/2010/main" val="1717105545"/>
+        <p14:creationId xmlns:p14="http://schemas.microsoft.com/office/powerpoint/2010/main" val="460544951"/>
+      </p:ext>
+    </p:extLst>
+  </p:cSld>
+</p:sld>
+</file>
+
+<file path=ppt/slides/slide13.xml><?xml version="1.0" encoding="utf-8"?>
+<p:sld xmlns:p="http://schemas.openxmlformats.org/presentationml/2006/main">
+  <p:cSld>
+    <p:bg>
+      <p:bgPr>
+        <a:solidFill xmlns:a="http://schemas.openxmlformats.org/drawingml/2006/main">
+          <a:srgbClr val="F6F8FB"/>
+        </a:solidFill>
+      </p:bgPr>
+    </p:bg>
+    <p:spTree>
+      <p:nvGrpSpPr>
+        <p:cNvPr id="1" name=""/>
+        <p:cNvGrpSpPr/>
+        <p:nvPr/>
+      </p:nvGrpSpPr>
+      <p:grpSpPr>
+        <a:xfrm xmlns:a="http://schemas.openxmlformats.org/drawingml/2006/main"/>
+      </p:grpSpPr>
+      <p:sp>
+        <p:nvSpPr>
+          <p:cNvPr id="1" name="">
+            <a:extLst xmlns:a="http://schemas.openxmlformats.org/drawingml/2006/main">
+              <a:ext uri="{FF2B5EF4-FFF2-40B4-BE49-F238E27FC236}">
+                <a16:creationId xmlns:a16="http://schemas.microsoft.com/office/drawing/2014/main" id="{8DC785F4-8135-46B4-A19B-BC6B09DAA38A}"/>
+              </a:ext>
+            </a:extLst>
+          </p:cNvPr>
+          <p:cNvSpPr>
+            <a:spLocks xmlns:a="http://schemas.openxmlformats.org/drawingml/2006/main" noGrp="1"/>
+          </p:cNvSpPr>
+          <p:nvPr/>
+        </p:nvSpPr>
+        <p:spPr>
+          <a:xfrm xmlns:a="http://schemas.openxmlformats.org/drawingml/2006/main">
+            <a:off x="533400" y="266700"/>
+            <a:ext cx="7239000" cy="228600"/>
+          </a:xfrm>
+          <a:prstGeom xmlns:a="http://schemas.openxmlformats.org/drawingml/2006/main" prst="rect">
+            <a:avLst/>
+          </a:prstGeom>
+          <a:noFill xmlns:a="http://schemas.openxmlformats.org/drawingml/2006/main"/>
+          <a:ln xmlns:a="http://schemas.openxmlformats.org/drawingml/2006/main" w="0">
+            <a:noFill/>
+            <a:prstDash val="solid"/>
+          </a:ln>
+        </p:spPr>
+        <p:txBody>
+          <a:bodyPr xmlns:a="http://schemas.openxmlformats.org/drawingml/2006/main" anchor="t"/>
+          <a:lstStyle xmlns:a="http://schemas.openxmlformats.org/drawingml/2006/main"/>
+          <a:p xmlns:a="http://schemas.openxmlformats.org/drawingml/2006/main">
+            <a:pPr algn="l">
+              <a:defRPr sz="975" b="1">
+                <a:solidFill>
+                  <a:srgbClr val="1F9D8A"/>
+                </a:solidFill>
+                <a:latin typeface="Aptos"/>
+                <a:ea typeface="Aptos"/>
+                <a:cs typeface="Aptos"/>
+              </a:defRPr>
+            </a:pPr>
+            <a:r>
+              <a:rPr sz="975" b="1">
+                <a:solidFill>
+                  <a:srgbClr val="1F9D8A"/>
+                </a:solidFill>
+                <a:latin typeface="Aptos"/>
+                <a:ea typeface="Aptos"/>
+                <a:cs typeface="Aptos"/>
+              </a:rPr>
+              <a:t>AI INTEGRATION GATE</a:t>
+            </a:r>
+          </a:p>
+        </p:txBody>
+      </p:sp>
+      <p:sp>
+        <p:nvSpPr>
+          <p:cNvPr id="2" name="">
+            <a:extLst xmlns:a="http://schemas.openxmlformats.org/drawingml/2006/main">
+              <a:ext uri="{FF2B5EF4-FFF2-40B4-BE49-F238E27FC236}">
+                <a16:creationId xmlns:a16="http://schemas.microsoft.com/office/drawing/2014/main" id="{EC8D01EC-5C5F-4289-8A52-3E5D4495EFFD}"/>
+              </a:ext>
+            </a:extLst>
+          </p:cNvPr>
+          <p:cNvSpPr>
+            <a:spLocks xmlns:a="http://schemas.openxmlformats.org/drawingml/2006/main" noGrp="1"/>
+          </p:cNvSpPr>
+          <p:nvPr/>
+        </p:nvSpPr>
+        <p:spPr>
+          <a:xfrm xmlns:a="http://schemas.openxmlformats.org/drawingml/2006/main">
+            <a:off x="533400" y="552450"/>
+            <a:ext cx="8191500" cy="552450"/>
+          </a:xfrm>
+          <a:prstGeom xmlns:a="http://schemas.openxmlformats.org/drawingml/2006/main" prst="rect">
+            <a:avLst/>
+          </a:prstGeom>
+          <a:noFill xmlns:a="http://schemas.openxmlformats.org/drawingml/2006/main"/>
+          <a:ln xmlns:a="http://schemas.openxmlformats.org/drawingml/2006/main" w="0">
+            <a:noFill/>
+            <a:prstDash val="solid"/>
+          </a:ln>
+        </p:spPr>
+        <p:txBody>
+          <a:bodyPr xmlns:a="http://schemas.openxmlformats.org/drawingml/2006/main" anchor="t"/>
+          <a:lstStyle xmlns:a="http://schemas.openxmlformats.org/drawingml/2006/main"/>
+          <a:p xmlns:a="http://schemas.openxmlformats.org/drawingml/2006/main">
+            <a:pPr algn="l">
+              <a:defRPr sz="2100" b="1">
+                <a:solidFill>
+                  <a:srgbClr val="151922"/>
+                </a:solidFill>
+                <a:latin typeface="Aptos Display"/>
+                <a:ea typeface="Aptos Display"/>
+                <a:cs typeface="Aptos Display"/>
+              </a:defRPr>
+            </a:pPr>
+            <a:r>
+              <a:rPr sz="2100" b="1">
+                <a:solidFill>
+                  <a:srgbClr val="151922"/>
+                </a:solidFill>
+                <a:latin typeface="Aptos Display"/>
+                <a:ea typeface="Aptos Display"/>
+                <a:cs typeface="Aptos Display"/>
+              </a:rPr>
+              <a:t>AI is integrated as an assistant, with deterministic SBOM authority preserved</a:t>
+            </a:r>
+          </a:p>
+        </p:txBody>
+      </p:sp>
+      <p:sp>
+        <p:nvSpPr>
+          <p:cNvPr id="3" name="">
+            <a:extLst xmlns:a="http://schemas.openxmlformats.org/drawingml/2006/main">
+              <a:ext uri="{FF2B5EF4-FFF2-40B4-BE49-F238E27FC236}">
+                <a16:creationId xmlns:a16="http://schemas.microsoft.com/office/drawing/2014/main" id="{D2D5032B-596D-4780-A2E3-3E6B1E52098D}"/>
+              </a:ext>
+            </a:extLst>
+          </p:cNvPr>
+          <p:cNvSpPr>
+            <a:spLocks xmlns:a="http://schemas.openxmlformats.org/drawingml/2006/main" noGrp="1"/>
+          </p:cNvSpPr>
+          <p:nvPr/>
+        </p:nvSpPr>
+        <p:spPr>
+          <a:xfrm xmlns:a="http://schemas.openxmlformats.org/drawingml/2006/main">
+            <a:off x="11125200" y="304800"/>
+            <a:ext cx="533400" cy="247650"/>
+          </a:xfrm>
+          <a:prstGeom xmlns:a="http://schemas.openxmlformats.org/drawingml/2006/main" prst="rect">
+            <a:avLst/>
+          </a:prstGeom>
+          <a:noFill xmlns:a="http://schemas.openxmlformats.org/drawingml/2006/main"/>
+          <a:ln xmlns:a="http://schemas.openxmlformats.org/drawingml/2006/main" w="0">
+            <a:noFill/>
+            <a:prstDash val="solid"/>
+          </a:ln>
+        </p:spPr>
+        <p:txBody>
+          <a:bodyPr xmlns:a="http://schemas.openxmlformats.org/drawingml/2006/main" anchor="t"/>
+          <a:lstStyle xmlns:a="http://schemas.openxmlformats.org/drawingml/2006/main"/>
+          <a:p xmlns:a="http://schemas.openxmlformats.org/drawingml/2006/main">
+            <a:pPr algn="r">
+              <a:defRPr sz="975" b="0">
+                <a:solidFill>
+                  <a:srgbClr val="596575"/>
+                </a:solidFill>
+                <a:latin typeface="Aptos"/>
+                <a:ea typeface="Aptos"/>
+                <a:cs typeface="Aptos"/>
+              </a:defRPr>
+            </a:pPr>
+            <a:r>
+              <a:rPr sz="975" b="0">
+                <a:solidFill>
+                  <a:srgbClr val="596575"/>
+                </a:solidFill>
+                <a:latin typeface="Aptos"/>
+                <a:ea typeface="Aptos"/>
+                <a:cs typeface="Aptos"/>
+              </a:rPr>
+              <a:t>13</a:t>
+            </a:r>
+          </a:p>
+        </p:txBody>
+      </p:sp>
+      <p:sp>
+        <p:nvSpPr>
+          <p:cNvPr id="4" name="rule">
+            <a:extLst xmlns:a="http://schemas.openxmlformats.org/drawingml/2006/main">
+              <a:ext uri="{FF2B5EF4-FFF2-40B4-BE49-F238E27FC236}">
+                <a16:creationId xmlns:a16="http://schemas.microsoft.com/office/drawing/2014/main" id="{940D202D-F56C-45D2-88EF-B968A6B0465E}"/>
+              </a:ext>
+            </a:extLst>
+          </p:cNvPr>
+          <p:cNvSpPr>
+            <a:spLocks xmlns:a="http://schemas.openxmlformats.org/drawingml/2006/main" noGrp="1"/>
+          </p:cNvSpPr>
+          <p:nvPr/>
+        </p:nvSpPr>
+        <p:spPr>
+          <a:xfrm xmlns:a="http://schemas.openxmlformats.org/drawingml/2006/main">
+            <a:off x="533400" y="1200150"/>
+            <a:ext cx="11125200" cy="19050"/>
+          </a:xfrm>
+          <a:prstGeom xmlns:a="http://schemas.openxmlformats.org/drawingml/2006/main" prst="rect">
+            <a:avLst/>
+          </a:prstGeom>
+          <a:solidFill xmlns:a="http://schemas.openxmlformats.org/drawingml/2006/main">
+            <a:srgbClr val="D6DEE8"/>
+          </a:solidFill>
+          <a:ln xmlns:a="http://schemas.openxmlformats.org/drawingml/2006/main" w="0">
+            <a:noFill/>
+            <a:prstDash val="solid"/>
+          </a:ln>
+        </p:spPr>
+      </p:sp>
+      <p:sp>
+        <p:nvSpPr>
+          <p:cNvPr id="5" name="">
+            <a:extLst xmlns:a="http://schemas.openxmlformats.org/drawingml/2006/main">
+              <a:ext uri="{FF2B5EF4-FFF2-40B4-BE49-F238E27FC236}">
+                <a16:creationId xmlns:a16="http://schemas.microsoft.com/office/drawing/2014/main" id="{FB14958F-85B1-47D8-ABA9-DE6F9AF233B8}"/>
+              </a:ext>
+            </a:extLst>
+          </p:cNvPr>
+          <p:cNvSpPr>
+            <a:spLocks xmlns:a="http://schemas.openxmlformats.org/drawingml/2006/main" noGrp="1"/>
+          </p:cNvSpPr>
+          <p:nvPr/>
+        </p:nvSpPr>
+        <p:spPr>
+          <a:xfrm xmlns:a="http://schemas.openxmlformats.org/drawingml/2006/main">
+            <a:off x="723900" y="1581150"/>
+            <a:ext cx="2381250" cy="1066800"/>
+          </a:xfrm>
+          <a:prstGeom xmlns:a="http://schemas.openxmlformats.org/drawingml/2006/main" prst="rect">
+            <a:avLst/>
+          </a:prstGeom>
+          <a:solidFill xmlns:a="http://schemas.openxmlformats.org/drawingml/2006/main">
+            <a:srgbClr val="FFFFFF"/>
+          </a:solidFill>
+          <a:ln xmlns:a="http://schemas.openxmlformats.org/drawingml/2006/main" w="9525">
+            <a:solidFill>
+              <a:srgbClr val="356AC3"/>
+            </a:solidFill>
+            <a:prstDash val="solid"/>
+          </a:ln>
+        </p:spPr>
+      </p:sp>
+      <p:sp>
+        <p:nvSpPr>
+          <p:cNvPr id="6" name="">
+            <a:extLst xmlns:a="http://schemas.openxmlformats.org/drawingml/2006/main">
+              <a:ext uri="{FF2B5EF4-FFF2-40B4-BE49-F238E27FC236}">
+                <a16:creationId xmlns:a16="http://schemas.microsoft.com/office/drawing/2014/main" id="{B73FEF07-395D-4AF5-B232-3D110D371443}"/>
+              </a:ext>
+            </a:extLst>
+          </p:cNvPr>
+          <p:cNvSpPr>
+            <a:spLocks xmlns:a="http://schemas.openxmlformats.org/drawingml/2006/main" noGrp="1"/>
+          </p:cNvSpPr>
+          <p:nvPr/>
+        </p:nvSpPr>
+        <p:spPr>
+          <a:xfrm xmlns:a="http://schemas.openxmlformats.org/drawingml/2006/main">
+            <a:off x="857250" y="1714500"/>
+            <a:ext cx="2114550" cy="342900"/>
+          </a:xfrm>
+          <a:prstGeom xmlns:a="http://schemas.openxmlformats.org/drawingml/2006/main" prst="rect">
+            <a:avLst/>
+          </a:prstGeom>
+          <a:noFill xmlns:a="http://schemas.openxmlformats.org/drawingml/2006/main"/>
+          <a:ln xmlns:a="http://schemas.openxmlformats.org/drawingml/2006/main" w="0">
+            <a:noFill/>
+            <a:prstDash val="solid"/>
+          </a:ln>
+        </p:spPr>
+        <p:txBody>
+          <a:bodyPr xmlns:a="http://schemas.openxmlformats.org/drawingml/2006/main" anchor="t"/>
+          <a:lstStyle xmlns:a="http://schemas.openxmlformats.org/drawingml/2006/main"/>
+          <a:p xmlns:a="http://schemas.openxmlformats.org/drawingml/2006/main">
+            <a:pPr algn="l">
+              <a:defRPr sz="2100" b="1">
+                <a:solidFill>
+                  <a:srgbClr val="356AC3"/>
+                </a:solidFill>
+                <a:latin typeface="Aptos"/>
+                <a:ea typeface="Aptos"/>
+                <a:cs typeface="Aptos"/>
+              </a:defRPr>
+            </a:pPr>
+            <a:r>
+              <a:rPr sz="2100" b="1">
+                <a:solidFill>
+                  <a:srgbClr val="356AC3"/>
+                </a:solidFill>
+                <a:latin typeface="Aptos"/>
+                <a:ea typeface="Aptos"/>
+                <a:cs typeface="Aptos"/>
+              </a:rPr>
+              <a:t>0.708</a:t>
+            </a:r>
+          </a:p>
+        </p:txBody>
+      </p:sp>
+      <p:sp>
+        <p:nvSpPr>
+          <p:cNvPr id="7" name="">
+            <a:extLst xmlns:a="http://schemas.openxmlformats.org/drawingml/2006/main">
+              <a:ext uri="{FF2B5EF4-FFF2-40B4-BE49-F238E27FC236}">
+                <a16:creationId xmlns:a16="http://schemas.microsoft.com/office/drawing/2014/main" id="{8F63088C-7E35-4A85-97E1-4A9C2832A0E4}"/>
+              </a:ext>
+            </a:extLst>
+          </p:cNvPr>
+          <p:cNvSpPr>
+            <a:spLocks xmlns:a="http://schemas.openxmlformats.org/drawingml/2006/main" noGrp="1"/>
+          </p:cNvSpPr>
+          <p:nvPr/>
+        </p:nvSpPr>
+        <p:spPr>
+          <a:xfrm xmlns:a="http://schemas.openxmlformats.org/drawingml/2006/main">
+            <a:off x="857250" y="2095500"/>
+            <a:ext cx="2114550" cy="476250"/>
+          </a:xfrm>
+          <a:prstGeom xmlns:a="http://schemas.openxmlformats.org/drawingml/2006/main" prst="rect">
+            <a:avLst/>
+          </a:prstGeom>
+          <a:noFill xmlns:a="http://schemas.openxmlformats.org/drawingml/2006/main"/>
+          <a:ln xmlns:a="http://schemas.openxmlformats.org/drawingml/2006/main" w="0">
+            <a:noFill/>
+            <a:prstDash val="solid"/>
+          </a:ln>
+        </p:spPr>
+        <p:txBody>
+          <a:bodyPr xmlns:a="http://schemas.openxmlformats.org/drawingml/2006/main" anchor="t"/>
+          <a:lstStyle xmlns:a="http://schemas.openxmlformats.org/drawingml/2006/main"/>
+          <a:p xmlns:a="http://schemas.openxmlformats.org/drawingml/2006/main">
+            <a:pPr algn="l">
+              <a:defRPr sz="900" b="0">
+                <a:solidFill>
+                  <a:srgbClr val="596575"/>
+                </a:solidFill>
+                <a:latin typeface="Aptos"/>
+                <a:ea typeface="Aptos"/>
+                <a:cs typeface="Aptos"/>
+              </a:defRPr>
+            </a:pPr>
+            <a:r>
+              <a:rPr sz="900" b="0">
+                <a:solidFill>
+                  <a:srgbClr val="596575"/>
+                </a:solidFill>
+                <a:latin typeface="Aptos"/>
+                <a:ea typeface="Aptos"/>
+                <a:cs typeface="Aptos"/>
+              </a:rPr>
+              <a:t>RandomForest test macro-F1 on 20,523 grouped evidence rows</a:t>
+            </a:r>
+          </a:p>
+        </p:txBody>
+      </p:sp>
+      <p:sp>
+        <p:nvSpPr>
+          <p:cNvPr id="8" name="">
+            <a:extLst xmlns:a="http://schemas.openxmlformats.org/drawingml/2006/main">
+              <a:ext uri="{FF2B5EF4-FFF2-40B4-BE49-F238E27FC236}">
+                <a16:creationId xmlns:a16="http://schemas.microsoft.com/office/drawing/2014/main" id="{DBE91E99-2857-4D9E-A345-5A1802DD75A1}"/>
+              </a:ext>
+            </a:extLst>
+          </p:cNvPr>
+          <p:cNvSpPr>
+            <a:spLocks xmlns:a="http://schemas.openxmlformats.org/drawingml/2006/main" noGrp="1"/>
+          </p:cNvSpPr>
+          <p:nvPr/>
+        </p:nvSpPr>
+        <p:spPr>
+          <a:xfrm xmlns:a="http://schemas.openxmlformats.org/drawingml/2006/main">
+            <a:off x="3409950" y="1581150"/>
+            <a:ext cx="2381250" cy="1066800"/>
+          </a:xfrm>
+          <a:prstGeom xmlns:a="http://schemas.openxmlformats.org/drawingml/2006/main" prst="rect">
+            <a:avLst/>
+          </a:prstGeom>
+          <a:solidFill xmlns:a="http://schemas.openxmlformats.org/drawingml/2006/main">
+            <a:srgbClr val="FFFFFF"/>
+          </a:solidFill>
+          <a:ln xmlns:a="http://schemas.openxmlformats.org/drawingml/2006/main" w="9525">
+            <a:solidFill>
+              <a:srgbClr val="1F9D8A"/>
+            </a:solidFill>
+            <a:prstDash val="solid"/>
+          </a:ln>
+        </p:spPr>
+      </p:sp>
+      <p:sp>
+        <p:nvSpPr>
+          <p:cNvPr id="9" name="">
+            <a:extLst xmlns:a="http://schemas.openxmlformats.org/drawingml/2006/main">
+              <a:ext uri="{FF2B5EF4-FFF2-40B4-BE49-F238E27FC236}">
+                <a16:creationId xmlns:a16="http://schemas.microsoft.com/office/drawing/2014/main" id="{D66BA37E-EDED-4B69-A0AF-60DF78FD4B73}"/>
+              </a:ext>
+            </a:extLst>
+          </p:cNvPr>
+          <p:cNvSpPr>
+            <a:spLocks xmlns:a="http://schemas.openxmlformats.org/drawingml/2006/main" noGrp="1"/>
+          </p:cNvSpPr>
+          <p:nvPr/>
+        </p:nvSpPr>
+        <p:spPr>
+          <a:xfrm xmlns:a="http://schemas.openxmlformats.org/drawingml/2006/main">
+            <a:off x="3543300" y="1714500"/>
+            <a:ext cx="2114550" cy="342900"/>
+          </a:xfrm>
+          <a:prstGeom xmlns:a="http://schemas.openxmlformats.org/drawingml/2006/main" prst="rect">
+            <a:avLst/>
+          </a:prstGeom>
+          <a:noFill xmlns:a="http://schemas.openxmlformats.org/drawingml/2006/main"/>
+          <a:ln xmlns:a="http://schemas.openxmlformats.org/drawingml/2006/main" w="0">
+            <a:noFill/>
+            <a:prstDash val="solid"/>
+          </a:ln>
+        </p:spPr>
+        <p:txBody>
+          <a:bodyPr xmlns:a="http://schemas.openxmlformats.org/drawingml/2006/main" anchor="t"/>
+          <a:lstStyle xmlns:a="http://schemas.openxmlformats.org/drawingml/2006/main"/>
+          <a:p xmlns:a="http://schemas.openxmlformats.org/drawingml/2006/main">
+            <a:pPr algn="l">
+              <a:defRPr sz="2100" b="1">
+                <a:solidFill>
+                  <a:srgbClr val="1F9D8A"/>
+                </a:solidFill>
+                <a:latin typeface="Aptos"/>
+                <a:ea typeface="Aptos"/>
+                <a:cs typeface="Aptos"/>
+              </a:defRPr>
+            </a:pPr>
+            <a:r>
+              <a:rPr sz="2100" b="1">
+                <a:solidFill>
+                  <a:srgbClr val="1F9D8A"/>
+                </a:solidFill>
+                <a:latin typeface="Aptos"/>
+                <a:ea typeface="Aptos"/>
+                <a:cs typeface="Aptos"/>
+              </a:rPr>
+              <a:t>0.882</a:t>
+            </a:r>
+          </a:p>
+        </p:txBody>
+      </p:sp>
+      <p:sp>
+        <p:nvSpPr>
+          <p:cNvPr id="10" name="">
+            <a:extLst xmlns:a="http://schemas.openxmlformats.org/drawingml/2006/main">
+              <a:ext uri="{FF2B5EF4-FFF2-40B4-BE49-F238E27FC236}">
+                <a16:creationId xmlns:a16="http://schemas.microsoft.com/office/drawing/2014/main" id="{F96C8587-C0E3-4A28-B12D-A70035E088B5}"/>
+              </a:ext>
+            </a:extLst>
+          </p:cNvPr>
+          <p:cNvSpPr>
+            <a:spLocks xmlns:a="http://schemas.openxmlformats.org/drawingml/2006/main" noGrp="1"/>
+          </p:cNvSpPr>
+          <p:nvPr/>
+        </p:nvSpPr>
+        <p:spPr>
+          <a:xfrm xmlns:a="http://schemas.openxmlformats.org/drawingml/2006/main">
+            <a:off x="3543300" y="2095500"/>
+            <a:ext cx="2114550" cy="476250"/>
+          </a:xfrm>
+          <a:prstGeom xmlns:a="http://schemas.openxmlformats.org/drawingml/2006/main" prst="rect">
+            <a:avLst/>
+          </a:prstGeom>
+          <a:noFill xmlns:a="http://schemas.openxmlformats.org/drawingml/2006/main"/>
+          <a:ln xmlns:a="http://schemas.openxmlformats.org/drawingml/2006/main" w="0">
+            <a:noFill/>
+            <a:prstDash val="solid"/>
+          </a:ln>
+        </p:spPr>
+        <p:txBody>
+          <a:bodyPr xmlns:a="http://schemas.openxmlformats.org/drawingml/2006/main" anchor="t"/>
+          <a:lstStyle xmlns:a="http://schemas.openxmlformats.org/drawingml/2006/main"/>
+          <a:p xmlns:a="http://schemas.openxmlformats.org/drawingml/2006/main">
+            <a:pPr algn="l">
+              <a:defRPr sz="900" b="0">
+                <a:solidFill>
+                  <a:srgbClr val="596575"/>
+                </a:solidFill>
+                <a:latin typeface="Aptos"/>
+                <a:ea typeface="Aptos"/>
+                <a:cs typeface="Aptos"/>
+              </a:defRPr>
+            </a:pPr>
+            <a:r>
+              <a:rPr sz="900" b="0">
+                <a:solidFill>
+                  <a:srgbClr val="596575"/>
+                </a:solidFill>
+                <a:latin typeface="Aptos"/>
+                <a:ea typeface="Aptos"/>
+                <a:cs typeface="Aptos"/>
+              </a:rPr>
+              <a:t>MVP-safe Transformer test macro-F1 without source shortcuts</a:t>
+            </a:r>
+          </a:p>
+        </p:txBody>
+      </p:sp>
+      <p:sp>
+        <p:nvSpPr>
+          <p:cNvPr id="11" name="">
+            <a:extLst xmlns:a="http://schemas.openxmlformats.org/drawingml/2006/main">
+              <a:ext uri="{FF2B5EF4-FFF2-40B4-BE49-F238E27FC236}">
+                <a16:creationId xmlns:a16="http://schemas.microsoft.com/office/drawing/2014/main" id="{AADDE2C9-4EA1-426E-9601-D2153020235D}"/>
+              </a:ext>
+            </a:extLst>
+          </p:cNvPr>
+          <p:cNvSpPr>
+            <a:spLocks xmlns:a="http://schemas.openxmlformats.org/drawingml/2006/main" noGrp="1"/>
+          </p:cNvSpPr>
+          <p:nvPr/>
+        </p:nvSpPr>
+        <p:spPr>
+          <a:xfrm xmlns:a="http://schemas.openxmlformats.org/drawingml/2006/main">
+            <a:off x="6096000" y="1581150"/>
+            <a:ext cx="2381250" cy="1066800"/>
+          </a:xfrm>
+          <a:prstGeom xmlns:a="http://schemas.openxmlformats.org/drawingml/2006/main" prst="rect">
+            <a:avLst/>
+          </a:prstGeom>
+          <a:solidFill xmlns:a="http://schemas.openxmlformats.org/drawingml/2006/main">
+            <a:srgbClr val="FFFFFF"/>
+          </a:solidFill>
+          <a:ln xmlns:a="http://schemas.openxmlformats.org/drawingml/2006/main" w="9525">
+            <a:solidFill>
+              <a:srgbClr val="C34E5A"/>
+            </a:solidFill>
+            <a:prstDash val="solid"/>
+          </a:ln>
+        </p:spPr>
+      </p:sp>
+      <p:sp>
+        <p:nvSpPr>
+          <p:cNvPr id="12" name="">
+            <a:extLst xmlns:a="http://schemas.openxmlformats.org/drawingml/2006/main">
+              <a:ext uri="{FF2B5EF4-FFF2-40B4-BE49-F238E27FC236}">
+                <a16:creationId xmlns:a16="http://schemas.microsoft.com/office/drawing/2014/main" id="{BCB92A4D-414B-48AB-854E-145917320A13}"/>
+              </a:ext>
+            </a:extLst>
+          </p:cNvPr>
+          <p:cNvSpPr>
+            <a:spLocks xmlns:a="http://schemas.openxmlformats.org/drawingml/2006/main" noGrp="1"/>
+          </p:cNvSpPr>
+          <p:nvPr/>
+        </p:nvSpPr>
+        <p:spPr>
+          <a:xfrm xmlns:a="http://schemas.openxmlformats.org/drawingml/2006/main">
+            <a:off x="6229350" y="1714500"/>
+            <a:ext cx="2114550" cy="342900"/>
+          </a:xfrm>
+          <a:prstGeom xmlns:a="http://schemas.openxmlformats.org/drawingml/2006/main" prst="rect">
+            <a:avLst/>
+          </a:prstGeom>
+          <a:noFill xmlns:a="http://schemas.openxmlformats.org/drawingml/2006/main"/>
+          <a:ln xmlns:a="http://schemas.openxmlformats.org/drawingml/2006/main" w="0">
+            <a:noFill/>
+            <a:prstDash val="solid"/>
+          </a:ln>
+        </p:spPr>
+        <p:txBody>
+          <a:bodyPr xmlns:a="http://schemas.openxmlformats.org/drawingml/2006/main" anchor="t"/>
+          <a:lstStyle xmlns:a="http://schemas.openxmlformats.org/drawingml/2006/main"/>
+          <a:p xmlns:a="http://schemas.openxmlformats.org/drawingml/2006/main">
+            <a:pPr algn="l">
+              <a:defRPr sz="2100" b="1">
+                <a:solidFill>
+                  <a:srgbClr val="C34E5A"/>
+                </a:solidFill>
+                <a:latin typeface="Aptos"/>
+                <a:ea typeface="Aptos"/>
+                <a:cs typeface="Aptos"/>
+              </a:defRPr>
+            </a:pPr>
+            <a:r>
+              <a:rPr sz="2100" b="1">
+                <a:solidFill>
+                  <a:srgbClr val="C34E5A"/>
+                </a:solidFill>
+                <a:latin typeface="Aptos"/>
+                <a:ea typeface="Aptos"/>
+                <a:cs typeface="Aptos"/>
+              </a:rPr>
+              <a:t>0.110</a:t>
+            </a:r>
+          </a:p>
+        </p:txBody>
+      </p:sp>
+      <p:sp>
+        <p:nvSpPr>
+          <p:cNvPr id="13" name="">
+            <a:extLst xmlns:a="http://schemas.openxmlformats.org/drawingml/2006/main">
+              <a:ext uri="{FF2B5EF4-FFF2-40B4-BE49-F238E27FC236}">
+                <a16:creationId xmlns:a16="http://schemas.microsoft.com/office/drawing/2014/main" id="{A4EE0589-E305-4C78-A99A-FB04D2FC75D1}"/>
+              </a:ext>
+            </a:extLst>
+          </p:cNvPr>
+          <p:cNvSpPr>
+            <a:spLocks xmlns:a="http://schemas.openxmlformats.org/drawingml/2006/main" noGrp="1"/>
+          </p:cNvSpPr>
+          <p:nvPr/>
+        </p:nvSpPr>
+        <p:spPr>
+          <a:xfrm xmlns:a="http://schemas.openxmlformats.org/drawingml/2006/main">
+            <a:off x="6229350" y="2095500"/>
+            <a:ext cx="2114550" cy="476250"/>
+          </a:xfrm>
+          <a:prstGeom xmlns:a="http://schemas.openxmlformats.org/drawingml/2006/main" prst="rect">
+            <a:avLst/>
+          </a:prstGeom>
+          <a:noFill xmlns:a="http://schemas.openxmlformats.org/drawingml/2006/main"/>
+          <a:ln xmlns:a="http://schemas.openxmlformats.org/drawingml/2006/main" w="0">
+            <a:noFill/>
+            <a:prstDash val="solid"/>
+          </a:ln>
+        </p:spPr>
+        <p:txBody>
+          <a:bodyPr xmlns:a="http://schemas.openxmlformats.org/drawingml/2006/main" anchor="t"/>
+          <a:lstStyle xmlns:a="http://schemas.openxmlformats.org/drawingml/2006/main"/>
+          <a:p xmlns:a="http://schemas.openxmlformats.org/drawingml/2006/main">
+            <a:pPr algn="l">
+              <a:defRPr sz="900" b="0">
+                <a:solidFill>
+                  <a:srgbClr val="596575"/>
+                </a:solidFill>
+                <a:latin typeface="Aptos"/>
+                <a:ea typeface="Aptos"/>
+                <a:cs typeface="Aptos"/>
+              </a:defRPr>
+            </a:pPr>
+            <a:r>
+              <a:rPr sz="900" b="0">
+                <a:solidFill>
+                  <a:srgbClr val="596575"/>
+                </a:solidFill>
+                <a:latin typeface="Aptos"/>
+                <a:ea typeface="Aptos"/>
+                <a:cs typeface="Aptos"/>
+              </a:rPr>
+              <a:t>raw-opcode Transformer macro-F1; below 0.128 baseline</a:t>
+            </a:r>
+          </a:p>
+        </p:txBody>
+      </p:sp>
+      <p:sp>
+        <p:nvSpPr>
+          <p:cNvPr id="14" name="">
+            <a:extLst xmlns:a="http://schemas.openxmlformats.org/drawingml/2006/main">
+              <a:ext uri="{FF2B5EF4-FFF2-40B4-BE49-F238E27FC236}">
+                <a16:creationId xmlns:a16="http://schemas.microsoft.com/office/drawing/2014/main" id="{9211FEB9-340F-4404-8D09-D57C3A7715D7}"/>
+              </a:ext>
+            </a:extLst>
+          </p:cNvPr>
+          <p:cNvSpPr>
+            <a:spLocks xmlns:a="http://schemas.openxmlformats.org/drawingml/2006/main" noGrp="1"/>
+          </p:cNvSpPr>
+          <p:nvPr/>
+        </p:nvSpPr>
+        <p:spPr>
+          <a:xfrm xmlns:a="http://schemas.openxmlformats.org/drawingml/2006/main">
+            <a:off x="8782050" y="1581150"/>
+            <a:ext cx="2381250" cy="1066800"/>
+          </a:xfrm>
+          <a:prstGeom xmlns:a="http://schemas.openxmlformats.org/drawingml/2006/main" prst="rect">
+            <a:avLst/>
+          </a:prstGeom>
+          <a:solidFill xmlns:a="http://schemas.openxmlformats.org/drawingml/2006/main">
+            <a:srgbClr val="FFFFFF"/>
+          </a:solidFill>
+          <a:ln xmlns:a="http://schemas.openxmlformats.org/drawingml/2006/main" w="9525">
+            <a:solidFill>
+              <a:srgbClr val="D89A2B"/>
+            </a:solidFill>
+            <a:prstDash val="solid"/>
+          </a:ln>
+        </p:spPr>
+      </p:sp>
+      <p:sp>
+        <p:nvSpPr>
+          <p:cNvPr id="15" name="">
+            <a:extLst xmlns:a="http://schemas.openxmlformats.org/drawingml/2006/main">
+              <a:ext uri="{FF2B5EF4-FFF2-40B4-BE49-F238E27FC236}">
+                <a16:creationId xmlns:a16="http://schemas.microsoft.com/office/drawing/2014/main" id="{F84605C3-58D5-4BDC-8C07-AC78352454B9}"/>
+              </a:ext>
+            </a:extLst>
+          </p:cNvPr>
+          <p:cNvSpPr>
+            <a:spLocks xmlns:a="http://schemas.openxmlformats.org/drawingml/2006/main" noGrp="1"/>
+          </p:cNvSpPr>
+          <p:nvPr/>
+        </p:nvSpPr>
+        <p:spPr>
+          <a:xfrm xmlns:a="http://schemas.openxmlformats.org/drawingml/2006/main">
+            <a:off x="8915400" y="1714500"/>
+            <a:ext cx="2114550" cy="342900"/>
+          </a:xfrm>
+          <a:prstGeom xmlns:a="http://schemas.openxmlformats.org/drawingml/2006/main" prst="rect">
+            <a:avLst/>
+          </a:prstGeom>
+          <a:noFill xmlns:a="http://schemas.openxmlformats.org/drawingml/2006/main"/>
+          <a:ln xmlns:a="http://schemas.openxmlformats.org/drawingml/2006/main" w="0">
+            <a:noFill/>
+            <a:prstDash val="solid"/>
+          </a:ln>
+        </p:spPr>
+        <p:txBody>
+          <a:bodyPr xmlns:a="http://schemas.openxmlformats.org/drawingml/2006/main" anchor="t"/>
+          <a:lstStyle xmlns:a="http://schemas.openxmlformats.org/drawingml/2006/main"/>
+          <a:p xmlns:a="http://schemas.openxmlformats.org/drawingml/2006/main">
+            <a:pPr algn="l">
+              <a:defRPr sz="2100" b="1">
+                <a:solidFill>
+                  <a:srgbClr val="D89A2B"/>
+                </a:solidFill>
+                <a:latin typeface="Aptos"/>
+                <a:ea typeface="Aptos"/>
+                <a:cs typeface="Aptos"/>
+              </a:defRPr>
+            </a:pPr>
+            <a:r>
+              <a:rPr sz="2100" b="1">
+                <a:solidFill>
+                  <a:srgbClr val="D89A2B"/>
+                </a:solidFill>
+                <a:latin typeface="Aptos"/>
+                <a:ea typeface="Aptos"/>
+                <a:cs typeface="Aptos"/>
+              </a:rPr>
+              <a:t>31,589</a:t>
+            </a:r>
+          </a:p>
+        </p:txBody>
+      </p:sp>
+      <p:sp>
+        <p:nvSpPr>
+          <p:cNvPr id="16" name="">
+            <a:extLst xmlns:a="http://schemas.openxmlformats.org/drawingml/2006/main">
+              <a:ext uri="{FF2B5EF4-FFF2-40B4-BE49-F238E27FC236}">
+                <a16:creationId xmlns:a16="http://schemas.microsoft.com/office/drawing/2014/main" id="{2C2C56F6-939E-4B4A-96C3-4A60D92803E0}"/>
+              </a:ext>
+            </a:extLst>
+          </p:cNvPr>
+          <p:cNvSpPr>
+            <a:spLocks xmlns:a="http://schemas.openxmlformats.org/drawingml/2006/main" noGrp="1"/>
+          </p:cNvSpPr>
+          <p:nvPr/>
+        </p:nvSpPr>
+        <p:spPr>
+          <a:xfrm xmlns:a="http://schemas.openxmlformats.org/drawingml/2006/main">
+            <a:off x="8915400" y="2095500"/>
+            <a:ext cx="2114550" cy="476250"/>
+          </a:xfrm>
+          <a:prstGeom xmlns:a="http://schemas.openxmlformats.org/drawingml/2006/main" prst="rect">
+            <a:avLst/>
+          </a:prstGeom>
+          <a:noFill xmlns:a="http://schemas.openxmlformats.org/drawingml/2006/main"/>
+          <a:ln xmlns:a="http://schemas.openxmlformats.org/drawingml/2006/main" w="0">
+            <a:noFill/>
+            <a:prstDash val="solid"/>
+          </a:ln>
+        </p:spPr>
+        <p:txBody>
+          <a:bodyPr xmlns:a="http://schemas.openxmlformats.org/drawingml/2006/main" anchor="t"/>
+          <a:lstStyle xmlns:a="http://schemas.openxmlformats.org/drawingml/2006/main"/>
+          <a:p xmlns:a="http://schemas.openxmlformats.org/drawingml/2006/main">
+            <a:pPr algn="l">
+              <a:defRPr sz="900" b="0">
+                <a:solidFill>
+                  <a:srgbClr val="596575"/>
+                </a:solidFill>
+                <a:latin typeface="Aptos"/>
+                <a:ea typeface="Aptos"/>
+                <a:cs typeface="Aptos"/>
+              </a:defRPr>
+            </a:pPr>
+            <a:r>
+              <a:rPr sz="900" b="0">
+                <a:solidFill>
+                  <a:srgbClr val="596575"/>
+                </a:solidFill>
+                <a:latin typeface="Aptos"/>
+                <a:ea typeface="Aptos"/>
+                <a:cs typeface="Aptos"/>
+              </a:rPr>
+              <a:t>largest local AI/R8 evidence package rows</a:t>
+            </a:r>
+          </a:p>
+        </p:txBody>
+      </p:sp>
+      <p:sp>
+        <p:nvSpPr>
+          <p:cNvPr id="17" name="">
+            <a:extLst xmlns:a="http://schemas.openxmlformats.org/drawingml/2006/main">
+              <a:ext uri="{FF2B5EF4-FFF2-40B4-BE49-F238E27FC236}">
+                <a16:creationId xmlns:a16="http://schemas.microsoft.com/office/drawing/2014/main" id="{87C4FD38-A281-430D-B602-996A0F8B6042}"/>
+              </a:ext>
+            </a:extLst>
+          </p:cNvPr>
+          <p:cNvSpPr>
+            <a:spLocks xmlns:a="http://schemas.openxmlformats.org/drawingml/2006/main" noGrp="1"/>
+          </p:cNvSpPr>
+          <p:nvPr/>
+        </p:nvSpPr>
+        <p:spPr>
+          <a:xfrm xmlns:a="http://schemas.openxmlformats.org/drawingml/2006/main">
+            <a:off x="723900" y="3086100"/>
+            <a:ext cx="4857750" cy="1981200"/>
+          </a:xfrm>
+          <a:prstGeom xmlns:a="http://schemas.openxmlformats.org/drawingml/2006/main" prst="rect">
+            <a:avLst/>
+          </a:prstGeom>
+          <a:solidFill xmlns:a="http://schemas.openxmlformats.org/drawingml/2006/main">
+            <a:srgbClr val="FFFFFF"/>
+          </a:solidFill>
+          <a:ln xmlns:a="http://schemas.openxmlformats.org/drawingml/2006/main" w="9525">
+            <a:solidFill>
+              <a:srgbClr val="367C59"/>
+            </a:solidFill>
+            <a:prstDash val="solid"/>
+          </a:ln>
+        </p:spPr>
+      </p:sp>
+      <p:sp>
+        <p:nvSpPr>
+          <p:cNvPr id="18" name="">
+            <a:extLst xmlns:a="http://schemas.openxmlformats.org/drawingml/2006/main">
+              <a:ext uri="{FF2B5EF4-FFF2-40B4-BE49-F238E27FC236}">
+                <a16:creationId xmlns:a16="http://schemas.microsoft.com/office/drawing/2014/main" id="{10226223-9A9F-4C8B-B7B3-D138E8A4539A}"/>
+              </a:ext>
+            </a:extLst>
+          </p:cNvPr>
+          <p:cNvSpPr>
+            <a:spLocks xmlns:a="http://schemas.openxmlformats.org/drawingml/2006/main" noGrp="1"/>
+          </p:cNvSpPr>
+          <p:nvPr/>
+        </p:nvSpPr>
+        <p:spPr>
+          <a:xfrm xmlns:a="http://schemas.openxmlformats.org/drawingml/2006/main">
+            <a:off x="971550" y="3333750"/>
+            <a:ext cx="2476500" cy="285750"/>
+          </a:xfrm>
+          <a:prstGeom xmlns:a="http://schemas.openxmlformats.org/drawingml/2006/main" prst="rect">
+            <a:avLst/>
+          </a:prstGeom>
+          <a:noFill xmlns:a="http://schemas.openxmlformats.org/drawingml/2006/main"/>
+          <a:ln xmlns:a="http://schemas.openxmlformats.org/drawingml/2006/main" w="0">
+            <a:noFill/>
+            <a:prstDash val="solid"/>
+          </a:ln>
+        </p:spPr>
+        <p:txBody>
+          <a:bodyPr xmlns:a="http://schemas.openxmlformats.org/drawingml/2006/main" anchor="t"/>
+          <a:lstStyle xmlns:a="http://schemas.openxmlformats.org/drawingml/2006/main"/>
+          <a:p xmlns:a="http://schemas.openxmlformats.org/drawingml/2006/main">
+            <a:pPr algn="l">
+              <a:defRPr sz="1650" b="1">
+                <a:solidFill>
+                  <a:srgbClr val="367C59"/>
+                </a:solidFill>
+                <a:latin typeface="Aptos"/>
+                <a:ea typeface="Aptos"/>
+                <a:cs typeface="Aptos"/>
+              </a:defRPr>
+            </a:pPr>
+            <a:r>
+              <a:rPr sz="1650" b="1">
+                <a:solidFill>
+                  <a:srgbClr val="367C59"/>
+                </a:solidFill>
+                <a:latin typeface="Aptos"/>
+                <a:ea typeface="Aptos"/>
+                <a:cs typeface="Aptos"/>
+              </a:rPr>
+              <a:t>Ready in the MVP</a:t>
+            </a:r>
+          </a:p>
+        </p:txBody>
+      </p:sp>
+      <p:sp>
+        <p:nvSpPr>
+          <p:cNvPr id="19" name="">
+            <a:extLst xmlns:a="http://schemas.openxmlformats.org/drawingml/2006/main">
+              <a:ext uri="{FF2B5EF4-FFF2-40B4-BE49-F238E27FC236}">
+                <a16:creationId xmlns:a16="http://schemas.microsoft.com/office/drawing/2014/main" id="{E890875C-40A1-43B8-8FE8-BB6E2668B020}"/>
+              </a:ext>
+            </a:extLst>
+          </p:cNvPr>
+          <p:cNvSpPr>
+            <a:spLocks xmlns:a="http://schemas.openxmlformats.org/drawingml/2006/main" noGrp="1"/>
+          </p:cNvSpPr>
+          <p:nvPr/>
+        </p:nvSpPr>
+        <p:spPr>
+          <a:xfrm xmlns:a="http://schemas.openxmlformats.org/drawingml/2006/main">
+            <a:off x="971550" y="3810000"/>
+            <a:ext cx="4000500" cy="1047750"/>
+          </a:xfrm>
+          <a:prstGeom xmlns:a="http://schemas.openxmlformats.org/drawingml/2006/main" prst="rect">
+            <a:avLst/>
+          </a:prstGeom>
+          <a:noFill xmlns:a="http://schemas.openxmlformats.org/drawingml/2006/main"/>
+          <a:ln xmlns:a="http://schemas.openxmlformats.org/drawingml/2006/main" w="0">
+            <a:noFill/>
+            <a:prstDash val="solid"/>
+          </a:ln>
+        </p:spPr>
+        <p:txBody>
+          <a:bodyPr xmlns:a="http://schemas.openxmlformats.org/drawingml/2006/main" anchor="t"/>
+          <a:lstStyle xmlns:a="http://schemas.openxmlformats.org/drawingml/2006/main"/>
+          <a:p xmlns:a="http://schemas.openxmlformats.org/drawingml/2006/main">
+            <a:pPr algn="l">
+              <a:defRPr sz="1050" b="0">
+                <a:solidFill>
+                  <a:srgbClr val="151922"/>
+                </a:solidFill>
+                <a:latin typeface="Aptos"/>
+                <a:ea typeface="Aptos"/>
+                <a:cs typeface="Aptos"/>
+              </a:defRPr>
+            </a:pPr>
+            <a:r>
+              <a:rPr sz="1050" b="0">
+                <a:solidFill>
+                  <a:srgbClr val="151922"/>
+                </a:solidFill>
+                <a:latin typeface="Aptos"/>
+                <a:ea typeface="Aptos"/>
+                <a:cs typeface="Aptos"/>
+              </a:rPr>
+              <a:t>- report-only R8 and matcher-recall suggestions</a:t>
+            </a:r>
+          </a:p>
+          <a:p xmlns:a="http://schemas.openxmlformats.org/drawingml/2006/main">
+            <a:pPr algn="l">
+              <a:defRPr sz="1050" b="0">
+                <a:solidFill>
+                  <a:srgbClr val="151922"/>
+                </a:solidFill>
+                <a:latin typeface="Aptos"/>
+                <a:ea typeface="Aptos"/>
+                <a:cs typeface="Aptos"/>
+              </a:defRPr>
+            </a:pPr>
+            <a:r>
+              <a:rPr sz="1050" b="0">
+                <a:solidFill>
+                  <a:srgbClr val="151922"/>
+                </a:solidFill>
+                <a:latin typeface="Aptos"/>
+                <a:ea typeface="Aptos"/>
+                <a:cs typeface="Aptos"/>
+              </a:rPr>
+              <a:t>- hybrid router and model status in JSON/HTML/Markdown</a:t>
+            </a:r>
+          </a:p>
+          <a:p xmlns:a="http://schemas.openxmlformats.org/drawingml/2006/main">
+            <a:pPr algn="l">
+              <a:defRPr sz="1050" b="0">
+                <a:solidFill>
+                  <a:srgbClr val="151922"/>
+                </a:solidFill>
+                <a:latin typeface="Aptos"/>
+                <a:ea typeface="Aptos"/>
+                <a:cs typeface="Aptos"/>
+              </a:defRPr>
+            </a:pPr>
+            <a:r>
+              <a:rPr sz="1050" b="0">
+                <a:solidFill>
+                  <a:srgbClr val="151922"/>
+                </a:solidFill>
+                <a:latin typeface="Aptos"/>
+                <a:ea typeface="Aptos"/>
+                <a:cs typeface="Aptos"/>
+              </a:rPr>
+              <a:t>- clean and hard APK smoke outputs unchanged</a:t>
+            </a:r>
+          </a:p>
+          <a:p xmlns:a="http://schemas.openxmlformats.org/drawingml/2006/main">
+            <a:pPr algn="l">
+              <a:defRPr sz="1050" b="0">
+                <a:solidFill>
+                  <a:srgbClr val="151922"/>
+                </a:solidFill>
+                <a:latin typeface="Aptos"/>
+                <a:ea typeface="Aptos"/>
+                <a:cs typeface="Aptos"/>
+              </a:defRPr>
+            </a:pPr>
+            <a:r>
+              <a:rPr sz="1050" b="0">
+                <a:solidFill>
+                  <a:srgbClr val="151922"/>
+                </a:solidFill>
+                <a:latin typeface="Aptos"/>
+                <a:ea typeface="Aptos"/>
+                <a:cs typeface="Aptos"/>
+              </a:rPr>
+              <a:t>- risk triage without changing CVE labels</a:t>
+            </a:r>
+          </a:p>
+        </p:txBody>
+      </p:sp>
+      <p:sp>
+        <p:nvSpPr>
+          <p:cNvPr id="20" name="">
+            <a:extLst xmlns:a="http://schemas.openxmlformats.org/drawingml/2006/main">
+              <a:ext uri="{FF2B5EF4-FFF2-40B4-BE49-F238E27FC236}">
+                <a16:creationId xmlns:a16="http://schemas.microsoft.com/office/drawing/2014/main" id="{47EB3782-C61E-4587-8F43-E41159CF9774}"/>
+              </a:ext>
+            </a:extLst>
+          </p:cNvPr>
+          <p:cNvSpPr>
+            <a:spLocks xmlns:a="http://schemas.openxmlformats.org/drawingml/2006/main" noGrp="1"/>
+          </p:cNvSpPr>
+          <p:nvPr/>
+        </p:nvSpPr>
+        <p:spPr>
+          <a:xfrm xmlns:a="http://schemas.openxmlformats.org/drawingml/2006/main">
+            <a:off x="6038850" y="3086100"/>
+            <a:ext cx="5124450" cy="1981200"/>
+          </a:xfrm>
+          <a:prstGeom xmlns:a="http://schemas.openxmlformats.org/drawingml/2006/main" prst="rect">
+            <a:avLst/>
+          </a:prstGeom>
+          <a:solidFill xmlns:a="http://schemas.openxmlformats.org/drawingml/2006/main">
+            <a:srgbClr val="FFFFFF"/>
+          </a:solidFill>
+          <a:ln xmlns:a="http://schemas.openxmlformats.org/drawingml/2006/main" w="9525">
+            <a:solidFill>
+              <a:srgbClr val="C34E5A"/>
+            </a:solidFill>
+            <a:prstDash val="solid"/>
+          </a:ln>
+        </p:spPr>
+      </p:sp>
+      <p:sp>
+        <p:nvSpPr>
+          <p:cNvPr id="21" name="">
+            <a:extLst xmlns:a="http://schemas.openxmlformats.org/drawingml/2006/main">
+              <a:ext uri="{FF2B5EF4-FFF2-40B4-BE49-F238E27FC236}">
+                <a16:creationId xmlns:a16="http://schemas.microsoft.com/office/drawing/2014/main" id="{CB2A61E0-C1D4-4B78-AF76-B6ACC9300C46}"/>
+              </a:ext>
+            </a:extLst>
+          </p:cNvPr>
+          <p:cNvSpPr>
+            <a:spLocks xmlns:a="http://schemas.openxmlformats.org/drawingml/2006/main" noGrp="1"/>
+          </p:cNvSpPr>
+          <p:nvPr/>
+        </p:nvSpPr>
+        <p:spPr>
+          <a:xfrm xmlns:a="http://schemas.openxmlformats.org/drawingml/2006/main">
+            <a:off x="6286500" y="3333750"/>
+            <a:ext cx="2667000" cy="285750"/>
+          </a:xfrm>
+          <a:prstGeom xmlns:a="http://schemas.openxmlformats.org/drawingml/2006/main" prst="rect">
+            <a:avLst/>
+          </a:prstGeom>
+          <a:noFill xmlns:a="http://schemas.openxmlformats.org/drawingml/2006/main"/>
+          <a:ln xmlns:a="http://schemas.openxmlformats.org/drawingml/2006/main" w="0">
+            <a:noFill/>
+            <a:prstDash val="solid"/>
+          </a:ln>
+        </p:spPr>
+        <p:txBody>
+          <a:bodyPr xmlns:a="http://schemas.openxmlformats.org/drawingml/2006/main" anchor="t"/>
+          <a:lstStyle xmlns:a="http://schemas.openxmlformats.org/drawingml/2006/main"/>
+          <a:p xmlns:a="http://schemas.openxmlformats.org/drawingml/2006/main">
+            <a:pPr algn="l">
+              <a:defRPr sz="1650" b="1">
+                <a:solidFill>
+                  <a:srgbClr val="C34E5A"/>
+                </a:solidFill>
+                <a:latin typeface="Aptos"/>
+                <a:ea typeface="Aptos"/>
+                <a:cs typeface="Aptos"/>
+              </a:defRPr>
+            </a:pPr>
+            <a:r>
+              <a:rPr sz="1650" b="1">
+                <a:solidFill>
+                  <a:srgbClr val="C34E5A"/>
+                </a:solidFill>
+                <a:latin typeface="Aptos"/>
+                <a:ea typeface="Aptos"/>
+                <a:cs typeface="Aptos"/>
+              </a:rPr>
+              <a:t>Deliberately blocked</a:t>
+            </a:r>
+          </a:p>
+        </p:txBody>
+      </p:sp>
+      <p:sp>
+        <p:nvSpPr>
+          <p:cNvPr id="22" name="">
+            <a:extLst xmlns:a="http://schemas.openxmlformats.org/drawingml/2006/main">
+              <a:ext uri="{FF2B5EF4-FFF2-40B4-BE49-F238E27FC236}">
+                <a16:creationId xmlns:a16="http://schemas.microsoft.com/office/drawing/2014/main" id="{F4D7EB21-8DAC-4EFA-A972-3B7704F15370}"/>
+              </a:ext>
+            </a:extLst>
+          </p:cNvPr>
+          <p:cNvSpPr>
+            <a:spLocks xmlns:a="http://schemas.openxmlformats.org/drawingml/2006/main" noGrp="1"/>
+          </p:cNvSpPr>
+          <p:nvPr/>
+        </p:nvSpPr>
+        <p:spPr>
+          <a:xfrm xmlns:a="http://schemas.openxmlformats.org/drawingml/2006/main">
+            <a:off x="6286500" y="3810000"/>
+            <a:ext cx="4095750" cy="1047750"/>
+          </a:xfrm>
+          <a:prstGeom xmlns:a="http://schemas.openxmlformats.org/drawingml/2006/main" prst="rect">
+            <a:avLst/>
+          </a:prstGeom>
+          <a:noFill xmlns:a="http://schemas.openxmlformats.org/drawingml/2006/main"/>
+          <a:ln xmlns:a="http://schemas.openxmlformats.org/drawingml/2006/main" w="0">
+            <a:noFill/>
+            <a:prstDash val="solid"/>
+          </a:ln>
+        </p:spPr>
+        <p:txBody>
+          <a:bodyPr xmlns:a="http://schemas.openxmlformats.org/drawingml/2006/main" anchor="t"/>
+          <a:lstStyle xmlns:a="http://schemas.openxmlformats.org/drawingml/2006/main"/>
+          <a:p xmlns:a="http://schemas.openxmlformats.org/drawingml/2006/main">
+            <a:pPr algn="l">
+              <a:defRPr sz="1050" b="0">
+                <a:solidFill>
+                  <a:srgbClr val="151922"/>
+                </a:solidFill>
+                <a:latin typeface="Aptos"/>
+                <a:ea typeface="Aptos"/>
+                <a:cs typeface="Aptos"/>
+              </a:defRPr>
+            </a:pPr>
+            <a:r>
+              <a:rPr sz="1050" b="0">
+                <a:solidFill>
+                  <a:srgbClr val="151922"/>
+                </a:solidFill>
+                <a:latin typeface="Aptos"/>
+                <a:ea typeface="Aptos"/>
+                <a:cs typeface="Aptos"/>
+              </a:rPr>
+              <a:t>- AI-selected exact Maven versions</a:t>
+            </a:r>
+          </a:p>
+          <a:p xmlns:a="http://schemas.openxmlformats.org/drawingml/2006/main">
+            <a:pPr algn="l">
+              <a:defRPr sz="1050" b="0">
+                <a:solidFill>
+                  <a:srgbClr val="151922"/>
+                </a:solidFill>
+                <a:latin typeface="Aptos"/>
+                <a:ea typeface="Aptos"/>
+                <a:cs typeface="Aptos"/>
+              </a:defRPr>
+            </a:pPr>
+            <a:r>
+              <a:rPr sz="1050" b="0">
+                <a:solidFill>
+                  <a:srgbClr val="151922"/>
+                </a:solidFill>
+                <a:latin typeface="Aptos"/>
+                <a:ea typeface="Aptos"/>
+                <a:cs typeface="Aptos"/>
+              </a:rPr>
+              <a:t>- AI changes to CycloneDX components</a:t>
+            </a:r>
+          </a:p>
+          <a:p xmlns:a="http://schemas.openxmlformats.org/drawingml/2006/main">
+            <a:pPr algn="l">
+              <a:defRPr sz="1050" b="0">
+                <a:solidFill>
+                  <a:srgbClr val="151922"/>
+                </a:solidFill>
+                <a:latin typeface="Aptos"/>
+                <a:ea typeface="Aptos"/>
+                <a:cs typeface="Aptos"/>
+              </a:defRPr>
+            </a:pPr>
+            <a:r>
+              <a:rPr sz="1050" b="0">
+                <a:solidFill>
+                  <a:srgbClr val="151922"/>
+                </a:solidFill>
+                <a:latin typeface="Aptos"/>
+                <a:ea typeface="Aptos"/>
+                <a:cs typeface="Aptos"/>
+              </a:rPr>
+              <a:t>- AI-confirmed vulnerability labels</a:t>
+            </a:r>
+          </a:p>
+          <a:p xmlns:a="http://schemas.openxmlformats.org/drawingml/2006/main">
+            <a:pPr algn="l">
+              <a:defRPr sz="1050" b="0">
+                <a:solidFill>
+                  <a:srgbClr val="151922"/>
+                </a:solidFill>
+                <a:latin typeface="Aptos"/>
+                <a:ea typeface="Aptos"/>
+                <a:cs typeface="Aptos"/>
+              </a:defRPr>
+            </a:pPr>
+            <a:r>
+              <a:rPr sz="1050" b="0">
+                <a:solidFill>
+                  <a:srgbClr val="151922"/>
+                </a:solidFill>
+                <a:latin typeface="Aptos"/>
+                <a:ea typeface="Aptos"/>
+                <a:cs typeface="Aptos"/>
+              </a:rPr>
+              <a:t>- raw-opcode production authority</a:t>
+            </a:r>
+          </a:p>
+        </p:txBody>
+      </p:sp>
+      <p:sp>
+        <p:nvSpPr>
+          <p:cNvPr id="23" name="">
+            <a:extLst xmlns:a="http://schemas.openxmlformats.org/drawingml/2006/main">
+              <a:ext uri="{FF2B5EF4-FFF2-40B4-BE49-F238E27FC236}">
+                <a16:creationId xmlns:a16="http://schemas.microsoft.com/office/drawing/2014/main" id="{F5BB33FB-DDFC-4BAD-B1E4-6B64237BFCD3}"/>
+              </a:ext>
+            </a:extLst>
+          </p:cNvPr>
+          <p:cNvSpPr>
+            <a:spLocks xmlns:a="http://schemas.openxmlformats.org/drawingml/2006/main" noGrp="1"/>
+          </p:cNvSpPr>
+          <p:nvPr/>
+        </p:nvSpPr>
+        <p:spPr>
+          <a:xfrm xmlns:a="http://schemas.openxmlformats.org/drawingml/2006/main">
+            <a:off x="1066800" y="5467350"/>
+            <a:ext cx="10058400" cy="457200"/>
+          </a:xfrm>
+          <a:prstGeom xmlns:a="http://schemas.openxmlformats.org/drawingml/2006/main" prst="rect">
+            <a:avLst/>
+          </a:prstGeom>
+          <a:noFill xmlns:a="http://schemas.openxmlformats.org/drawingml/2006/main"/>
+          <a:ln xmlns:a="http://schemas.openxmlformats.org/drawingml/2006/main" w="0">
+            <a:noFill/>
+            <a:prstDash val="solid"/>
+          </a:ln>
+        </p:spPr>
+        <p:txBody>
+          <a:bodyPr xmlns:a="http://schemas.openxmlformats.org/drawingml/2006/main" anchor="t"/>
+          <a:lstStyle xmlns:a="http://schemas.openxmlformats.org/drawingml/2006/main"/>
+          <a:p xmlns:a="http://schemas.openxmlformats.org/drawingml/2006/main">
+            <a:pPr algn="ctr">
+              <a:defRPr sz="1350" b="1">
+                <a:solidFill>
+                  <a:srgbClr val="151922"/>
+                </a:solidFill>
+                <a:latin typeface="Aptos"/>
+                <a:ea typeface="Aptos"/>
+                <a:cs typeface="Aptos"/>
+              </a:defRPr>
+            </a:pPr>
+            <a:r>
+              <a:rPr sz="1350" b="1">
+                <a:solidFill>
+                  <a:srgbClr val="151922"/>
+                </a:solidFill>
+                <a:latin typeface="Aptos"/>
+                <a:ea typeface="Aptos"/>
+                <a:cs typeface="Aptos"/>
+              </a:rPr>
+              <a:t>Promotion verdict: report-only ready; matcher/SBOM authority not ready because strict APK controls yield 0 eligible candidates.</a:t>
+            </a:r>
+          </a:p>
+        </p:txBody>
+      </p:sp>
+      <p:sp>
+        <p:nvSpPr>
+          <p:cNvPr id="24" name="">
+            <a:extLst xmlns:a="http://schemas.openxmlformats.org/drawingml/2006/main">
+              <a:ext uri="{FF2B5EF4-FFF2-40B4-BE49-F238E27FC236}">
+                <a16:creationId xmlns:a16="http://schemas.microsoft.com/office/drawing/2014/main" id="{DDED1910-06DC-4F98-A5D9-0DFA5289E8F4}"/>
+              </a:ext>
+            </a:extLst>
+          </p:cNvPr>
+          <p:cNvSpPr>
+            <a:spLocks xmlns:a="http://schemas.openxmlformats.org/drawingml/2006/main" noGrp="1"/>
+          </p:cNvSpPr>
+          <p:nvPr/>
+        </p:nvSpPr>
+        <p:spPr>
+          <a:xfrm xmlns:a="http://schemas.openxmlformats.org/drawingml/2006/main">
+            <a:off x="533400" y="6477000"/>
+            <a:ext cx="9525000" cy="190500"/>
+          </a:xfrm>
+          <a:prstGeom xmlns:a="http://schemas.openxmlformats.org/drawingml/2006/main" prst="rect">
+            <a:avLst/>
+          </a:prstGeom>
+          <a:noFill xmlns:a="http://schemas.openxmlformats.org/drawingml/2006/main"/>
+          <a:ln xmlns:a="http://schemas.openxmlformats.org/drawingml/2006/main" w="0">
+            <a:noFill/>
+            <a:prstDash val="solid"/>
+          </a:ln>
+        </p:spPr>
+        <p:txBody>
+          <a:bodyPr xmlns:a="http://schemas.openxmlformats.org/drawingml/2006/main" anchor="t"/>
+          <a:lstStyle xmlns:a="http://schemas.openxmlformats.org/drawingml/2006/main"/>
+          <a:p xmlns:a="http://schemas.openxmlformats.org/drawingml/2006/main">
+            <a:pPr algn="l">
+              <a:defRPr sz="750" b="0">
+                <a:solidFill>
+                  <a:srgbClr val="596575"/>
+                </a:solidFill>
+                <a:latin typeface="Aptos"/>
+                <a:ea typeface="Aptos"/>
+                <a:cs typeface="Aptos"/>
+              </a:defRPr>
+            </a:pPr>
+            <a:r>
+              <a:rPr sz="750" b="0">
+                <a:solidFill>
+                  <a:srgbClr val="596575"/>
+                </a:solidFill>
+                <a:latin typeface="Aptos"/>
+                <a:ea typeface="Aptos"/>
+                <a:cs typeface="Aptos"/>
+              </a:rPr>
+              <a:t>APK-to-SBOM MVP | emitted confirmation != full recall; v2 source-known lane != APK-only accuracy</a:t>
+            </a:r>
+          </a:p>
+        </p:txBody>
+      </p:sp>
+    </p:spTree>
+    <p:extLst>
+      <p:ext uri="{BB962C8B-B14F-4D97-AF65-F5344CB8AC3E}">
+        <p14:creationId xmlns:p14="http://schemas.microsoft.com/office/powerpoint/2010/main" val="16991803"/>
       </p:ext>
     </p:extLst>
   </p:cSld>
@@ -6631,7 +8050,7 @@
           <p:cNvPr id="1" name="">
             <a:extLst xmlns:a="http://schemas.openxmlformats.org/drawingml/2006/main">
               <a:ext uri="{FF2B5EF4-FFF2-40B4-BE49-F238E27FC236}">
-                <a16:creationId xmlns:a16="http://schemas.microsoft.com/office/drawing/2014/main" id="{642D7090-1786-4782-96B8-3BA18A934613}"/>
+                <a16:creationId xmlns:a16="http://schemas.microsoft.com/office/drawing/2014/main" id="{82549264-6483-419F-BE67-5D1240A1A74D}"/>
               </a:ext>
             </a:extLst>
           </p:cNvPr>
@@ -6687,7 +8106,7 @@
           <p:cNvPr id="2" name="">
             <a:extLst xmlns:a="http://schemas.openxmlformats.org/drawingml/2006/main">
               <a:ext uri="{FF2B5EF4-FFF2-40B4-BE49-F238E27FC236}">
-                <a16:creationId xmlns:a16="http://schemas.microsoft.com/office/drawing/2014/main" id="{C0082E3F-B253-4C0A-AC63-B02DDBBED5B8}"/>
+                <a16:creationId xmlns:a16="http://schemas.microsoft.com/office/drawing/2014/main" id="{B444B499-A002-4730-9587-00E1D8D4FC9F}"/>
               </a:ext>
             </a:extLst>
           </p:cNvPr>
@@ -6743,7 +8162,7 @@
           <p:cNvPr id="3" name="">
             <a:extLst xmlns:a="http://schemas.openxmlformats.org/drawingml/2006/main">
               <a:ext uri="{FF2B5EF4-FFF2-40B4-BE49-F238E27FC236}">
-                <a16:creationId xmlns:a16="http://schemas.microsoft.com/office/drawing/2014/main" id="{FAF9685E-705D-4EB4-814B-00E6043E09EA}"/>
+                <a16:creationId xmlns:a16="http://schemas.microsoft.com/office/drawing/2014/main" id="{571A2FE8-D9ED-4DCE-B090-39725F5A6781}"/>
               </a:ext>
             </a:extLst>
           </p:cNvPr>
@@ -6799,7 +8218,7 @@
           <p:cNvPr id="4" name="rule">
             <a:extLst xmlns:a="http://schemas.openxmlformats.org/drawingml/2006/main">
               <a:ext uri="{FF2B5EF4-FFF2-40B4-BE49-F238E27FC236}">
-                <a16:creationId xmlns:a16="http://schemas.microsoft.com/office/drawing/2014/main" id="{5E60CA4E-426B-4472-8350-E0825AC894FE}"/>
+                <a16:creationId xmlns:a16="http://schemas.microsoft.com/office/drawing/2014/main" id="{89BB6A14-090E-46A9-A379-60C251C102DD}"/>
               </a:ext>
             </a:extLst>
           </p:cNvPr>
@@ -6830,7 +8249,7 @@
           <p:cNvPr id="5" name="">
             <a:extLst xmlns:a="http://schemas.openxmlformats.org/drawingml/2006/main">
               <a:ext uri="{FF2B5EF4-FFF2-40B4-BE49-F238E27FC236}">
-                <a16:creationId xmlns:a16="http://schemas.microsoft.com/office/drawing/2014/main" id="{045883F7-ABA8-4C88-BBCD-BF92DC49DF75}"/>
+                <a16:creationId xmlns:a16="http://schemas.microsoft.com/office/drawing/2014/main" id="{16503539-0C25-41D8-A0E3-6C42BE225FD7}"/>
               </a:ext>
             </a:extLst>
           </p:cNvPr>
@@ -6863,7 +8282,7 @@
           <p:cNvPr id="6" name="">
             <a:extLst xmlns:a="http://schemas.openxmlformats.org/drawingml/2006/main">
               <a:ext uri="{FF2B5EF4-FFF2-40B4-BE49-F238E27FC236}">
-                <a16:creationId xmlns:a16="http://schemas.microsoft.com/office/drawing/2014/main" id="{49D8AE6A-279B-4AD6-A64B-39CC78B97C06}"/>
+                <a16:creationId xmlns:a16="http://schemas.microsoft.com/office/drawing/2014/main" id="{F4382322-D767-42FB-8FE9-1EB1D4736558}"/>
               </a:ext>
             </a:extLst>
           </p:cNvPr>
@@ -6896,7 +8315,7 @@
           <p:cNvPr id="7" name="">
             <a:extLst xmlns:a="http://schemas.openxmlformats.org/drawingml/2006/main">
               <a:ext uri="{FF2B5EF4-FFF2-40B4-BE49-F238E27FC236}">
-                <a16:creationId xmlns:a16="http://schemas.microsoft.com/office/drawing/2014/main" id="{E1FEC855-0CAE-432B-AE3B-DA60361571ED}"/>
+                <a16:creationId xmlns:a16="http://schemas.microsoft.com/office/drawing/2014/main" id="{953DB3EB-58BC-4B2B-8669-FFAD3EB2E106}"/>
               </a:ext>
             </a:extLst>
           </p:cNvPr>
@@ -6952,7 +8371,7 @@
           <p:cNvPr id="8" name="">
             <a:extLst xmlns:a="http://schemas.openxmlformats.org/drawingml/2006/main">
               <a:ext uri="{FF2B5EF4-FFF2-40B4-BE49-F238E27FC236}">
-                <a16:creationId xmlns:a16="http://schemas.microsoft.com/office/drawing/2014/main" id="{885D23B5-33DD-4180-A138-EA006947B8AD}"/>
+                <a16:creationId xmlns:a16="http://schemas.microsoft.com/office/drawing/2014/main" id="{D8CA3838-4188-4BA9-87F1-64B5E8C066E2}"/>
               </a:ext>
             </a:extLst>
           </p:cNvPr>
@@ -7077,7 +8496,7 @@
           <p:cNvPr id="9" name="">
             <a:extLst xmlns:a="http://schemas.openxmlformats.org/drawingml/2006/main">
               <a:ext uri="{FF2B5EF4-FFF2-40B4-BE49-F238E27FC236}">
-                <a16:creationId xmlns:a16="http://schemas.microsoft.com/office/drawing/2014/main" id="{147EB4F3-D487-41D6-8DF2-123209D1E5DB}"/>
+                <a16:creationId xmlns:a16="http://schemas.microsoft.com/office/drawing/2014/main" id="{F6C33C0E-A585-40BC-948E-8ACF7F00F513}"/>
               </a:ext>
             </a:extLst>
           </p:cNvPr>
@@ -7133,7 +8552,7 @@
           <p:cNvPr id="10" name="">
             <a:extLst xmlns:a="http://schemas.openxmlformats.org/drawingml/2006/main">
               <a:ext uri="{FF2B5EF4-FFF2-40B4-BE49-F238E27FC236}">
-                <a16:creationId xmlns:a16="http://schemas.microsoft.com/office/drawing/2014/main" id="{353A7F0C-3B19-452F-9B2C-24D771028906}"/>
+                <a16:creationId xmlns:a16="http://schemas.microsoft.com/office/drawing/2014/main" id="{AA69227A-E181-4D70-8486-E938B599BF04}"/>
               </a:ext>
             </a:extLst>
           </p:cNvPr>
@@ -7258,7 +8677,7 @@
           <p:cNvPr id="11" name="">
             <a:extLst xmlns:a="http://schemas.openxmlformats.org/drawingml/2006/main">
               <a:ext uri="{FF2B5EF4-FFF2-40B4-BE49-F238E27FC236}">
-                <a16:creationId xmlns:a16="http://schemas.microsoft.com/office/drawing/2014/main" id="{F192B00C-069E-4B3E-AEDB-58B025334CF0}"/>
+                <a16:creationId xmlns:a16="http://schemas.microsoft.com/office/drawing/2014/main" id="{572C967D-5F66-4B41-A2BF-4C2FA5068E77}"/>
               </a:ext>
             </a:extLst>
           </p:cNvPr>
@@ -7314,7 +8733,7 @@
           <p:cNvPr id="12" name="">
             <a:extLst xmlns:a="http://schemas.openxmlformats.org/drawingml/2006/main">
               <a:ext uri="{FF2B5EF4-FFF2-40B4-BE49-F238E27FC236}">
-                <a16:creationId xmlns:a16="http://schemas.microsoft.com/office/drawing/2014/main" id="{6C20C2D3-4F0D-4D0C-82D0-BFD1EB7D6C39}"/>
+                <a16:creationId xmlns:a16="http://schemas.microsoft.com/office/drawing/2014/main" id="{8326AF86-DAB6-4A47-A6C9-A07FE8C1C76B}"/>
               </a:ext>
             </a:extLst>
           </p:cNvPr>
@@ -7370,7 +8789,7 @@
           <p:cNvPr id="13" name="">
             <a:extLst xmlns:a="http://schemas.openxmlformats.org/drawingml/2006/main">
               <a:ext uri="{FF2B5EF4-FFF2-40B4-BE49-F238E27FC236}">
-                <a16:creationId xmlns:a16="http://schemas.microsoft.com/office/drawing/2014/main" id="{C0EF970D-3E0D-4464-8320-240FD8F3AB5E}"/>
+                <a16:creationId xmlns:a16="http://schemas.microsoft.com/office/drawing/2014/main" id="{E7FAF034-2F41-41C3-AD7D-2C16EDD17316}"/>
               </a:ext>
             </a:extLst>
           </p:cNvPr>
@@ -7426,7 +8845,7 @@
           <p:cNvPr id="14" name="">
             <a:extLst xmlns:a="http://schemas.openxmlformats.org/drawingml/2006/main">
               <a:ext uri="{FF2B5EF4-FFF2-40B4-BE49-F238E27FC236}">
-                <a16:creationId xmlns:a16="http://schemas.microsoft.com/office/drawing/2014/main" id="{196661E8-2974-4256-ABC6-FD05AE6EC554}"/>
+                <a16:creationId xmlns:a16="http://schemas.microsoft.com/office/drawing/2014/main" id="{94CE3C50-6185-41FF-A0D0-B345E2D41B07}"/>
               </a:ext>
             </a:extLst>
           </p:cNvPr>
@@ -7480,7 +8899,7 @@
     </p:spTree>
     <p:extLst>
       <p:ext uri="{BB962C8B-B14F-4D97-AF65-F5344CB8AC3E}">
-        <p14:creationId xmlns:p14="http://schemas.microsoft.com/office/powerpoint/2010/main" val="522550161"/>
+        <p14:creationId xmlns:p14="http://schemas.microsoft.com/office/powerpoint/2010/main" val="1827652829"/>
       </p:ext>
     </p:extLst>
   </p:cSld>
@@ -7511,7 +8930,7 @@
           <p:cNvPr id="1" name="">
             <a:extLst xmlns:a="http://schemas.openxmlformats.org/drawingml/2006/main">
               <a:ext uri="{FF2B5EF4-FFF2-40B4-BE49-F238E27FC236}">
-                <a16:creationId xmlns:a16="http://schemas.microsoft.com/office/drawing/2014/main" id="{5C7B1D07-6645-487A-910D-EEAEFA3DECC0}"/>
+                <a16:creationId xmlns:a16="http://schemas.microsoft.com/office/drawing/2014/main" id="{0596249D-46BC-47FB-82A3-E8BF38C10208}"/>
               </a:ext>
             </a:extLst>
           </p:cNvPr>
@@ -7567,7 +8986,7 @@
           <p:cNvPr id="2" name="">
             <a:extLst xmlns:a="http://schemas.openxmlformats.org/drawingml/2006/main">
               <a:ext uri="{FF2B5EF4-FFF2-40B4-BE49-F238E27FC236}">
-                <a16:creationId xmlns:a16="http://schemas.microsoft.com/office/drawing/2014/main" id="{64878FCC-F601-40D2-BF81-372F35077F72}"/>
+                <a16:creationId xmlns:a16="http://schemas.microsoft.com/office/drawing/2014/main" id="{5A47C450-DA18-4E35-A142-96B34BE2B3CF}"/>
               </a:ext>
             </a:extLst>
           </p:cNvPr>
@@ -7623,7 +9042,7 @@
           <p:cNvPr id="3" name="">
             <a:extLst xmlns:a="http://schemas.openxmlformats.org/drawingml/2006/main">
               <a:ext uri="{FF2B5EF4-FFF2-40B4-BE49-F238E27FC236}">
-                <a16:creationId xmlns:a16="http://schemas.microsoft.com/office/drawing/2014/main" id="{CF84FE51-7E6E-4B81-8CA5-2AFF40A11B5E}"/>
+                <a16:creationId xmlns:a16="http://schemas.microsoft.com/office/drawing/2014/main" id="{EB3257CB-6622-41DB-A132-37CB980E7BD6}"/>
               </a:ext>
             </a:extLst>
           </p:cNvPr>
@@ -7679,7 +9098,7 @@
           <p:cNvPr id="4" name="rule">
             <a:extLst xmlns:a="http://schemas.openxmlformats.org/drawingml/2006/main">
               <a:ext uri="{FF2B5EF4-FFF2-40B4-BE49-F238E27FC236}">
-                <a16:creationId xmlns:a16="http://schemas.microsoft.com/office/drawing/2014/main" id="{934D7182-D536-4FF0-8164-0C732F6A51B7}"/>
+                <a16:creationId xmlns:a16="http://schemas.microsoft.com/office/drawing/2014/main" id="{D3C63E79-8E64-4E8B-8C48-D9CB0E6C8220}"/>
               </a:ext>
             </a:extLst>
           </p:cNvPr>
@@ -7710,7 +9129,7 @@
           <p:cNvPr id="5" name="">
             <a:extLst xmlns:a="http://schemas.openxmlformats.org/drawingml/2006/main">
               <a:ext uri="{FF2B5EF4-FFF2-40B4-BE49-F238E27FC236}">
-                <a16:creationId xmlns:a16="http://schemas.microsoft.com/office/drawing/2014/main" id="{A38BF68A-A9E2-403D-B5D7-38413B355874}"/>
+                <a16:creationId xmlns:a16="http://schemas.microsoft.com/office/drawing/2014/main" id="{106B2E9A-88BF-4DF8-9116-D032428978AA}"/>
               </a:ext>
             </a:extLst>
           </p:cNvPr>
@@ -7743,7 +9162,7 @@
           <p:cNvPr id="6" name="">
             <a:extLst xmlns:a="http://schemas.openxmlformats.org/drawingml/2006/main">
               <a:ext uri="{FF2B5EF4-FFF2-40B4-BE49-F238E27FC236}">
-                <a16:creationId xmlns:a16="http://schemas.microsoft.com/office/drawing/2014/main" id="{E12AEC40-2378-45DA-8EEA-7B7603765E9F}"/>
+                <a16:creationId xmlns:a16="http://schemas.microsoft.com/office/drawing/2014/main" id="{7FA7C773-91EF-4569-8C15-24462A1393B0}"/>
               </a:ext>
             </a:extLst>
           </p:cNvPr>
@@ -7799,7 +9218,7 @@
           <p:cNvPr id="7" name="">
             <a:extLst xmlns:a="http://schemas.openxmlformats.org/drawingml/2006/main">
               <a:ext uri="{FF2B5EF4-FFF2-40B4-BE49-F238E27FC236}">
-                <a16:creationId xmlns:a16="http://schemas.microsoft.com/office/drawing/2014/main" id="{AF1F2B91-7CEA-4955-B3C8-F59D868D4DF6}"/>
+                <a16:creationId xmlns:a16="http://schemas.microsoft.com/office/drawing/2014/main" id="{9EC349EB-9AAC-485E-A13C-065E5851FDCC}"/>
               </a:ext>
             </a:extLst>
           </p:cNvPr>
@@ -7832,7 +9251,7 @@
           <p:cNvPr id="8" name="">
             <a:extLst xmlns:a="http://schemas.openxmlformats.org/drawingml/2006/main">
               <a:ext uri="{FF2B5EF4-FFF2-40B4-BE49-F238E27FC236}">
-                <a16:creationId xmlns:a16="http://schemas.microsoft.com/office/drawing/2014/main" id="{45209B99-88D7-496E-BF8A-888BDDBB5A37}"/>
+                <a16:creationId xmlns:a16="http://schemas.microsoft.com/office/drawing/2014/main" id="{6EE802C3-06C0-4F56-9348-E4B85A9AFC71}"/>
               </a:ext>
             </a:extLst>
           </p:cNvPr>
@@ -7888,7 +9307,7 @@
           <p:cNvPr id="9" name="">
             <a:extLst xmlns:a="http://schemas.openxmlformats.org/drawingml/2006/main">
               <a:ext uri="{FF2B5EF4-FFF2-40B4-BE49-F238E27FC236}">
-                <a16:creationId xmlns:a16="http://schemas.microsoft.com/office/drawing/2014/main" id="{AEDE6A0D-C6A1-4745-B4F2-CE97A22C7F53}"/>
+                <a16:creationId xmlns:a16="http://schemas.microsoft.com/office/drawing/2014/main" id="{70F49B3E-70A8-44F5-A97B-876BEB961DF1}"/>
               </a:ext>
             </a:extLst>
           </p:cNvPr>
@@ -7921,7 +9340,7 @@
           <p:cNvPr id="10" name="">
             <a:extLst xmlns:a="http://schemas.openxmlformats.org/drawingml/2006/main">
               <a:ext uri="{FF2B5EF4-FFF2-40B4-BE49-F238E27FC236}">
-                <a16:creationId xmlns:a16="http://schemas.microsoft.com/office/drawing/2014/main" id="{3F54C004-888E-4AAD-8F3C-852BDA4711B0}"/>
+                <a16:creationId xmlns:a16="http://schemas.microsoft.com/office/drawing/2014/main" id="{CBB59087-462D-4860-827B-988A4F42A6AA}"/>
               </a:ext>
             </a:extLst>
           </p:cNvPr>
@@ -7977,7 +9396,7 @@
           <p:cNvPr id="11" name="">
             <a:extLst xmlns:a="http://schemas.openxmlformats.org/drawingml/2006/main">
               <a:ext uri="{FF2B5EF4-FFF2-40B4-BE49-F238E27FC236}">
-                <a16:creationId xmlns:a16="http://schemas.microsoft.com/office/drawing/2014/main" id="{BDB27000-F76D-4386-B5DF-3B29143CA0E8}"/>
+                <a16:creationId xmlns:a16="http://schemas.microsoft.com/office/drawing/2014/main" id="{BA02809A-CFF1-4DB5-AB7C-E3722F416B44}"/>
               </a:ext>
             </a:extLst>
           </p:cNvPr>
@@ -8010,7 +9429,7 @@
           <p:cNvPr id="12" name="">
             <a:extLst xmlns:a="http://schemas.openxmlformats.org/drawingml/2006/main">
               <a:ext uri="{FF2B5EF4-FFF2-40B4-BE49-F238E27FC236}">
-                <a16:creationId xmlns:a16="http://schemas.microsoft.com/office/drawing/2014/main" id="{C4A5D9B6-AE5B-40C9-91C1-9AA4A8724819}"/>
+                <a16:creationId xmlns:a16="http://schemas.microsoft.com/office/drawing/2014/main" id="{E9EBF0DB-1557-493B-8957-789CE368CDB5}"/>
               </a:ext>
             </a:extLst>
           </p:cNvPr>
@@ -8066,7 +9485,7 @@
           <p:cNvPr id="13" name="">
             <a:extLst xmlns:a="http://schemas.openxmlformats.org/drawingml/2006/main">
               <a:ext uri="{FF2B5EF4-FFF2-40B4-BE49-F238E27FC236}">
-                <a16:creationId xmlns:a16="http://schemas.microsoft.com/office/drawing/2014/main" id="{D7F74083-913F-46FB-B49E-AA49172F858B}"/>
+                <a16:creationId xmlns:a16="http://schemas.microsoft.com/office/drawing/2014/main" id="{FB78BDF3-5AFE-43A2-8A1B-614026BE33EC}"/>
               </a:ext>
             </a:extLst>
           </p:cNvPr>
@@ -8099,7 +9518,7 @@
           <p:cNvPr id="14" name="">
             <a:extLst xmlns:a="http://schemas.openxmlformats.org/drawingml/2006/main">
               <a:ext uri="{FF2B5EF4-FFF2-40B4-BE49-F238E27FC236}">
-                <a16:creationId xmlns:a16="http://schemas.microsoft.com/office/drawing/2014/main" id="{9EABAD84-2962-45A3-9D82-0B1D1C8D30CB}"/>
+                <a16:creationId xmlns:a16="http://schemas.microsoft.com/office/drawing/2014/main" id="{9CD092CD-AA3A-4B3E-AD46-B6E46893D337}"/>
               </a:ext>
             </a:extLst>
           </p:cNvPr>
@@ -8155,7 +9574,7 @@
           <p:cNvPr id="15" name="">
             <a:extLst xmlns:a="http://schemas.openxmlformats.org/drawingml/2006/main">
               <a:ext uri="{FF2B5EF4-FFF2-40B4-BE49-F238E27FC236}">
-                <a16:creationId xmlns:a16="http://schemas.microsoft.com/office/drawing/2014/main" id="{1D45175B-6E77-4EE2-83CA-A18D273FA5B5}"/>
+                <a16:creationId xmlns:a16="http://schemas.microsoft.com/office/drawing/2014/main" id="{2115C1B5-CB02-48FE-9815-151204DF5D6B}"/>
               </a:ext>
             </a:extLst>
           </p:cNvPr>
@@ -8188,7 +9607,7 @@
           <p:cNvPr id="16" name="">
             <a:extLst xmlns:a="http://schemas.openxmlformats.org/drawingml/2006/main">
               <a:ext uri="{FF2B5EF4-FFF2-40B4-BE49-F238E27FC236}">
-                <a16:creationId xmlns:a16="http://schemas.microsoft.com/office/drawing/2014/main" id="{F6DEF768-00A5-40E5-98DC-3361BED5F6BB}"/>
+                <a16:creationId xmlns:a16="http://schemas.microsoft.com/office/drawing/2014/main" id="{57E49144-2E5B-4272-A6F4-AF1EFFDFC029}"/>
               </a:ext>
             </a:extLst>
           </p:cNvPr>
@@ -8244,7 +9663,7 @@
           <p:cNvPr id="17" name="">
             <a:extLst xmlns:a="http://schemas.openxmlformats.org/drawingml/2006/main">
               <a:ext uri="{FF2B5EF4-FFF2-40B4-BE49-F238E27FC236}">
-                <a16:creationId xmlns:a16="http://schemas.microsoft.com/office/drawing/2014/main" id="{3BF3FC3C-5E98-4555-BF87-A6BA51162ACA}"/>
+                <a16:creationId xmlns:a16="http://schemas.microsoft.com/office/drawing/2014/main" id="{DDF9C4E4-2F6D-4461-AEBE-638E6ED59A02}"/>
               </a:ext>
             </a:extLst>
           </p:cNvPr>
@@ -8277,7 +9696,7 @@
           <p:cNvPr id="18" name="">
             <a:extLst xmlns:a="http://schemas.openxmlformats.org/drawingml/2006/main">
               <a:ext uri="{FF2B5EF4-FFF2-40B4-BE49-F238E27FC236}">
-                <a16:creationId xmlns:a16="http://schemas.microsoft.com/office/drawing/2014/main" id="{80E2B5C6-3C18-44F6-A4BF-E5B1548F3B68}"/>
+                <a16:creationId xmlns:a16="http://schemas.microsoft.com/office/drawing/2014/main" id="{AE420546-1A6B-4C8E-9F8C-44AF85D7020C}"/>
               </a:ext>
             </a:extLst>
           </p:cNvPr>
@@ -8333,7 +9752,7 @@
           <p:cNvPr id="19" name="">
             <a:extLst xmlns:a="http://schemas.openxmlformats.org/drawingml/2006/main">
               <a:ext uri="{FF2B5EF4-FFF2-40B4-BE49-F238E27FC236}">
-                <a16:creationId xmlns:a16="http://schemas.microsoft.com/office/drawing/2014/main" id="{7E9F6554-F441-4417-8DE2-1B6F81A7743E}"/>
+                <a16:creationId xmlns:a16="http://schemas.microsoft.com/office/drawing/2014/main" id="{6E1A0BFF-8DA7-47C0-9A13-49B317E2293C}"/>
               </a:ext>
             </a:extLst>
           </p:cNvPr>
@@ -8366,7 +9785,7 @@
           <p:cNvPr id="20" name="">
             <a:extLst xmlns:a="http://schemas.openxmlformats.org/drawingml/2006/main">
               <a:ext uri="{FF2B5EF4-FFF2-40B4-BE49-F238E27FC236}">
-                <a16:creationId xmlns:a16="http://schemas.microsoft.com/office/drawing/2014/main" id="{D0F9760A-7C48-414B-857E-B3C347AE48A4}"/>
+                <a16:creationId xmlns:a16="http://schemas.microsoft.com/office/drawing/2014/main" id="{1A1133B6-8B68-457B-8650-A85E07949FA1}"/>
               </a:ext>
             </a:extLst>
           </p:cNvPr>
@@ -8422,7 +9841,7 @@
           <p:cNvPr id="21" name="">
             <a:extLst xmlns:a="http://schemas.openxmlformats.org/drawingml/2006/main">
               <a:ext uri="{FF2B5EF4-FFF2-40B4-BE49-F238E27FC236}">
-                <a16:creationId xmlns:a16="http://schemas.microsoft.com/office/drawing/2014/main" id="{039489BB-1A49-4074-BDD2-EC060DDAFD0C}"/>
+                <a16:creationId xmlns:a16="http://schemas.microsoft.com/office/drawing/2014/main" id="{DF32C607-D3E0-4623-83E0-CAEF7A7DD7A8}"/>
               </a:ext>
             </a:extLst>
           </p:cNvPr>
@@ -8455,7 +9874,7 @@
           <p:cNvPr id="22" name="">
             <a:extLst xmlns:a="http://schemas.openxmlformats.org/drawingml/2006/main">
               <a:ext uri="{FF2B5EF4-FFF2-40B4-BE49-F238E27FC236}">
-                <a16:creationId xmlns:a16="http://schemas.microsoft.com/office/drawing/2014/main" id="{398A9042-E92A-4392-9746-DE83C87C2B6B}"/>
+                <a16:creationId xmlns:a16="http://schemas.microsoft.com/office/drawing/2014/main" id="{2F5072F1-F20C-4360-982C-437A77E5130C}"/>
               </a:ext>
             </a:extLst>
           </p:cNvPr>
@@ -8511,7 +9930,7 @@
           <p:cNvPr id="23" name="">
             <a:extLst xmlns:a="http://schemas.openxmlformats.org/drawingml/2006/main">
               <a:ext uri="{FF2B5EF4-FFF2-40B4-BE49-F238E27FC236}">
-                <a16:creationId xmlns:a16="http://schemas.microsoft.com/office/drawing/2014/main" id="{D31D6431-0B0A-4DE0-98D9-EBCDC7BD484B}"/>
+                <a16:creationId xmlns:a16="http://schemas.microsoft.com/office/drawing/2014/main" id="{36D7467E-C257-4ABF-B5C4-E65B66BBB9C4}"/>
               </a:ext>
             </a:extLst>
           </p:cNvPr>
@@ -8544,7 +9963,7 @@
           <p:cNvPr id="24" name="">
             <a:extLst xmlns:a="http://schemas.openxmlformats.org/drawingml/2006/main">
               <a:ext uri="{FF2B5EF4-FFF2-40B4-BE49-F238E27FC236}">
-                <a16:creationId xmlns:a16="http://schemas.microsoft.com/office/drawing/2014/main" id="{446D7C27-830D-4993-A63A-6B4C002274A7}"/>
+                <a16:creationId xmlns:a16="http://schemas.microsoft.com/office/drawing/2014/main" id="{3ACFE670-BBFB-4F7D-B3E6-1CA7B93821C9}"/>
               </a:ext>
             </a:extLst>
           </p:cNvPr>
@@ -8600,7 +10019,7 @@
           <p:cNvPr id="25" name="">
             <a:extLst xmlns:a="http://schemas.openxmlformats.org/drawingml/2006/main">
               <a:ext uri="{FF2B5EF4-FFF2-40B4-BE49-F238E27FC236}">
-                <a16:creationId xmlns:a16="http://schemas.microsoft.com/office/drawing/2014/main" id="{29D03273-54DD-47D0-92A2-331AF6B50E81}"/>
+                <a16:creationId xmlns:a16="http://schemas.microsoft.com/office/drawing/2014/main" id="{49D7F88D-C7F7-4108-BD8E-785EC540EDC6}"/>
               </a:ext>
             </a:extLst>
           </p:cNvPr>
@@ -8633,7 +10052,7 @@
           <p:cNvPr id="26" name="">
             <a:extLst xmlns:a="http://schemas.openxmlformats.org/drawingml/2006/main">
               <a:ext uri="{FF2B5EF4-FFF2-40B4-BE49-F238E27FC236}">
-                <a16:creationId xmlns:a16="http://schemas.microsoft.com/office/drawing/2014/main" id="{586C5C41-CF4D-432F-9A31-8D65C970FE52}"/>
+                <a16:creationId xmlns:a16="http://schemas.microsoft.com/office/drawing/2014/main" id="{20359D80-E215-409E-9BE9-69A7ECD797A6}"/>
               </a:ext>
             </a:extLst>
           </p:cNvPr>
@@ -8689,7 +10108,7 @@
           <p:cNvPr id="27" name="">
             <a:extLst xmlns:a="http://schemas.openxmlformats.org/drawingml/2006/main">
               <a:ext uri="{FF2B5EF4-FFF2-40B4-BE49-F238E27FC236}">
-                <a16:creationId xmlns:a16="http://schemas.microsoft.com/office/drawing/2014/main" id="{7F645094-A53C-4951-83C9-98DC2EE2E4DE}"/>
+                <a16:creationId xmlns:a16="http://schemas.microsoft.com/office/drawing/2014/main" id="{4148FF53-3DF9-492D-AE71-75AF0334DBBC}"/>
               </a:ext>
             </a:extLst>
           </p:cNvPr>
@@ -8722,7 +10141,7 @@
           <p:cNvPr id="28" name="">
             <a:extLst xmlns:a="http://schemas.openxmlformats.org/drawingml/2006/main">
               <a:ext uri="{FF2B5EF4-FFF2-40B4-BE49-F238E27FC236}">
-                <a16:creationId xmlns:a16="http://schemas.microsoft.com/office/drawing/2014/main" id="{38DD5FBE-40E6-4FCF-B235-8EF6439A9761}"/>
+                <a16:creationId xmlns:a16="http://schemas.microsoft.com/office/drawing/2014/main" id="{D4561128-2F72-4026-BC18-7E046C7AEA60}"/>
               </a:ext>
             </a:extLst>
           </p:cNvPr>
@@ -8778,7 +10197,7 @@
           <p:cNvPr id="29" name="">
             <a:extLst xmlns:a="http://schemas.openxmlformats.org/drawingml/2006/main">
               <a:ext uri="{FF2B5EF4-FFF2-40B4-BE49-F238E27FC236}">
-                <a16:creationId xmlns:a16="http://schemas.microsoft.com/office/drawing/2014/main" id="{CCF4F7CD-144A-4B94-97F3-59272D908146}"/>
+                <a16:creationId xmlns:a16="http://schemas.microsoft.com/office/drawing/2014/main" id="{4E61910A-6718-4588-8785-7F28C60F3320}"/>
               </a:ext>
             </a:extLst>
           </p:cNvPr>
@@ -8811,7 +10230,7 @@
           <p:cNvPr id="30" name="">
             <a:extLst xmlns:a="http://schemas.openxmlformats.org/drawingml/2006/main">
               <a:ext uri="{FF2B5EF4-FFF2-40B4-BE49-F238E27FC236}">
-                <a16:creationId xmlns:a16="http://schemas.microsoft.com/office/drawing/2014/main" id="{4834DF1D-75E3-4A86-AFAE-52200A1A2FEB}"/>
+                <a16:creationId xmlns:a16="http://schemas.microsoft.com/office/drawing/2014/main" id="{F9E6D7A5-C7DD-4AF5-8F53-B0D1A6E878D2}"/>
               </a:ext>
             </a:extLst>
           </p:cNvPr>
@@ -8867,7 +10286,7 @@
           <p:cNvPr id="31" name="">
             <a:extLst xmlns:a="http://schemas.openxmlformats.org/drawingml/2006/main">
               <a:ext uri="{FF2B5EF4-FFF2-40B4-BE49-F238E27FC236}">
-                <a16:creationId xmlns:a16="http://schemas.microsoft.com/office/drawing/2014/main" id="{87D73533-746F-4890-A3CE-CE99B1632964}"/>
+                <a16:creationId xmlns:a16="http://schemas.microsoft.com/office/drawing/2014/main" id="{0FE8E265-6002-4352-A159-78F9F7931BB0}"/>
               </a:ext>
             </a:extLst>
           </p:cNvPr>
@@ -8900,7 +10319,7 @@
           <p:cNvPr id="32" name="">
             <a:extLst xmlns:a="http://schemas.openxmlformats.org/drawingml/2006/main">
               <a:ext uri="{FF2B5EF4-FFF2-40B4-BE49-F238E27FC236}">
-                <a16:creationId xmlns:a16="http://schemas.microsoft.com/office/drawing/2014/main" id="{BB489558-8BF0-4D5B-A248-6FC6F5DC0CBE}"/>
+                <a16:creationId xmlns:a16="http://schemas.microsoft.com/office/drawing/2014/main" id="{86E163BD-9083-4D06-A617-7D51736D96D0}"/>
               </a:ext>
             </a:extLst>
           </p:cNvPr>
@@ -8956,7 +10375,7 @@
           <p:cNvPr id="33" name="">
             <a:extLst xmlns:a="http://schemas.openxmlformats.org/drawingml/2006/main">
               <a:ext uri="{FF2B5EF4-FFF2-40B4-BE49-F238E27FC236}">
-                <a16:creationId xmlns:a16="http://schemas.microsoft.com/office/drawing/2014/main" id="{D43A7E55-2609-49D6-98C8-46EBCC3826BB}"/>
+                <a16:creationId xmlns:a16="http://schemas.microsoft.com/office/drawing/2014/main" id="{E213DA02-7D0B-45F5-B581-7CB0C4CF2663}"/>
               </a:ext>
             </a:extLst>
           </p:cNvPr>
@@ -8989,7 +10408,7 @@
           <p:cNvPr id="34" name="">
             <a:extLst xmlns:a="http://schemas.openxmlformats.org/drawingml/2006/main">
               <a:ext uri="{FF2B5EF4-FFF2-40B4-BE49-F238E27FC236}">
-                <a16:creationId xmlns:a16="http://schemas.microsoft.com/office/drawing/2014/main" id="{51433617-B7EB-4890-9788-6124090D189B}"/>
+                <a16:creationId xmlns:a16="http://schemas.microsoft.com/office/drawing/2014/main" id="{F28632E9-869E-4A7A-B442-ECB130A096C5}"/>
               </a:ext>
             </a:extLst>
           </p:cNvPr>
@@ -9045,7 +10464,7 @@
           <p:cNvPr id="35" name="">
             <a:extLst xmlns:a="http://schemas.openxmlformats.org/drawingml/2006/main">
               <a:ext uri="{FF2B5EF4-FFF2-40B4-BE49-F238E27FC236}">
-                <a16:creationId xmlns:a16="http://schemas.microsoft.com/office/drawing/2014/main" id="{D81BB343-DAA4-40B9-B5E9-F609D0A0E526}"/>
+                <a16:creationId xmlns:a16="http://schemas.microsoft.com/office/drawing/2014/main" id="{0FF4AFE4-9629-47DE-AD48-C49C7A5DD0D4}"/>
               </a:ext>
             </a:extLst>
           </p:cNvPr>
@@ -9078,7 +10497,7 @@
           <p:cNvPr id="36" name="">
             <a:extLst xmlns:a="http://schemas.openxmlformats.org/drawingml/2006/main">
               <a:ext uri="{FF2B5EF4-FFF2-40B4-BE49-F238E27FC236}">
-                <a16:creationId xmlns:a16="http://schemas.microsoft.com/office/drawing/2014/main" id="{686B8184-3821-45FA-9CE5-57BBDF2F91A0}"/>
+                <a16:creationId xmlns:a16="http://schemas.microsoft.com/office/drawing/2014/main" id="{4188EBDE-55EE-4B32-B7C0-87A7D7AE756A}"/>
               </a:ext>
             </a:extLst>
           </p:cNvPr>
@@ -9134,7 +10553,7 @@
           <p:cNvPr id="37" name="">
             <a:extLst xmlns:a="http://schemas.openxmlformats.org/drawingml/2006/main">
               <a:ext uri="{FF2B5EF4-FFF2-40B4-BE49-F238E27FC236}">
-                <a16:creationId xmlns:a16="http://schemas.microsoft.com/office/drawing/2014/main" id="{539E0E86-E61C-426B-B66E-D925C5202FB0}"/>
+                <a16:creationId xmlns:a16="http://schemas.microsoft.com/office/drawing/2014/main" id="{4DA1BDB2-AEEA-46CD-9310-E5AA45D7A4FB}"/>
               </a:ext>
             </a:extLst>
           </p:cNvPr>
@@ -9167,7 +10586,7 @@
           <p:cNvPr id="38" name="">
             <a:extLst xmlns:a="http://schemas.openxmlformats.org/drawingml/2006/main">
               <a:ext uri="{FF2B5EF4-FFF2-40B4-BE49-F238E27FC236}">
-                <a16:creationId xmlns:a16="http://schemas.microsoft.com/office/drawing/2014/main" id="{E37FB5CF-8E02-40EB-A361-62DA37EE23F6}"/>
+                <a16:creationId xmlns:a16="http://schemas.microsoft.com/office/drawing/2014/main" id="{519F2092-B3FF-4D22-B279-99D28FC3E99E}"/>
               </a:ext>
             </a:extLst>
           </p:cNvPr>
@@ -9223,7 +10642,7 @@
           <p:cNvPr id="39" name="">
             <a:extLst xmlns:a="http://schemas.openxmlformats.org/drawingml/2006/main">
               <a:ext uri="{FF2B5EF4-FFF2-40B4-BE49-F238E27FC236}">
-                <a16:creationId xmlns:a16="http://schemas.microsoft.com/office/drawing/2014/main" id="{82C40DA9-7FE2-4D32-821A-2747E87CD442}"/>
+                <a16:creationId xmlns:a16="http://schemas.microsoft.com/office/drawing/2014/main" id="{D433CA26-EF68-43F7-89BD-D17C2B9208D7}"/>
               </a:ext>
             </a:extLst>
           </p:cNvPr>
@@ -9256,7 +10675,7 @@
           <p:cNvPr id="40" name="">
             <a:extLst xmlns:a="http://schemas.openxmlformats.org/drawingml/2006/main">
               <a:ext uri="{FF2B5EF4-FFF2-40B4-BE49-F238E27FC236}">
-                <a16:creationId xmlns:a16="http://schemas.microsoft.com/office/drawing/2014/main" id="{C035AB2D-0684-4F40-AA55-C4BEEE53E761}"/>
+                <a16:creationId xmlns:a16="http://schemas.microsoft.com/office/drawing/2014/main" id="{AA356CF4-5B94-4749-8D4E-1BBFE93A989E}"/>
               </a:ext>
             </a:extLst>
           </p:cNvPr>
@@ -9312,7 +10731,7 @@
           <p:cNvPr id="41" name="">
             <a:extLst xmlns:a="http://schemas.openxmlformats.org/drawingml/2006/main">
               <a:ext uri="{FF2B5EF4-FFF2-40B4-BE49-F238E27FC236}">
-                <a16:creationId xmlns:a16="http://schemas.microsoft.com/office/drawing/2014/main" id="{6209487B-FF04-44A1-AAFD-00E87A706F54}"/>
+                <a16:creationId xmlns:a16="http://schemas.microsoft.com/office/drawing/2014/main" id="{C3738190-6DBA-409D-8DD9-A65B0F48C512}"/>
               </a:ext>
             </a:extLst>
           </p:cNvPr>
@@ -9368,7 +10787,7 @@
           <p:cNvPr id="42" name="">
             <a:extLst xmlns:a="http://schemas.openxmlformats.org/drawingml/2006/main">
               <a:ext uri="{FF2B5EF4-FFF2-40B4-BE49-F238E27FC236}">
-                <a16:creationId xmlns:a16="http://schemas.microsoft.com/office/drawing/2014/main" id="{E73CB097-E686-4BCF-9B10-B9E21201EAC5}"/>
+                <a16:creationId xmlns:a16="http://schemas.microsoft.com/office/drawing/2014/main" id="{34B23108-88DD-4AE9-B662-2136AEDF41BC}"/>
               </a:ext>
             </a:extLst>
           </p:cNvPr>
@@ -9422,7 +10841,7 @@
     </p:spTree>
     <p:extLst>
       <p:ext uri="{BB962C8B-B14F-4D97-AF65-F5344CB8AC3E}">
-        <p14:creationId xmlns:p14="http://schemas.microsoft.com/office/powerpoint/2010/main" val="482315258"/>
+        <p14:creationId xmlns:p14="http://schemas.microsoft.com/office/powerpoint/2010/main" val="196421111"/>
       </p:ext>
     </p:extLst>
   </p:cSld>
@@ -9453,7 +10872,7 @@
           <p:cNvPr id="1" name="">
             <a:extLst xmlns:a="http://schemas.openxmlformats.org/drawingml/2006/main">
               <a:ext uri="{FF2B5EF4-FFF2-40B4-BE49-F238E27FC236}">
-                <a16:creationId xmlns:a16="http://schemas.microsoft.com/office/drawing/2014/main" id="{6679D2C3-5BC9-4791-BEB5-86843B1F944A}"/>
+                <a16:creationId xmlns:a16="http://schemas.microsoft.com/office/drawing/2014/main" id="{C820223F-9425-4BB8-A6B0-DDF6737549C3}"/>
               </a:ext>
             </a:extLst>
           </p:cNvPr>
@@ -9509,7 +10928,7 @@
           <p:cNvPr id="2" name="">
             <a:extLst xmlns:a="http://schemas.openxmlformats.org/drawingml/2006/main">
               <a:ext uri="{FF2B5EF4-FFF2-40B4-BE49-F238E27FC236}">
-                <a16:creationId xmlns:a16="http://schemas.microsoft.com/office/drawing/2014/main" id="{CECFEF06-5332-403A-A44E-BA05AC5A75A6}"/>
+                <a16:creationId xmlns:a16="http://schemas.microsoft.com/office/drawing/2014/main" id="{C3DF38D2-22C7-4C4F-9232-1E7A5F73169B}"/>
               </a:ext>
             </a:extLst>
           </p:cNvPr>
@@ -9565,7 +10984,7 @@
           <p:cNvPr id="3" name="">
             <a:extLst xmlns:a="http://schemas.openxmlformats.org/drawingml/2006/main">
               <a:ext uri="{FF2B5EF4-FFF2-40B4-BE49-F238E27FC236}">
-                <a16:creationId xmlns:a16="http://schemas.microsoft.com/office/drawing/2014/main" id="{406A6791-BB10-4A7C-ACD0-9051229DE73A}"/>
+                <a16:creationId xmlns:a16="http://schemas.microsoft.com/office/drawing/2014/main" id="{B64EFEA0-EFC7-4511-A679-EA0821EC2923}"/>
               </a:ext>
             </a:extLst>
           </p:cNvPr>
@@ -9621,7 +11040,7 @@
           <p:cNvPr id="4" name="rule">
             <a:extLst xmlns:a="http://schemas.openxmlformats.org/drawingml/2006/main">
               <a:ext uri="{FF2B5EF4-FFF2-40B4-BE49-F238E27FC236}">
-                <a16:creationId xmlns:a16="http://schemas.microsoft.com/office/drawing/2014/main" id="{0F0C1116-436E-4605-9C1B-84A7A67A992B}"/>
+                <a16:creationId xmlns:a16="http://schemas.microsoft.com/office/drawing/2014/main" id="{7A61A8D8-2F2B-4736-9E16-13EB7A6D64FA}"/>
               </a:ext>
             </a:extLst>
           </p:cNvPr>
@@ -9652,7 +11071,7 @@
           <p:cNvPr id="5" name="">
             <a:extLst xmlns:a="http://schemas.openxmlformats.org/drawingml/2006/main">
               <a:ext uri="{FF2B5EF4-FFF2-40B4-BE49-F238E27FC236}">
-                <a16:creationId xmlns:a16="http://schemas.microsoft.com/office/drawing/2014/main" id="{E0FAF7B8-1D75-4E68-A495-3A65689B5939}"/>
+                <a16:creationId xmlns:a16="http://schemas.microsoft.com/office/drawing/2014/main" id="{0BD0C1FF-0C51-4EF6-AABE-7D6BA8C15E56}"/>
               </a:ext>
             </a:extLst>
           </p:cNvPr>
@@ -9685,7 +11104,7 @@
           <p:cNvPr id="6" name="">
             <a:extLst xmlns:a="http://schemas.openxmlformats.org/drawingml/2006/main">
               <a:ext uri="{FF2B5EF4-FFF2-40B4-BE49-F238E27FC236}">
-                <a16:creationId xmlns:a16="http://schemas.microsoft.com/office/drawing/2014/main" id="{101CA902-09E5-4E5D-9FBB-E9F4CF5E4F2B}"/>
+                <a16:creationId xmlns:a16="http://schemas.microsoft.com/office/drawing/2014/main" id="{D4DEDFEA-CAB4-48F3-A6EF-557507E15847}"/>
               </a:ext>
             </a:extLst>
           </p:cNvPr>
@@ -9741,7 +11160,7 @@
           <p:cNvPr id="7" name="">
             <a:extLst xmlns:a="http://schemas.openxmlformats.org/drawingml/2006/main">
               <a:ext uri="{FF2B5EF4-FFF2-40B4-BE49-F238E27FC236}">
-                <a16:creationId xmlns:a16="http://schemas.microsoft.com/office/drawing/2014/main" id="{AB223478-6CC8-401D-8953-03A39C539883}"/>
+                <a16:creationId xmlns:a16="http://schemas.microsoft.com/office/drawing/2014/main" id="{C99ED114-F3DE-4DE2-A16E-3F7461976279}"/>
               </a:ext>
             </a:extLst>
           </p:cNvPr>
@@ -9797,7 +11216,7 @@
           <p:cNvPr id="8" name="">
             <a:extLst xmlns:a="http://schemas.openxmlformats.org/drawingml/2006/main">
               <a:ext uri="{FF2B5EF4-FFF2-40B4-BE49-F238E27FC236}">
-                <a16:creationId xmlns:a16="http://schemas.microsoft.com/office/drawing/2014/main" id="{165BB7AA-AB8C-42F5-B59B-F554D58E9387}"/>
+                <a16:creationId xmlns:a16="http://schemas.microsoft.com/office/drawing/2014/main" id="{49B5E7DC-3616-4E83-9F2B-9F72EC1E4842}"/>
               </a:ext>
             </a:extLst>
           </p:cNvPr>
@@ -9853,7 +11272,7 @@
           <p:cNvPr id="9" name="">
             <a:extLst xmlns:a="http://schemas.openxmlformats.org/drawingml/2006/main">
               <a:ext uri="{FF2B5EF4-FFF2-40B4-BE49-F238E27FC236}">
-                <a16:creationId xmlns:a16="http://schemas.microsoft.com/office/drawing/2014/main" id="{99C4B84D-A465-42F9-B40B-41ED08F9C56B}"/>
+                <a16:creationId xmlns:a16="http://schemas.microsoft.com/office/drawing/2014/main" id="{DE95F38C-6A27-40E3-9270-56A8159E63FD}"/>
               </a:ext>
             </a:extLst>
           </p:cNvPr>
@@ -9909,7 +11328,7 @@
           <p:cNvPr id="10" name="">
             <a:extLst xmlns:a="http://schemas.openxmlformats.org/drawingml/2006/main">
               <a:ext uri="{FF2B5EF4-FFF2-40B4-BE49-F238E27FC236}">
-                <a16:creationId xmlns:a16="http://schemas.microsoft.com/office/drawing/2014/main" id="{A5C6C4B7-736D-4F22-9B09-6AC303072307}"/>
+                <a16:creationId xmlns:a16="http://schemas.microsoft.com/office/drawing/2014/main" id="{263BB9BC-2674-4FDA-8CE4-B316997E0B3A}"/>
               </a:ext>
             </a:extLst>
           </p:cNvPr>
@@ -9942,7 +11361,7 @@
           <p:cNvPr id="11" name="">
             <a:extLst xmlns:a="http://schemas.openxmlformats.org/drawingml/2006/main">
               <a:ext uri="{FF2B5EF4-FFF2-40B4-BE49-F238E27FC236}">
-                <a16:creationId xmlns:a16="http://schemas.microsoft.com/office/drawing/2014/main" id="{260D890D-0ADA-4A39-B1FC-D2A65CC45084}"/>
+                <a16:creationId xmlns:a16="http://schemas.microsoft.com/office/drawing/2014/main" id="{52F51BB6-1885-42D8-97F6-66BFEA846877}"/>
               </a:ext>
             </a:extLst>
           </p:cNvPr>
@@ -9998,7 +11417,7 @@
           <p:cNvPr id="12" name="">
             <a:extLst xmlns:a="http://schemas.openxmlformats.org/drawingml/2006/main">
               <a:ext uri="{FF2B5EF4-FFF2-40B4-BE49-F238E27FC236}">
-                <a16:creationId xmlns:a16="http://schemas.microsoft.com/office/drawing/2014/main" id="{F7B8C31A-0992-44A8-82EE-F5538DE72936}"/>
+                <a16:creationId xmlns:a16="http://schemas.microsoft.com/office/drawing/2014/main" id="{0171C3A8-A31A-4BF5-AE14-26A6DD2A575E}"/>
               </a:ext>
             </a:extLst>
           </p:cNvPr>
@@ -10031,7 +11450,7 @@
           <p:cNvPr id="13" name="">
             <a:extLst xmlns:a="http://schemas.openxmlformats.org/drawingml/2006/main">
               <a:ext uri="{FF2B5EF4-FFF2-40B4-BE49-F238E27FC236}">
-                <a16:creationId xmlns:a16="http://schemas.microsoft.com/office/drawing/2014/main" id="{AB92196C-4689-4E0E-95B3-239BF4D7731B}"/>
+                <a16:creationId xmlns:a16="http://schemas.microsoft.com/office/drawing/2014/main" id="{B7905D64-F8AC-4627-A4BF-60CD06F53C16}"/>
               </a:ext>
             </a:extLst>
           </p:cNvPr>
@@ -10087,7 +11506,7 @@
           <p:cNvPr id="14" name="">
             <a:extLst xmlns:a="http://schemas.openxmlformats.org/drawingml/2006/main">
               <a:ext uri="{FF2B5EF4-FFF2-40B4-BE49-F238E27FC236}">
-                <a16:creationId xmlns:a16="http://schemas.microsoft.com/office/drawing/2014/main" id="{2BF31F41-4863-468F-8175-4E940FCE093A}"/>
+                <a16:creationId xmlns:a16="http://schemas.microsoft.com/office/drawing/2014/main" id="{9220FD66-40A5-4F57-9612-C1FDCBCBA844}"/>
               </a:ext>
             </a:extLst>
           </p:cNvPr>
@@ -10120,7 +11539,7 @@
           <p:cNvPr id="15" name="">
             <a:extLst xmlns:a="http://schemas.openxmlformats.org/drawingml/2006/main">
               <a:ext uri="{FF2B5EF4-FFF2-40B4-BE49-F238E27FC236}">
-                <a16:creationId xmlns:a16="http://schemas.microsoft.com/office/drawing/2014/main" id="{F3E373C4-9099-4668-B661-8E65306F3772}"/>
+                <a16:creationId xmlns:a16="http://schemas.microsoft.com/office/drawing/2014/main" id="{9D7698BB-5994-4C99-A3DC-7D59F35CFFEE}"/>
               </a:ext>
             </a:extLst>
           </p:cNvPr>
@@ -10176,7 +11595,7 @@
           <p:cNvPr id="16" name="">
             <a:extLst xmlns:a="http://schemas.openxmlformats.org/drawingml/2006/main">
               <a:ext uri="{FF2B5EF4-FFF2-40B4-BE49-F238E27FC236}">
-                <a16:creationId xmlns:a16="http://schemas.microsoft.com/office/drawing/2014/main" id="{FC0485CC-617E-48C4-9752-7069570CF334}"/>
+                <a16:creationId xmlns:a16="http://schemas.microsoft.com/office/drawing/2014/main" id="{5FFFFE3D-AC24-42BE-A235-4E679132AAA2}"/>
               </a:ext>
             </a:extLst>
           </p:cNvPr>
@@ -10209,7 +11628,7 @@
           <p:cNvPr id="17" name="">
             <a:extLst xmlns:a="http://schemas.openxmlformats.org/drawingml/2006/main">
               <a:ext uri="{FF2B5EF4-FFF2-40B4-BE49-F238E27FC236}">
-                <a16:creationId xmlns:a16="http://schemas.microsoft.com/office/drawing/2014/main" id="{B90164CF-13A8-4758-B8B7-FDD8555B12EE}"/>
+                <a16:creationId xmlns:a16="http://schemas.microsoft.com/office/drawing/2014/main" id="{3932754D-E759-47F8-86B2-39C509B2894C}"/>
               </a:ext>
             </a:extLst>
           </p:cNvPr>
@@ -10265,7 +11684,7 @@
           <p:cNvPr id="18" name="">
             <a:extLst xmlns:a="http://schemas.openxmlformats.org/drawingml/2006/main">
               <a:ext uri="{FF2B5EF4-FFF2-40B4-BE49-F238E27FC236}">
-                <a16:creationId xmlns:a16="http://schemas.microsoft.com/office/drawing/2014/main" id="{1A09035A-25CA-47CE-AEDD-9F344CFFC27E}"/>
+                <a16:creationId xmlns:a16="http://schemas.microsoft.com/office/drawing/2014/main" id="{018C906C-40A7-4FB0-868E-17EAC75C0D1C}"/>
               </a:ext>
             </a:extLst>
           </p:cNvPr>
@@ -10298,7 +11717,7 @@
           <p:cNvPr id="19" name="">
             <a:extLst xmlns:a="http://schemas.openxmlformats.org/drawingml/2006/main">
               <a:ext uri="{FF2B5EF4-FFF2-40B4-BE49-F238E27FC236}">
-                <a16:creationId xmlns:a16="http://schemas.microsoft.com/office/drawing/2014/main" id="{3156B781-437E-4E6D-9CAC-69E8AC241773}"/>
+                <a16:creationId xmlns:a16="http://schemas.microsoft.com/office/drawing/2014/main" id="{F31587AE-17B6-4592-940A-EDCD26BFE2AB}"/>
               </a:ext>
             </a:extLst>
           </p:cNvPr>
@@ -10354,7 +11773,7 @@
           <p:cNvPr id="20" name="">
             <a:extLst xmlns:a="http://schemas.openxmlformats.org/drawingml/2006/main">
               <a:ext uri="{FF2B5EF4-FFF2-40B4-BE49-F238E27FC236}">
-                <a16:creationId xmlns:a16="http://schemas.microsoft.com/office/drawing/2014/main" id="{8CC06C0D-F315-4749-A20A-661201A20342}"/>
+                <a16:creationId xmlns:a16="http://schemas.microsoft.com/office/drawing/2014/main" id="{392E3D25-F2F0-4355-A5B4-C6A2D5A704C8}"/>
               </a:ext>
             </a:extLst>
           </p:cNvPr>
@@ -10387,7 +11806,7 @@
           <p:cNvPr id="21" name="">
             <a:extLst xmlns:a="http://schemas.openxmlformats.org/drawingml/2006/main">
               <a:ext uri="{FF2B5EF4-FFF2-40B4-BE49-F238E27FC236}">
-                <a16:creationId xmlns:a16="http://schemas.microsoft.com/office/drawing/2014/main" id="{892A260A-434F-4745-8BCD-4837468D8E6E}"/>
+                <a16:creationId xmlns:a16="http://schemas.microsoft.com/office/drawing/2014/main" id="{4E5B763F-EFCF-4C81-8B1E-B2B69ED097D2}"/>
               </a:ext>
             </a:extLst>
           </p:cNvPr>
@@ -10443,7 +11862,7 @@
           <p:cNvPr id="22" name="">
             <a:extLst xmlns:a="http://schemas.openxmlformats.org/drawingml/2006/main">
               <a:ext uri="{FF2B5EF4-FFF2-40B4-BE49-F238E27FC236}">
-                <a16:creationId xmlns:a16="http://schemas.microsoft.com/office/drawing/2014/main" id="{6703EF20-4E85-4CF0-94CB-389BF9ADDDC6}"/>
+                <a16:creationId xmlns:a16="http://schemas.microsoft.com/office/drawing/2014/main" id="{ABF534BC-77E8-47CB-8E06-F075461DFE10}"/>
               </a:ext>
             </a:extLst>
           </p:cNvPr>
@@ -10499,7 +11918,7 @@
           <p:cNvPr id="23" name="">
             <a:extLst xmlns:a="http://schemas.openxmlformats.org/drawingml/2006/main">
               <a:ext uri="{FF2B5EF4-FFF2-40B4-BE49-F238E27FC236}">
-                <a16:creationId xmlns:a16="http://schemas.microsoft.com/office/drawing/2014/main" id="{F978979C-1375-465C-BBBB-59C7B3199FC0}"/>
+                <a16:creationId xmlns:a16="http://schemas.microsoft.com/office/drawing/2014/main" id="{DCE454C1-AFC3-4747-84FF-FB6E0B522338}"/>
               </a:ext>
             </a:extLst>
           </p:cNvPr>
@@ -10553,7 +11972,7 @@
     </p:spTree>
     <p:extLst>
       <p:ext uri="{BB962C8B-B14F-4D97-AF65-F5344CB8AC3E}">
-        <p14:creationId xmlns:p14="http://schemas.microsoft.com/office/powerpoint/2010/main" val="1648242114"/>
+        <p14:creationId xmlns:p14="http://schemas.microsoft.com/office/powerpoint/2010/main" val="677567134"/>
       </p:ext>
     </p:extLst>
   </p:cSld>
@@ -10584,7 +12003,7 @@
           <p:cNvPr id="1" name="">
             <a:extLst xmlns:a="http://schemas.openxmlformats.org/drawingml/2006/main">
               <a:ext uri="{FF2B5EF4-FFF2-40B4-BE49-F238E27FC236}">
-                <a16:creationId xmlns:a16="http://schemas.microsoft.com/office/drawing/2014/main" id="{CDA574BA-4E30-446C-B73A-2FD13FDF9441}"/>
+                <a16:creationId xmlns:a16="http://schemas.microsoft.com/office/drawing/2014/main" id="{806B38D0-0007-4849-91E3-8F8CDD17220E}"/>
               </a:ext>
             </a:extLst>
           </p:cNvPr>
@@ -10640,7 +12059,7 @@
           <p:cNvPr id="2" name="">
             <a:extLst xmlns:a="http://schemas.openxmlformats.org/drawingml/2006/main">
               <a:ext uri="{FF2B5EF4-FFF2-40B4-BE49-F238E27FC236}">
-                <a16:creationId xmlns:a16="http://schemas.microsoft.com/office/drawing/2014/main" id="{92A51A66-1F7E-421A-A56E-462787E18176}"/>
+                <a16:creationId xmlns:a16="http://schemas.microsoft.com/office/drawing/2014/main" id="{5AABE98B-F032-4D7F-8D90-0EC099F54BD7}"/>
               </a:ext>
             </a:extLst>
           </p:cNvPr>
@@ -10696,7 +12115,7 @@
           <p:cNvPr id="3" name="">
             <a:extLst xmlns:a="http://schemas.openxmlformats.org/drawingml/2006/main">
               <a:ext uri="{FF2B5EF4-FFF2-40B4-BE49-F238E27FC236}">
-                <a16:creationId xmlns:a16="http://schemas.microsoft.com/office/drawing/2014/main" id="{FA6C1B2E-AE62-48A7-810F-509F691C943B}"/>
+                <a16:creationId xmlns:a16="http://schemas.microsoft.com/office/drawing/2014/main" id="{0F925F4F-D0C4-4727-A602-ABC555717454}"/>
               </a:ext>
             </a:extLst>
           </p:cNvPr>
@@ -10752,7 +12171,7 @@
           <p:cNvPr id="4" name="rule">
             <a:extLst xmlns:a="http://schemas.openxmlformats.org/drawingml/2006/main">
               <a:ext uri="{FF2B5EF4-FFF2-40B4-BE49-F238E27FC236}">
-                <a16:creationId xmlns:a16="http://schemas.microsoft.com/office/drawing/2014/main" id="{49C9A270-6960-47F5-B18B-AC2C94A9FBB0}"/>
+                <a16:creationId xmlns:a16="http://schemas.microsoft.com/office/drawing/2014/main" id="{818D49B1-90B8-4B57-A749-BE423CDB3448}"/>
               </a:ext>
             </a:extLst>
           </p:cNvPr>
@@ -10783,7 +12202,7 @@
           <p:cNvPr id="5" name="">
             <a:extLst xmlns:a="http://schemas.openxmlformats.org/drawingml/2006/main">
               <a:ext uri="{FF2B5EF4-FFF2-40B4-BE49-F238E27FC236}">
-                <a16:creationId xmlns:a16="http://schemas.microsoft.com/office/drawing/2014/main" id="{85B9263E-5759-4192-A8AE-A7A30022C3DE}"/>
+                <a16:creationId xmlns:a16="http://schemas.microsoft.com/office/drawing/2014/main" id="{09791A8D-DF1E-4AE0-9927-CE9188563C1C}"/>
               </a:ext>
             </a:extLst>
           </p:cNvPr>
@@ -10816,7 +12235,7 @@
           <p:cNvPr id="6" name="">
             <a:extLst xmlns:a="http://schemas.openxmlformats.org/drawingml/2006/main">
               <a:ext uri="{FF2B5EF4-FFF2-40B4-BE49-F238E27FC236}">
-                <a16:creationId xmlns:a16="http://schemas.microsoft.com/office/drawing/2014/main" id="{86774D60-3C85-46DD-B118-AE71F3C606CF}"/>
+                <a16:creationId xmlns:a16="http://schemas.microsoft.com/office/drawing/2014/main" id="{FF6A31B4-C06C-47F7-BFC5-1359022A3812}"/>
               </a:ext>
             </a:extLst>
           </p:cNvPr>
@@ -10872,7 +12291,7 @@
           <p:cNvPr id="7" name="">
             <a:extLst xmlns:a="http://schemas.openxmlformats.org/drawingml/2006/main">
               <a:ext uri="{FF2B5EF4-FFF2-40B4-BE49-F238E27FC236}">
-                <a16:creationId xmlns:a16="http://schemas.microsoft.com/office/drawing/2014/main" id="{AA72AA06-3768-42BD-902F-273288D84885}"/>
+                <a16:creationId xmlns:a16="http://schemas.microsoft.com/office/drawing/2014/main" id="{CC464D69-FBA1-40D6-BCBD-E381E08A4240}"/>
               </a:ext>
             </a:extLst>
           </p:cNvPr>
@@ -10928,7 +12347,7 @@
           <p:cNvPr id="8" name="">
             <a:extLst xmlns:a="http://schemas.openxmlformats.org/drawingml/2006/main">
               <a:ext uri="{FF2B5EF4-FFF2-40B4-BE49-F238E27FC236}">
-                <a16:creationId xmlns:a16="http://schemas.microsoft.com/office/drawing/2014/main" id="{28C04C4F-FBA4-423B-9A07-E737DB21421D}"/>
+                <a16:creationId xmlns:a16="http://schemas.microsoft.com/office/drawing/2014/main" id="{78071943-045B-4ED9-BF48-9C4E162A079F}"/>
               </a:ext>
             </a:extLst>
           </p:cNvPr>
@@ -10961,7 +12380,7 @@
           <p:cNvPr id="9" name="">
             <a:extLst xmlns:a="http://schemas.openxmlformats.org/drawingml/2006/main">
               <a:ext uri="{FF2B5EF4-FFF2-40B4-BE49-F238E27FC236}">
-                <a16:creationId xmlns:a16="http://schemas.microsoft.com/office/drawing/2014/main" id="{BD7983BA-D70B-444C-BCD8-CACFF1A066B9}"/>
+                <a16:creationId xmlns:a16="http://schemas.microsoft.com/office/drawing/2014/main" id="{8304A4AC-36D1-4D5F-AC52-DD68AA925052}"/>
               </a:ext>
             </a:extLst>
           </p:cNvPr>
@@ -11017,7 +12436,7 @@
           <p:cNvPr id="10" name="">
             <a:extLst xmlns:a="http://schemas.openxmlformats.org/drawingml/2006/main">
               <a:ext uri="{FF2B5EF4-FFF2-40B4-BE49-F238E27FC236}">
-                <a16:creationId xmlns:a16="http://schemas.microsoft.com/office/drawing/2014/main" id="{46C09147-95D8-4789-AF3F-C31E183301F4}"/>
+                <a16:creationId xmlns:a16="http://schemas.microsoft.com/office/drawing/2014/main" id="{F38D44BE-FE50-44AB-A3E4-FFCF975A7F62}"/>
               </a:ext>
             </a:extLst>
           </p:cNvPr>
@@ -11073,7 +12492,7 @@
           <p:cNvPr id="11" name="">
             <a:extLst xmlns:a="http://schemas.openxmlformats.org/drawingml/2006/main">
               <a:ext uri="{FF2B5EF4-FFF2-40B4-BE49-F238E27FC236}">
-                <a16:creationId xmlns:a16="http://schemas.microsoft.com/office/drawing/2014/main" id="{D60584AF-96E0-4629-86A1-2D62F261857D}"/>
+                <a16:creationId xmlns:a16="http://schemas.microsoft.com/office/drawing/2014/main" id="{A07C5394-570F-4DE6-8663-481AE4B626D9}"/>
               </a:ext>
             </a:extLst>
           </p:cNvPr>
@@ -11106,7 +12525,7 @@
           <p:cNvPr id="12" name="">
             <a:extLst xmlns:a="http://schemas.openxmlformats.org/drawingml/2006/main">
               <a:ext uri="{FF2B5EF4-FFF2-40B4-BE49-F238E27FC236}">
-                <a16:creationId xmlns:a16="http://schemas.microsoft.com/office/drawing/2014/main" id="{168EF92B-B237-4247-96DA-DC67EC7BE429}"/>
+                <a16:creationId xmlns:a16="http://schemas.microsoft.com/office/drawing/2014/main" id="{B4FB95CC-02F9-48EF-B745-7C2FCA851347}"/>
               </a:ext>
             </a:extLst>
           </p:cNvPr>
@@ -11162,7 +12581,7 @@
           <p:cNvPr id="13" name="">
             <a:extLst xmlns:a="http://schemas.openxmlformats.org/drawingml/2006/main">
               <a:ext uri="{FF2B5EF4-FFF2-40B4-BE49-F238E27FC236}">
-                <a16:creationId xmlns:a16="http://schemas.microsoft.com/office/drawing/2014/main" id="{373D809C-2CAB-4D84-AFB9-250AB90CF729}"/>
+                <a16:creationId xmlns:a16="http://schemas.microsoft.com/office/drawing/2014/main" id="{D43634DA-AE69-406D-A14D-EDFD4912ABEF}"/>
               </a:ext>
             </a:extLst>
           </p:cNvPr>
@@ -11218,7 +12637,7 @@
           <p:cNvPr id="14" name="">
             <a:extLst xmlns:a="http://schemas.openxmlformats.org/drawingml/2006/main">
               <a:ext uri="{FF2B5EF4-FFF2-40B4-BE49-F238E27FC236}">
-                <a16:creationId xmlns:a16="http://schemas.microsoft.com/office/drawing/2014/main" id="{C6D7F388-FD0B-46B0-83CC-3726235A6513}"/>
+                <a16:creationId xmlns:a16="http://schemas.microsoft.com/office/drawing/2014/main" id="{4A35412A-3617-4C0C-B085-56D5F562C659}"/>
               </a:ext>
             </a:extLst>
           </p:cNvPr>
@@ -11251,7 +12670,7 @@
           <p:cNvPr id="15" name="">
             <a:extLst xmlns:a="http://schemas.openxmlformats.org/drawingml/2006/main">
               <a:ext uri="{FF2B5EF4-FFF2-40B4-BE49-F238E27FC236}">
-                <a16:creationId xmlns:a16="http://schemas.microsoft.com/office/drawing/2014/main" id="{3F78E3E4-7583-47D0-BA11-0947F71B2BCB}"/>
+                <a16:creationId xmlns:a16="http://schemas.microsoft.com/office/drawing/2014/main" id="{E6B6AC66-8FC2-470E-AE60-2F99517F6DEE}"/>
               </a:ext>
             </a:extLst>
           </p:cNvPr>
@@ -11307,7 +12726,7 @@
           <p:cNvPr id="16" name="">
             <a:extLst xmlns:a="http://schemas.openxmlformats.org/drawingml/2006/main">
               <a:ext uri="{FF2B5EF4-FFF2-40B4-BE49-F238E27FC236}">
-                <a16:creationId xmlns:a16="http://schemas.microsoft.com/office/drawing/2014/main" id="{E7E3CF0C-91FA-46E6-A212-4A1159C87F42}"/>
+                <a16:creationId xmlns:a16="http://schemas.microsoft.com/office/drawing/2014/main" id="{92652429-C64E-421F-8974-1DC5DAFA5744}"/>
               </a:ext>
             </a:extLst>
           </p:cNvPr>
@@ -11363,7 +12782,7 @@
           <p:cNvPr id="17" name="">
             <a:extLst xmlns:a="http://schemas.openxmlformats.org/drawingml/2006/main">
               <a:ext uri="{FF2B5EF4-FFF2-40B4-BE49-F238E27FC236}">
-                <a16:creationId xmlns:a16="http://schemas.microsoft.com/office/drawing/2014/main" id="{649D7C3F-F47C-47C5-88AE-A2D34B5FABF5}"/>
+                <a16:creationId xmlns:a16="http://schemas.microsoft.com/office/drawing/2014/main" id="{C547F958-CC1E-464A-ABC7-466CEF88485F}"/>
               </a:ext>
             </a:extLst>
           </p:cNvPr>
@@ -11396,7 +12815,7 @@
           <p:cNvPr id="18" name="">
             <a:extLst xmlns:a="http://schemas.openxmlformats.org/drawingml/2006/main">
               <a:ext uri="{FF2B5EF4-FFF2-40B4-BE49-F238E27FC236}">
-                <a16:creationId xmlns:a16="http://schemas.microsoft.com/office/drawing/2014/main" id="{8B91F135-EDFE-417D-9AC9-C6FF48B17201}"/>
+                <a16:creationId xmlns:a16="http://schemas.microsoft.com/office/drawing/2014/main" id="{0965EFDC-BF47-4F0A-A915-5B1737CA1410}"/>
               </a:ext>
             </a:extLst>
           </p:cNvPr>
@@ -11452,7 +12871,7 @@
           <p:cNvPr id="19" name="">
             <a:extLst xmlns:a="http://schemas.openxmlformats.org/drawingml/2006/main">
               <a:ext uri="{FF2B5EF4-FFF2-40B4-BE49-F238E27FC236}">
-                <a16:creationId xmlns:a16="http://schemas.microsoft.com/office/drawing/2014/main" id="{C766880C-DEAE-41BC-95A1-4159E2382D70}"/>
+                <a16:creationId xmlns:a16="http://schemas.microsoft.com/office/drawing/2014/main" id="{054FA8E3-D1E6-4CD6-A96E-85E1BBBDD340}"/>
               </a:ext>
             </a:extLst>
           </p:cNvPr>
@@ -11508,7 +12927,7 @@
           <p:cNvPr id="20" name="">
             <a:extLst xmlns:a="http://schemas.openxmlformats.org/drawingml/2006/main">
               <a:ext uri="{FF2B5EF4-FFF2-40B4-BE49-F238E27FC236}">
-                <a16:creationId xmlns:a16="http://schemas.microsoft.com/office/drawing/2014/main" id="{8521FBB5-6C63-4005-AC99-D18D0C30AC50}"/>
+                <a16:creationId xmlns:a16="http://schemas.microsoft.com/office/drawing/2014/main" id="{E54E2BBB-9208-45E5-9712-E198DF409864}"/>
               </a:ext>
             </a:extLst>
           </p:cNvPr>
@@ -11541,7 +12960,7 @@
           <p:cNvPr id="21" name="">
             <a:extLst xmlns:a="http://schemas.openxmlformats.org/drawingml/2006/main">
               <a:ext uri="{FF2B5EF4-FFF2-40B4-BE49-F238E27FC236}">
-                <a16:creationId xmlns:a16="http://schemas.microsoft.com/office/drawing/2014/main" id="{0B61BFD9-058E-4163-B254-952485B9CE5F}"/>
+                <a16:creationId xmlns:a16="http://schemas.microsoft.com/office/drawing/2014/main" id="{B4BF5909-DAEF-4F2C-9F43-F68C52D0724D}"/>
               </a:ext>
             </a:extLst>
           </p:cNvPr>
@@ -11597,7 +13016,7 @@
           <p:cNvPr id="22" name="">
             <a:extLst xmlns:a="http://schemas.openxmlformats.org/drawingml/2006/main">
               <a:ext uri="{FF2B5EF4-FFF2-40B4-BE49-F238E27FC236}">
-                <a16:creationId xmlns:a16="http://schemas.microsoft.com/office/drawing/2014/main" id="{CD26DE96-FC7D-42C6-AF02-ACB675290B84}"/>
+                <a16:creationId xmlns:a16="http://schemas.microsoft.com/office/drawing/2014/main" id="{BCEFDDB9-10B9-49D8-9A8C-B614149BECD3}"/>
               </a:ext>
             </a:extLst>
           </p:cNvPr>
@@ -11653,7 +13072,7 @@
           <p:cNvPr id="23" name="">
             <a:extLst xmlns:a="http://schemas.openxmlformats.org/drawingml/2006/main">
               <a:ext uri="{FF2B5EF4-FFF2-40B4-BE49-F238E27FC236}">
-                <a16:creationId xmlns:a16="http://schemas.microsoft.com/office/drawing/2014/main" id="{5BE2FC87-2767-4C51-9834-7FFF9EA35E67}"/>
+                <a16:creationId xmlns:a16="http://schemas.microsoft.com/office/drawing/2014/main" id="{566D90BA-5994-4FBE-9D90-D9C420AE09E5}"/>
               </a:ext>
             </a:extLst>
           </p:cNvPr>
@@ -11686,7 +13105,7 @@
           <p:cNvPr id="24" name="">
             <a:extLst xmlns:a="http://schemas.openxmlformats.org/drawingml/2006/main">
               <a:ext uri="{FF2B5EF4-FFF2-40B4-BE49-F238E27FC236}">
-                <a16:creationId xmlns:a16="http://schemas.microsoft.com/office/drawing/2014/main" id="{074521E2-835B-4916-9BE6-88AD7F7D303A}"/>
+                <a16:creationId xmlns:a16="http://schemas.microsoft.com/office/drawing/2014/main" id="{FDA92CE2-A477-4762-BEFB-D08CC3D3559A}"/>
               </a:ext>
             </a:extLst>
           </p:cNvPr>
@@ -11742,7 +13161,7 @@
           <p:cNvPr id="25" name="">
             <a:extLst xmlns:a="http://schemas.openxmlformats.org/drawingml/2006/main">
               <a:ext uri="{FF2B5EF4-FFF2-40B4-BE49-F238E27FC236}">
-                <a16:creationId xmlns:a16="http://schemas.microsoft.com/office/drawing/2014/main" id="{EC2B575A-5255-4C31-A583-9ED5FA77C0C4}"/>
+                <a16:creationId xmlns:a16="http://schemas.microsoft.com/office/drawing/2014/main" id="{A4613D69-C9AE-4EC3-B75F-1F3D1B18E4AB}"/>
               </a:ext>
             </a:extLst>
           </p:cNvPr>
@@ -11775,7 +13194,7 @@
           <p:cNvPr id="26" name="">
             <a:extLst xmlns:a="http://schemas.openxmlformats.org/drawingml/2006/main">
               <a:ext uri="{FF2B5EF4-FFF2-40B4-BE49-F238E27FC236}">
-                <a16:creationId xmlns:a16="http://schemas.microsoft.com/office/drawing/2014/main" id="{49F8BB0F-2C66-4B3A-9EE6-21937661E897}"/>
+                <a16:creationId xmlns:a16="http://schemas.microsoft.com/office/drawing/2014/main" id="{23E9A41B-51B7-4C2B-B314-9692E594AD69}"/>
               </a:ext>
             </a:extLst>
           </p:cNvPr>
@@ -11831,7 +13250,7 @@
           <p:cNvPr id="27" name="">
             <a:extLst xmlns:a="http://schemas.openxmlformats.org/drawingml/2006/main">
               <a:ext uri="{FF2B5EF4-FFF2-40B4-BE49-F238E27FC236}">
-                <a16:creationId xmlns:a16="http://schemas.microsoft.com/office/drawing/2014/main" id="{95DB95AA-FC34-4E62-838F-ACF666DE86C0}"/>
+                <a16:creationId xmlns:a16="http://schemas.microsoft.com/office/drawing/2014/main" id="{C7385993-330E-4825-868B-77259E5993B9}"/>
               </a:ext>
             </a:extLst>
           </p:cNvPr>
@@ -11933,7 +13352,7 @@
           <p:cNvPr id="28" name="">
             <a:extLst xmlns:a="http://schemas.openxmlformats.org/drawingml/2006/main">
               <a:ext uri="{FF2B5EF4-FFF2-40B4-BE49-F238E27FC236}">
-                <a16:creationId xmlns:a16="http://schemas.microsoft.com/office/drawing/2014/main" id="{A627D3AF-29B0-48F6-8760-2834EF43C1EE}"/>
+                <a16:creationId xmlns:a16="http://schemas.microsoft.com/office/drawing/2014/main" id="{90BD1736-5187-4E1B-AD68-2C4870723814}"/>
               </a:ext>
             </a:extLst>
           </p:cNvPr>
@@ -11966,7 +13385,7 @@
           <p:cNvPr id="29" name="">
             <a:extLst xmlns:a="http://schemas.openxmlformats.org/drawingml/2006/main">
               <a:ext uri="{FF2B5EF4-FFF2-40B4-BE49-F238E27FC236}">
-                <a16:creationId xmlns:a16="http://schemas.microsoft.com/office/drawing/2014/main" id="{1CA3FCC9-E93F-4F2A-B110-10B27CC0A8C3}"/>
+                <a16:creationId xmlns:a16="http://schemas.microsoft.com/office/drawing/2014/main" id="{AE6E8825-6B35-42F1-931A-3D2D80B1E0A5}"/>
               </a:ext>
             </a:extLst>
           </p:cNvPr>
@@ -12022,7 +13441,7 @@
           <p:cNvPr id="30" name="">
             <a:extLst xmlns:a="http://schemas.openxmlformats.org/drawingml/2006/main">
               <a:ext uri="{FF2B5EF4-FFF2-40B4-BE49-F238E27FC236}">
-                <a16:creationId xmlns:a16="http://schemas.microsoft.com/office/drawing/2014/main" id="{126678BE-7605-4A40-8C2E-91AE96644F47}"/>
+                <a16:creationId xmlns:a16="http://schemas.microsoft.com/office/drawing/2014/main" id="{FE59C41E-5205-4AAF-B33D-5F584414CAC8}"/>
               </a:ext>
             </a:extLst>
           </p:cNvPr>
@@ -12124,7 +13543,7 @@
           <p:cNvPr id="31" name="">
             <a:extLst xmlns:a="http://schemas.openxmlformats.org/drawingml/2006/main">
               <a:ext uri="{FF2B5EF4-FFF2-40B4-BE49-F238E27FC236}">
-                <a16:creationId xmlns:a16="http://schemas.microsoft.com/office/drawing/2014/main" id="{8D7EC528-42E4-4E9E-A310-044A2C4FFE15}"/>
+                <a16:creationId xmlns:a16="http://schemas.microsoft.com/office/drawing/2014/main" id="{EFED9DF7-F926-451D-9D13-2313F8727982}"/>
               </a:ext>
             </a:extLst>
           </p:cNvPr>
@@ -12157,7 +13576,7 @@
           <p:cNvPr id="32" name="">
             <a:extLst xmlns:a="http://schemas.openxmlformats.org/drawingml/2006/main">
               <a:ext uri="{FF2B5EF4-FFF2-40B4-BE49-F238E27FC236}">
-                <a16:creationId xmlns:a16="http://schemas.microsoft.com/office/drawing/2014/main" id="{C627542C-9D9C-44AA-982F-D5A1251F38A9}"/>
+                <a16:creationId xmlns:a16="http://schemas.microsoft.com/office/drawing/2014/main" id="{3CB9719F-1BCE-4197-A6C0-9F740B9BA690}"/>
               </a:ext>
             </a:extLst>
           </p:cNvPr>
@@ -12213,7 +13632,7 @@
           <p:cNvPr id="33" name="">
             <a:extLst xmlns:a="http://schemas.openxmlformats.org/drawingml/2006/main">
               <a:ext uri="{FF2B5EF4-FFF2-40B4-BE49-F238E27FC236}">
-                <a16:creationId xmlns:a16="http://schemas.microsoft.com/office/drawing/2014/main" id="{6FD4DE32-15DE-4FFD-9CE4-B240B2E8D3FC}"/>
+                <a16:creationId xmlns:a16="http://schemas.microsoft.com/office/drawing/2014/main" id="{5B305154-C908-40F6-A2C4-CE232030FBBA}"/>
               </a:ext>
             </a:extLst>
           </p:cNvPr>
@@ -12315,7 +13734,7 @@
           <p:cNvPr id="34" name="">
             <a:extLst xmlns:a="http://schemas.openxmlformats.org/drawingml/2006/main">
               <a:ext uri="{FF2B5EF4-FFF2-40B4-BE49-F238E27FC236}">
-                <a16:creationId xmlns:a16="http://schemas.microsoft.com/office/drawing/2014/main" id="{DC581B6B-CFB7-47D9-ACA1-69D84A81FB40}"/>
+                <a16:creationId xmlns:a16="http://schemas.microsoft.com/office/drawing/2014/main" id="{12EC60B2-C5A2-4B91-870D-C350858AA841}"/>
               </a:ext>
             </a:extLst>
           </p:cNvPr>
@@ -12348,7 +13767,7 @@
           <p:cNvPr id="35" name="">
             <a:extLst xmlns:a="http://schemas.openxmlformats.org/drawingml/2006/main">
               <a:ext uri="{FF2B5EF4-FFF2-40B4-BE49-F238E27FC236}">
-                <a16:creationId xmlns:a16="http://schemas.microsoft.com/office/drawing/2014/main" id="{C1329BDA-6B78-4066-AD36-B6A1A6881E9B}"/>
+                <a16:creationId xmlns:a16="http://schemas.microsoft.com/office/drawing/2014/main" id="{5DF2C629-37AE-4B65-A4C5-80E78A7C4E2C}"/>
               </a:ext>
             </a:extLst>
           </p:cNvPr>
@@ -12404,7 +13823,7 @@
           <p:cNvPr id="36" name="">
             <a:extLst xmlns:a="http://schemas.openxmlformats.org/drawingml/2006/main">
               <a:ext uri="{FF2B5EF4-FFF2-40B4-BE49-F238E27FC236}">
-                <a16:creationId xmlns:a16="http://schemas.microsoft.com/office/drawing/2014/main" id="{B347AEE3-CAD1-4C75-B296-60A8C3E47B63}"/>
+                <a16:creationId xmlns:a16="http://schemas.microsoft.com/office/drawing/2014/main" id="{AF1B2F1B-2DA6-4353-B176-CB53E619E025}"/>
               </a:ext>
             </a:extLst>
           </p:cNvPr>
@@ -12506,7 +13925,7 @@
           <p:cNvPr id="37" name="">
             <a:extLst xmlns:a="http://schemas.openxmlformats.org/drawingml/2006/main">
               <a:ext uri="{FF2B5EF4-FFF2-40B4-BE49-F238E27FC236}">
-                <a16:creationId xmlns:a16="http://schemas.microsoft.com/office/drawing/2014/main" id="{5ED222B8-C27E-4C5F-BCD3-14BCE203434F}"/>
+                <a16:creationId xmlns:a16="http://schemas.microsoft.com/office/drawing/2014/main" id="{37A0C204-3AAB-4C9D-B7BE-B34D7899D98B}"/>
               </a:ext>
             </a:extLst>
           </p:cNvPr>
@@ -12562,7 +13981,7 @@
           <p:cNvPr id="38" name="">
             <a:extLst xmlns:a="http://schemas.openxmlformats.org/drawingml/2006/main">
               <a:ext uri="{FF2B5EF4-FFF2-40B4-BE49-F238E27FC236}">
-                <a16:creationId xmlns:a16="http://schemas.microsoft.com/office/drawing/2014/main" id="{ED5D93DF-0132-4872-810F-C9A6EF78C41A}"/>
+                <a16:creationId xmlns:a16="http://schemas.microsoft.com/office/drawing/2014/main" id="{2F8D6D90-CBE3-42AF-8232-11AD8A3D7497}"/>
               </a:ext>
             </a:extLst>
           </p:cNvPr>
@@ -12616,7 +14035,7 @@
     </p:spTree>
     <p:extLst>
       <p:ext uri="{BB962C8B-B14F-4D97-AF65-F5344CB8AC3E}">
-        <p14:creationId xmlns:p14="http://schemas.microsoft.com/office/powerpoint/2010/main" val="1783577384"/>
+        <p14:creationId xmlns:p14="http://schemas.microsoft.com/office/powerpoint/2010/main" val="272038503"/>
       </p:ext>
     </p:extLst>
   </p:cSld>
@@ -12647,7 +14066,7 @@
           <p:cNvPr id="1" name="">
             <a:extLst xmlns:a="http://schemas.openxmlformats.org/drawingml/2006/main">
               <a:ext uri="{FF2B5EF4-FFF2-40B4-BE49-F238E27FC236}">
-                <a16:creationId xmlns:a16="http://schemas.microsoft.com/office/drawing/2014/main" id="{062E6CF8-073B-43DF-BEC5-B168C3449E0D}"/>
+                <a16:creationId xmlns:a16="http://schemas.microsoft.com/office/drawing/2014/main" id="{A7568D33-4D00-489F-A8F1-0F91D443C39C}"/>
               </a:ext>
             </a:extLst>
           </p:cNvPr>
@@ -12703,7 +14122,7 @@
           <p:cNvPr id="2" name="">
             <a:extLst xmlns:a="http://schemas.openxmlformats.org/drawingml/2006/main">
               <a:ext uri="{FF2B5EF4-FFF2-40B4-BE49-F238E27FC236}">
-                <a16:creationId xmlns:a16="http://schemas.microsoft.com/office/drawing/2014/main" id="{1955DBF2-6B5F-4869-930F-C864506C8A36}"/>
+                <a16:creationId xmlns:a16="http://schemas.microsoft.com/office/drawing/2014/main" id="{26CB48CE-A9A1-42CD-ABFC-D17A33B85CAA}"/>
               </a:ext>
             </a:extLst>
           </p:cNvPr>
@@ -12759,7 +14178,7 @@
           <p:cNvPr id="3" name="">
             <a:extLst xmlns:a="http://schemas.openxmlformats.org/drawingml/2006/main">
               <a:ext uri="{FF2B5EF4-FFF2-40B4-BE49-F238E27FC236}">
-                <a16:creationId xmlns:a16="http://schemas.microsoft.com/office/drawing/2014/main" id="{068D9FB5-3CD1-4418-8FA7-F399E3DCBDF6}"/>
+                <a16:creationId xmlns:a16="http://schemas.microsoft.com/office/drawing/2014/main" id="{D0B14FCB-82B2-4B53-8C64-C5758B896B88}"/>
               </a:ext>
             </a:extLst>
           </p:cNvPr>
@@ -12815,7 +14234,7 @@
           <p:cNvPr id="4" name="rule">
             <a:extLst xmlns:a="http://schemas.openxmlformats.org/drawingml/2006/main">
               <a:ext uri="{FF2B5EF4-FFF2-40B4-BE49-F238E27FC236}">
-                <a16:creationId xmlns:a16="http://schemas.microsoft.com/office/drawing/2014/main" id="{C9C11D88-3B6D-4EB9-AE5B-1FC9C5FEF0BA}"/>
+                <a16:creationId xmlns:a16="http://schemas.microsoft.com/office/drawing/2014/main" id="{95BA55B8-0654-41F1-9616-69E319EB389B}"/>
               </a:ext>
             </a:extLst>
           </p:cNvPr>
@@ -12846,7 +14265,7 @@
           <p:cNvPr id="5" name="">
             <a:extLst xmlns:a="http://schemas.openxmlformats.org/drawingml/2006/main">
               <a:ext uri="{FF2B5EF4-FFF2-40B4-BE49-F238E27FC236}">
-                <a16:creationId xmlns:a16="http://schemas.microsoft.com/office/drawing/2014/main" id="{AC9D052F-A4A6-4A4E-9FAD-A78FCE0834DB}"/>
+                <a16:creationId xmlns:a16="http://schemas.microsoft.com/office/drawing/2014/main" id="{0E7602FD-FDB6-4E76-B819-E937E0DF6939}"/>
               </a:ext>
             </a:extLst>
           </p:cNvPr>
@@ -12879,7 +14298,7 @@
           <p:cNvPr id="6" name="">
             <a:extLst xmlns:a="http://schemas.openxmlformats.org/drawingml/2006/main">
               <a:ext uri="{FF2B5EF4-FFF2-40B4-BE49-F238E27FC236}">
-                <a16:creationId xmlns:a16="http://schemas.microsoft.com/office/drawing/2014/main" id="{2C8B6477-EB25-4CC1-A554-A5D5D89172FE}"/>
+                <a16:creationId xmlns:a16="http://schemas.microsoft.com/office/drawing/2014/main" id="{5F68BB59-E6D7-42A4-96DD-594573C753AB}"/>
               </a:ext>
             </a:extLst>
           </p:cNvPr>
@@ -12935,7 +14354,7 @@
           <p:cNvPr id="7" name="">
             <a:extLst xmlns:a="http://schemas.openxmlformats.org/drawingml/2006/main">
               <a:ext uri="{FF2B5EF4-FFF2-40B4-BE49-F238E27FC236}">
-                <a16:creationId xmlns:a16="http://schemas.microsoft.com/office/drawing/2014/main" id="{82FB8F65-4045-4B64-9BD7-41189C30FA83}"/>
+                <a16:creationId xmlns:a16="http://schemas.microsoft.com/office/drawing/2014/main" id="{ECCC37EA-10FF-4450-ACF5-B759467897CD}"/>
               </a:ext>
             </a:extLst>
           </p:cNvPr>
@@ -12968,7 +14387,7 @@
           <p:cNvPr id="8" name="">
             <a:extLst xmlns:a="http://schemas.openxmlformats.org/drawingml/2006/main">
               <a:ext uri="{FF2B5EF4-FFF2-40B4-BE49-F238E27FC236}">
-                <a16:creationId xmlns:a16="http://schemas.microsoft.com/office/drawing/2014/main" id="{17434DF8-D45E-46C0-AB88-064E5E3E6DEC}"/>
+                <a16:creationId xmlns:a16="http://schemas.microsoft.com/office/drawing/2014/main" id="{959A4045-16AE-41ED-AD62-5BC5D5DCAC03}"/>
               </a:ext>
             </a:extLst>
           </p:cNvPr>
@@ -13024,7 +14443,7 @@
           <p:cNvPr id="9" name="">
             <a:extLst xmlns:a="http://schemas.openxmlformats.org/drawingml/2006/main">
               <a:ext uri="{FF2B5EF4-FFF2-40B4-BE49-F238E27FC236}">
-                <a16:creationId xmlns:a16="http://schemas.microsoft.com/office/drawing/2014/main" id="{AD4711E3-2891-4A48-80C5-2CBDB6AB6178}"/>
+                <a16:creationId xmlns:a16="http://schemas.microsoft.com/office/drawing/2014/main" id="{51CBB5BA-1ABD-4D01-94B4-7D7F14113B1A}"/>
               </a:ext>
             </a:extLst>
           </p:cNvPr>
@@ -13057,7 +14476,7 @@
           <p:cNvPr id="10" name="">
             <a:extLst xmlns:a="http://schemas.openxmlformats.org/drawingml/2006/main">
               <a:ext uri="{FF2B5EF4-FFF2-40B4-BE49-F238E27FC236}">
-                <a16:creationId xmlns:a16="http://schemas.microsoft.com/office/drawing/2014/main" id="{E3D0F050-D337-4176-A6E5-F669F99AD19A}"/>
+                <a16:creationId xmlns:a16="http://schemas.microsoft.com/office/drawing/2014/main" id="{BBAE84FC-277B-41B1-9B0C-2F9B1A3ED67F}"/>
               </a:ext>
             </a:extLst>
           </p:cNvPr>
@@ -13113,7 +14532,7 @@
           <p:cNvPr id="11" name="">
             <a:extLst xmlns:a="http://schemas.openxmlformats.org/drawingml/2006/main">
               <a:ext uri="{FF2B5EF4-FFF2-40B4-BE49-F238E27FC236}">
-                <a16:creationId xmlns:a16="http://schemas.microsoft.com/office/drawing/2014/main" id="{60F80A55-EB8E-41C0-86D6-ED54A417A3B1}"/>
+                <a16:creationId xmlns:a16="http://schemas.microsoft.com/office/drawing/2014/main" id="{2B18B57F-BF75-4C07-ADAF-EA41CB2AC08C}"/>
               </a:ext>
             </a:extLst>
           </p:cNvPr>
@@ -13146,7 +14565,7 @@
           <p:cNvPr id="12" name="">
             <a:extLst xmlns:a="http://schemas.openxmlformats.org/drawingml/2006/main">
               <a:ext uri="{FF2B5EF4-FFF2-40B4-BE49-F238E27FC236}">
-                <a16:creationId xmlns:a16="http://schemas.microsoft.com/office/drawing/2014/main" id="{3CF89C2D-7B91-4FFD-A5B5-26A293E6723F}"/>
+                <a16:creationId xmlns:a16="http://schemas.microsoft.com/office/drawing/2014/main" id="{A269E8C5-3EF6-4440-AA34-B7CD328A28CA}"/>
               </a:ext>
             </a:extLst>
           </p:cNvPr>
@@ -13202,7 +14621,7 @@
           <p:cNvPr id="13" name="">
             <a:extLst xmlns:a="http://schemas.openxmlformats.org/drawingml/2006/main">
               <a:ext uri="{FF2B5EF4-FFF2-40B4-BE49-F238E27FC236}">
-                <a16:creationId xmlns:a16="http://schemas.microsoft.com/office/drawing/2014/main" id="{57DCFEDA-702A-4A61-89F5-9CB62EDB0D3E}"/>
+                <a16:creationId xmlns:a16="http://schemas.microsoft.com/office/drawing/2014/main" id="{3024C5DC-CFEA-4CE1-A7F5-F5246C0DC792}"/>
               </a:ext>
             </a:extLst>
           </p:cNvPr>
@@ -13235,7 +14654,7 @@
           <p:cNvPr id="14" name="">
             <a:extLst xmlns:a="http://schemas.openxmlformats.org/drawingml/2006/main">
               <a:ext uri="{FF2B5EF4-FFF2-40B4-BE49-F238E27FC236}">
-                <a16:creationId xmlns:a16="http://schemas.microsoft.com/office/drawing/2014/main" id="{8637CC50-6A35-4274-96BC-68A97A94DEC2}"/>
+                <a16:creationId xmlns:a16="http://schemas.microsoft.com/office/drawing/2014/main" id="{BB88D0AC-44EB-4D45-B6AA-9CE8EDE32719}"/>
               </a:ext>
             </a:extLst>
           </p:cNvPr>
@@ -13291,7 +14710,7 @@
           <p:cNvPr id="15" name="">
             <a:extLst xmlns:a="http://schemas.openxmlformats.org/drawingml/2006/main">
               <a:ext uri="{FF2B5EF4-FFF2-40B4-BE49-F238E27FC236}">
-                <a16:creationId xmlns:a16="http://schemas.microsoft.com/office/drawing/2014/main" id="{411207EC-80F5-4781-A206-FCECB0375407}"/>
+                <a16:creationId xmlns:a16="http://schemas.microsoft.com/office/drawing/2014/main" id="{C9D96088-7008-4D68-9DAA-D793DF4C3C27}"/>
               </a:ext>
             </a:extLst>
           </p:cNvPr>
@@ -13324,7 +14743,7 @@
           <p:cNvPr id="16" name="">
             <a:extLst xmlns:a="http://schemas.openxmlformats.org/drawingml/2006/main">
               <a:ext uri="{FF2B5EF4-FFF2-40B4-BE49-F238E27FC236}">
-                <a16:creationId xmlns:a16="http://schemas.microsoft.com/office/drawing/2014/main" id="{F7438B21-EEB4-41D2-8150-2B48E295B2AF}"/>
+                <a16:creationId xmlns:a16="http://schemas.microsoft.com/office/drawing/2014/main" id="{1532DD8B-28C8-42AE-B1A0-91D9A86B300B}"/>
               </a:ext>
             </a:extLst>
           </p:cNvPr>
@@ -13380,7 +14799,7 @@
           <p:cNvPr id="17" name="">
             <a:extLst xmlns:a="http://schemas.openxmlformats.org/drawingml/2006/main">
               <a:ext uri="{FF2B5EF4-FFF2-40B4-BE49-F238E27FC236}">
-                <a16:creationId xmlns:a16="http://schemas.microsoft.com/office/drawing/2014/main" id="{7B7B7E22-5703-4D27-BBE6-0F79FADF2927}"/>
+                <a16:creationId xmlns:a16="http://schemas.microsoft.com/office/drawing/2014/main" id="{AA8D16C4-C83E-43CA-B282-391E65524907}"/>
               </a:ext>
             </a:extLst>
           </p:cNvPr>
@@ -13413,7 +14832,7 @@
           <p:cNvPr id="18" name="">
             <a:extLst xmlns:a="http://schemas.openxmlformats.org/drawingml/2006/main">
               <a:ext uri="{FF2B5EF4-FFF2-40B4-BE49-F238E27FC236}">
-                <a16:creationId xmlns:a16="http://schemas.microsoft.com/office/drawing/2014/main" id="{A7917098-EE6B-411A-9CD8-FBB0B6BF8F94}"/>
+                <a16:creationId xmlns:a16="http://schemas.microsoft.com/office/drawing/2014/main" id="{811904F1-F98D-4588-ABF0-43C42580AF9E}"/>
               </a:ext>
             </a:extLst>
           </p:cNvPr>
@@ -13469,7 +14888,7 @@
           <p:cNvPr id="19" name="">
             <a:extLst xmlns:a="http://schemas.openxmlformats.org/drawingml/2006/main">
               <a:ext uri="{FF2B5EF4-FFF2-40B4-BE49-F238E27FC236}">
-                <a16:creationId xmlns:a16="http://schemas.microsoft.com/office/drawing/2014/main" id="{3E04B498-96A7-4916-B806-A629AC06C1AA}"/>
+                <a16:creationId xmlns:a16="http://schemas.microsoft.com/office/drawing/2014/main" id="{96051650-6539-4CEB-B3B1-CFD6DA7A7E4B}"/>
               </a:ext>
             </a:extLst>
           </p:cNvPr>
@@ -13502,7 +14921,7 @@
           <p:cNvPr id="20" name="">
             <a:extLst xmlns:a="http://schemas.openxmlformats.org/drawingml/2006/main">
               <a:ext uri="{FF2B5EF4-FFF2-40B4-BE49-F238E27FC236}">
-                <a16:creationId xmlns:a16="http://schemas.microsoft.com/office/drawing/2014/main" id="{C2E5F172-00F9-4D1A-8D4A-842C055CD4F1}"/>
+                <a16:creationId xmlns:a16="http://schemas.microsoft.com/office/drawing/2014/main" id="{D5318426-BD85-4C8D-B69F-39B0BCDF16E6}"/>
               </a:ext>
             </a:extLst>
           </p:cNvPr>
@@ -13558,7 +14977,7 @@
           <p:cNvPr id="21" name="">
             <a:extLst xmlns:a="http://schemas.openxmlformats.org/drawingml/2006/main">
               <a:ext uri="{FF2B5EF4-FFF2-40B4-BE49-F238E27FC236}">
-                <a16:creationId xmlns:a16="http://schemas.microsoft.com/office/drawing/2014/main" id="{7D86003C-B92B-4995-9042-908A7542DB97}"/>
+                <a16:creationId xmlns:a16="http://schemas.microsoft.com/office/drawing/2014/main" id="{399051F6-AF21-4995-AB8C-8416E0D78F89}"/>
               </a:ext>
             </a:extLst>
           </p:cNvPr>
@@ -13591,7 +15010,7 @@
           <p:cNvPr id="22" name="">
             <a:extLst xmlns:a="http://schemas.openxmlformats.org/drawingml/2006/main">
               <a:ext uri="{FF2B5EF4-FFF2-40B4-BE49-F238E27FC236}">
-                <a16:creationId xmlns:a16="http://schemas.microsoft.com/office/drawing/2014/main" id="{69F83C60-CB73-453E-BCA3-9500431DDC7E}"/>
+                <a16:creationId xmlns:a16="http://schemas.microsoft.com/office/drawing/2014/main" id="{DB59D5EE-DE98-4785-B807-D6E88ECBD36D}"/>
               </a:ext>
             </a:extLst>
           </p:cNvPr>
@@ -13647,7 +15066,7 @@
           <p:cNvPr id="23" name="">
             <a:extLst xmlns:a="http://schemas.openxmlformats.org/drawingml/2006/main">
               <a:ext uri="{FF2B5EF4-FFF2-40B4-BE49-F238E27FC236}">
-                <a16:creationId xmlns:a16="http://schemas.microsoft.com/office/drawing/2014/main" id="{BDCD2E01-EE3E-4195-B3AA-8726F21FC5FD}"/>
+                <a16:creationId xmlns:a16="http://schemas.microsoft.com/office/drawing/2014/main" id="{8F2C8B0A-F5DD-48C1-874D-AAEAB20A1326}"/>
               </a:ext>
             </a:extLst>
           </p:cNvPr>
@@ -13680,7 +15099,7 @@
           <p:cNvPr id="24" name="">
             <a:extLst xmlns:a="http://schemas.openxmlformats.org/drawingml/2006/main">
               <a:ext uri="{FF2B5EF4-FFF2-40B4-BE49-F238E27FC236}">
-                <a16:creationId xmlns:a16="http://schemas.microsoft.com/office/drawing/2014/main" id="{6BC8B20C-38BD-4F68-92C7-12322477B872}"/>
+                <a16:creationId xmlns:a16="http://schemas.microsoft.com/office/drawing/2014/main" id="{B0627962-3BA8-4360-BE94-BFA1BF939E80}"/>
               </a:ext>
             </a:extLst>
           </p:cNvPr>
@@ -13736,7 +15155,7 @@
           <p:cNvPr id="25" name="">
             <a:extLst xmlns:a="http://schemas.openxmlformats.org/drawingml/2006/main">
               <a:ext uri="{FF2B5EF4-FFF2-40B4-BE49-F238E27FC236}">
-                <a16:creationId xmlns:a16="http://schemas.microsoft.com/office/drawing/2014/main" id="{E7690484-8B5E-4286-BEAF-B86FC245912D}"/>
+                <a16:creationId xmlns:a16="http://schemas.microsoft.com/office/drawing/2014/main" id="{C7A80CC3-ECE6-4353-804D-E5379C54E279}"/>
               </a:ext>
             </a:extLst>
           </p:cNvPr>
@@ -13769,7 +15188,7 @@
           <p:cNvPr id="26" name="">
             <a:extLst xmlns:a="http://schemas.openxmlformats.org/drawingml/2006/main">
               <a:ext uri="{FF2B5EF4-FFF2-40B4-BE49-F238E27FC236}">
-                <a16:creationId xmlns:a16="http://schemas.microsoft.com/office/drawing/2014/main" id="{F456AE85-66D5-41F8-820B-751617958D53}"/>
+                <a16:creationId xmlns:a16="http://schemas.microsoft.com/office/drawing/2014/main" id="{5F6E25AA-A413-492B-8968-3A2A7B0871FF}"/>
               </a:ext>
             </a:extLst>
           </p:cNvPr>
@@ -13825,7 +15244,7 @@
           <p:cNvPr id="27" name="">
             <a:extLst xmlns:a="http://schemas.openxmlformats.org/drawingml/2006/main">
               <a:ext uri="{FF2B5EF4-FFF2-40B4-BE49-F238E27FC236}">
-                <a16:creationId xmlns:a16="http://schemas.microsoft.com/office/drawing/2014/main" id="{AE66BFC4-5E3F-408D-BD38-F77EFCA88040}"/>
+                <a16:creationId xmlns:a16="http://schemas.microsoft.com/office/drawing/2014/main" id="{4B59782B-5A98-46DC-9A31-061AAE8F1241}"/>
               </a:ext>
             </a:extLst>
           </p:cNvPr>
@@ -13858,7 +15277,7 @@
           <p:cNvPr id="28" name="">
             <a:extLst xmlns:a="http://schemas.openxmlformats.org/drawingml/2006/main">
               <a:ext uri="{FF2B5EF4-FFF2-40B4-BE49-F238E27FC236}">
-                <a16:creationId xmlns:a16="http://schemas.microsoft.com/office/drawing/2014/main" id="{D89D348E-6861-4401-90B4-825B5ED407BD}"/>
+                <a16:creationId xmlns:a16="http://schemas.microsoft.com/office/drawing/2014/main" id="{6CCBA66B-3A5E-402E-B2D0-51759ED80CF7}"/>
               </a:ext>
             </a:extLst>
           </p:cNvPr>
@@ -13914,7 +15333,7 @@
           <p:cNvPr id="29" name="">
             <a:extLst xmlns:a="http://schemas.openxmlformats.org/drawingml/2006/main">
               <a:ext uri="{FF2B5EF4-FFF2-40B4-BE49-F238E27FC236}">
-                <a16:creationId xmlns:a16="http://schemas.microsoft.com/office/drawing/2014/main" id="{D1DD23C9-B9F8-435F-B730-9166F06C83D8}"/>
+                <a16:creationId xmlns:a16="http://schemas.microsoft.com/office/drawing/2014/main" id="{EB13D22C-6FDF-4F8A-B56C-22795DD02D3D}"/>
               </a:ext>
             </a:extLst>
           </p:cNvPr>
@@ -13947,7 +15366,7 @@
           <p:cNvPr id="30" name="">
             <a:extLst xmlns:a="http://schemas.openxmlformats.org/drawingml/2006/main">
               <a:ext uri="{FF2B5EF4-FFF2-40B4-BE49-F238E27FC236}">
-                <a16:creationId xmlns:a16="http://schemas.microsoft.com/office/drawing/2014/main" id="{98DABB46-A08B-4859-A1FF-A3F05574A4F0}"/>
+                <a16:creationId xmlns:a16="http://schemas.microsoft.com/office/drawing/2014/main" id="{AE35CAA3-B504-4422-8EA8-04309D47129E}"/>
               </a:ext>
             </a:extLst>
           </p:cNvPr>
@@ -14003,7 +15422,7 @@
           <p:cNvPr id="31" name="">
             <a:extLst xmlns:a="http://schemas.openxmlformats.org/drawingml/2006/main">
               <a:ext uri="{FF2B5EF4-FFF2-40B4-BE49-F238E27FC236}">
-                <a16:creationId xmlns:a16="http://schemas.microsoft.com/office/drawing/2014/main" id="{A3633CFF-68AF-49C7-B6DB-316AA72B0391}"/>
+                <a16:creationId xmlns:a16="http://schemas.microsoft.com/office/drawing/2014/main" id="{D087A966-19E5-4A5D-98F3-F47A1A154262}"/>
               </a:ext>
             </a:extLst>
           </p:cNvPr>
@@ -14036,7 +15455,7 @@
           <p:cNvPr id="32" name="">
             <a:extLst xmlns:a="http://schemas.openxmlformats.org/drawingml/2006/main">
               <a:ext uri="{FF2B5EF4-FFF2-40B4-BE49-F238E27FC236}">
-                <a16:creationId xmlns:a16="http://schemas.microsoft.com/office/drawing/2014/main" id="{1027C425-B31F-47E1-A597-ECA748FF5607}"/>
+                <a16:creationId xmlns:a16="http://schemas.microsoft.com/office/drawing/2014/main" id="{1F8A5629-F628-42B8-BD05-FCB2FFFD470A}"/>
               </a:ext>
             </a:extLst>
           </p:cNvPr>
@@ -14092,7 +15511,7 @@
           <p:cNvPr id="33" name="">
             <a:extLst xmlns:a="http://schemas.openxmlformats.org/drawingml/2006/main">
               <a:ext uri="{FF2B5EF4-FFF2-40B4-BE49-F238E27FC236}">
-                <a16:creationId xmlns:a16="http://schemas.microsoft.com/office/drawing/2014/main" id="{10C3F803-EC8C-46C9-89D9-75EDA85F17C4}"/>
+                <a16:creationId xmlns:a16="http://schemas.microsoft.com/office/drawing/2014/main" id="{FB16680F-3D50-4963-B654-DE41D4DC055D}"/>
               </a:ext>
             </a:extLst>
           </p:cNvPr>
@@ -14125,7 +15544,7 @@
           <p:cNvPr id="34" name="">
             <a:extLst xmlns:a="http://schemas.openxmlformats.org/drawingml/2006/main">
               <a:ext uri="{FF2B5EF4-FFF2-40B4-BE49-F238E27FC236}">
-                <a16:creationId xmlns:a16="http://schemas.microsoft.com/office/drawing/2014/main" id="{AEAE8032-A44F-4B65-BE0A-262FC5A35762}"/>
+                <a16:creationId xmlns:a16="http://schemas.microsoft.com/office/drawing/2014/main" id="{BF01FE41-C520-42B8-B700-550D8828F7E9}"/>
               </a:ext>
             </a:extLst>
           </p:cNvPr>
@@ -14181,7 +15600,7 @@
           <p:cNvPr id="35" name="">
             <a:extLst xmlns:a="http://schemas.openxmlformats.org/drawingml/2006/main">
               <a:ext uri="{FF2B5EF4-FFF2-40B4-BE49-F238E27FC236}">
-                <a16:creationId xmlns:a16="http://schemas.microsoft.com/office/drawing/2014/main" id="{BE2BB0FA-4264-46B8-9C3A-C18396FBF557}"/>
+                <a16:creationId xmlns:a16="http://schemas.microsoft.com/office/drawing/2014/main" id="{338870A1-F90E-4DAB-AD04-6C00F441C8FE}"/>
               </a:ext>
             </a:extLst>
           </p:cNvPr>
@@ -14214,7 +15633,7 @@
           <p:cNvPr id="36" name="">
             <a:extLst xmlns:a="http://schemas.openxmlformats.org/drawingml/2006/main">
               <a:ext uri="{FF2B5EF4-FFF2-40B4-BE49-F238E27FC236}">
-                <a16:creationId xmlns:a16="http://schemas.microsoft.com/office/drawing/2014/main" id="{5196C6DD-AD32-491D-BD33-AC4C9363440F}"/>
+                <a16:creationId xmlns:a16="http://schemas.microsoft.com/office/drawing/2014/main" id="{17C1069E-D957-46AB-8341-B5EA69B4D839}"/>
               </a:ext>
             </a:extLst>
           </p:cNvPr>
@@ -14270,7 +15689,7 @@
           <p:cNvPr id="37" name="">
             <a:extLst xmlns:a="http://schemas.openxmlformats.org/drawingml/2006/main">
               <a:ext uri="{FF2B5EF4-FFF2-40B4-BE49-F238E27FC236}">
-                <a16:creationId xmlns:a16="http://schemas.microsoft.com/office/drawing/2014/main" id="{2520138B-AAC0-4F8A-BC92-1D7CBEB48139}"/>
+                <a16:creationId xmlns:a16="http://schemas.microsoft.com/office/drawing/2014/main" id="{E3C6C43D-5717-446E-839B-DF07E6306969}"/>
               </a:ext>
             </a:extLst>
           </p:cNvPr>
@@ -14303,7 +15722,7 @@
           <p:cNvPr id="38" name="">
             <a:extLst xmlns:a="http://schemas.openxmlformats.org/drawingml/2006/main">
               <a:ext uri="{FF2B5EF4-FFF2-40B4-BE49-F238E27FC236}">
-                <a16:creationId xmlns:a16="http://schemas.microsoft.com/office/drawing/2014/main" id="{174AF903-6E9D-45F3-A075-8C6628BC2BEF}"/>
+                <a16:creationId xmlns:a16="http://schemas.microsoft.com/office/drawing/2014/main" id="{5663CC10-29AF-4731-A993-00B4CAD083FA}"/>
               </a:ext>
             </a:extLst>
           </p:cNvPr>
@@ -14359,7 +15778,7 @@
           <p:cNvPr id="39" name="">
             <a:extLst xmlns:a="http://schemas.openxmlformats.org/drawingml/2006/main">
               <a:ext uri="{FF2B5EF4-FFF2-40B4-BE49-F238E27FC236}">
-                <a16:creationId xmlns:a16="http://schemas.microsoft.com/office/drawing/2014/main" id="{0AB691FD-E7E3-43FB-83E6-F960A34A182B}"/>
+                <a16:creationId xmlns:a16="http://schemas.microsoft.com/office/drawing/2014/main" id="{BDAD56B2-8FF2-43AB-BC84-A512BDF9EA26}"/>
               </a:ext>
             </a:extLst>
           </p:cNvPr>
@@ -14392,7 +15811,7 @@
           <p:cNvPr id="40" name="">
             <a:extLst xmlns:a="http://schemas.openxmlformats.org/drawingml/2006/main">
               <a:ext uri="{FF2B5EF4-FFF2-40B4-BE49-F238E27FC236}">
-                <a16:creationId xmlns:a16="http://schemas.microsoft.com/office/drawing/2014/main" id="{5660F106-34F2-41D0-A02A-EDCF1D95AA65}"/>
+                <a16:creationId xmlns:a16="http://schemas.microsoft.com/office/drawing/2014/main" id="{7C481DAF-DCE6-4FA0-B922-5322449D4F45}"/>
               </a:ext>
             </a:extLst>
           </p:cNvPr>
@@ -14448,7 +15867,7 @@
           <p:cNvPr id="41" name="">
             <a:extLst xmlns:a="http://schemas.openxmlformats.org/drawingml/2006/main">
               <a:ext uri="{FF2B5EF4-FFF2-40B4-BE49-F238E27FC236}">
-                <a16:creationId xmlns:a16="http://schemas.microsoft.com/office/drawing/2014/main" id="{048F5BB7-B191-4771-9F07-83A520DB5C81}"/>
+                <a16:creationId xmlns:a16="http://schemas.microsoft.com/office/drawing/2014/main" id="{9E0BCEF8-B0C4-4B24-B05B-C3F8DEBE8A9B}"/>
               </a:ext>
             </a:extLst>
           </p:cNvPr>
@@ -14481,7 +15900,7 @@
           <p:cNvPr id="42" name="">
             <a:extLst xmlns:a="http://schemas.openxmlformats.org/drawingml/2006/main">
               <a:ext uri="{FF2B5EF4-FFF2-40B4-BE49-F238E27FC236}">
-                <a16:creationId xmlns:a16="http://schemas.microsoft.com/office/drawing/2014/main" id="{E8F534F1-B6F9-43E9-B962-20CB682CC58F}"/>
+                <a16:creationId xmlns:a16="http://schemas.microsoft.com/office/drawing/2014/main" id="{FBE641D6-9952-4418-8CD9-3BA6C1F388D8}"/>
               </a:ext>
             </a:extLst>
           </p:cNvPr>
@@ -14537,7 +15956,7 @@
           <p:cNvPr id="43" name="">
             <a:extLst xmlns:a="http://schemas.openxmlformats.org/drawingml/2006/main">
               <a:ext uri="{FF2B5EF4-FFF2-40B4-BE49-F238E27FC236}">
-                <a16:creationId xmlns:a16="http://schemas.microsoft.com/office/drawing/2014/main" id="{D3AAE8C6-A77B-4413-AC19-1E94BD700CD9}"/>
+                <a16:creationId xmlns:a16="http://schemas.microsoft.com/office/drawing/2014/main" id="{6E17F828-A7DA-45FD-950F-448CA4D41D10}"/>
               </a:ext>
             </a:extLst>
           </p:cNvPr>
@@ -14570,7 +15989,7 @@
           <p:cNvPr id="44" name="">
             <a:extLst xmlns:a="http://schemas.openxmlformats.org/drawingml/2006/main">
               <a:ext uri="{FF2B5EF4-FFF2-40B4-BE49-F238E27FC236}">
-                <a16:creationId xmlns:a16="http://schemas.microsoft.com/office/drawing/2014/main" id="{429BA88A-DD31-4398-B8A9-73049730BF4D}"/>
+                <a16:creationId xmlns:a16="http://schemas.microsoft.com/office/drawing/2014/main" id="{BE092986-3F9E-459D-9B65-4AA49F5EA071}"/>
               </a:ext>
             </a:extLst>
           </p:cNvPr>
@@ -14626,7 +16045,7 @@
           <p:cNvPr id="45" name="">
             <a:extLst xmlns:a="http://schemas.openxmlformats.org/drawingml/2006/main">
               <a:ext uri="{FF2B5EF4-FFF2-40B4-BE49-F238E27FC236}">
-                <a16:creationId xmlns:a16="http://schemas.microsoft.com/office/drawing/2014/main" id="{3F9A26BE-F997-44B0-A6CC-A24B4F78B3E0}"/>
+                <a16:creationId xmlns:a16="http://schemas.microsoft.com/office/drawing/2014/main" id="{E102A423-D671-4FAE-B35A-9CB3BEBC9F24}"/>
               </a:ext>
             </a:extLst>
           </p:cNvPr>
@@ -14659,7 +16078,7 @@
           <p:cNvPr id="46" name="">
             <a:extLst xmlns:a="http://schemas.openxmlformats.org/drawingml/2006/main">
               <a:ext uri="{FF2B5EF4-FFF2-40B4-BE49-F238E27FC236}">
-                <a16:creationId xmlns:a16="http://schemas.microsoft.com/office/drawing/2014/main" id="{BB21B4B2-ECDD-4F18-A14A-04AD645F48FE}"/>
+                <a16:creationId xmlns:a16="http://schemas.microsoft.com/office/drawing/2014/main" id="{294D700C-5684-49ED-AFC6-4EB3F324A653}"/>
               </a:ext>
             </a:extLst>
           </p:cNvPr>
@@ -14715,7 +16134,7 @@
           <p:cNvPr id="47" name="">
             <a:extLst xmlns:a="http://schemas.openxmlformats.org/drawingml/2006/main">
               <a:ext uri="{FF2B5EF4-FFF2-40B4-BE49-F238E27FC236}">
-                <a16:creationId xmlns:a16="http://schemas.microsoft.com/office/drawing/2014/main" id="{BA188152-6C19-4891-81F2-FCE8B07A220D}"/>
+                <a16:creationId xmlns:a16="http://schemas.microsoft.com/office/drawing/2014/main" id="{A89228A8-A887-4437-8BFB-20BF7153665A}"/>
               </a:ext>
             </a:extLst>
           </p:cNvPr>
@@ -14771,7 +16190,7 @@
           <p:cNvPr id="48" name="">
             <a:extLst xmlns:a="http://schemas.openxmlformats.org/drawingml/2006/main">
               <a:ext uri="{FF2B5EF4-FFF2-40B4-BE49-F238E27FC236}">
-                <a16:creationId xmlns:a16="http://schemas.microsoft.com/office/drawing/2014/main" id="{1AC4FE6A-94C5-4C9B-A7C0-A94B073BC900}"/>
+                <a16:creationId xmlns:a16="http://schemas.microsoft.com/office/drawing/2014/main" id="{2DF1681E-FD86-4C1A-8D2D-AE2C554A18C5}"/>
               </a:ext>
             </a:extLst>
           </p:cNvPr>
@@ -14825,7 +16244,7 @@
     </p:spTree>
     <p:extLst>
       <p:ext uri="{BB962C8B-B14F-4D97-AF65-F5344CB8AC3E}">
-        <p14:creationId xmlns:p14="http://schemas.microsoft.com/office/powerpoint/2010/main" val="1401002423"/>
+        <p14:creationId xmlns:p14="http://schemas.microsoft.com/office/powerpoint/2010/main" val="2078706310"/>
       </p:ext>
     </p:extLst>
   </p:cSld>
@@ -14856,7 +16275,7 @@
           <p:cNvPr id="1" name="">
             <a:extLst xmlns:a="http://schemas.openxmlformats.org/drawingml/2006/main">
               <a:ext uri="{FF2B5EF4-FFF2-40B4-BE49-F238E27FC236}">
-                <a16:creationId xmlns:a16="http://schemas.microsoft.com/office/drawing/2014/main" id="{B56027B6-72F4-47B2-B73B-36BD7C5A2C95}"/>
+                <a16:creationId xmlns:a16="http://schemas.microsoft.com/office/drawing/2014/main" id="{D8F50BF3-CD49-4569-A18D-E968619EF726}"/>
               </a:ext>
             </a:extLst>
           </p:cNvPr>
@@ -14912,7 +16331,7 @@
           <p:cNvPr id="2" name="">
             <a:extLst xmlns:a="http://schemas.openxmlformats.org/drawingml/2006/main">
               <a:ext uri="{FF2B5EF4-FFF2-40B4-BE49-F238E27FC236}">
-                <a16:creationId xmlns:a16="http://schemas.microsoft.com/office/drawing/2014/main" id="{9DDE7516-7EDA-4D76-8332-5CEDECA18E21}"/>
+                <a16:creationId xmlns:a16="http://schemas.microsoft.com/office/drawing/2014/main" id="{849F176E-8D1E-4123-A3B2-A2E9ADB454D9}"/>
               </a:ext>
             </a:extLst>
           </p:cNvPr>
@@ -14968,7 +16387,7 @@
           <p:cNvPr id="3" name="">
             <a:extLst xmlns:a="http://schemas.openxmlformats.org/drawingml/2006/main">
               <a:ext uri="{FF2B5EF4-FFF2-40B4-BE49-F238E27FC236}">
-                <a16:creationId xmlns:a16="http://schemas.microsoft.com/office/drawing/2014/main" id="{9AB44FBD-A070-4CC7-8DF6-5E07BBA68589}"/>
+                <a16:creationId xmlns:a16="http://schemas.microsoft.com/office/drawing/2014/main" id="{E98766C5-FDCF-435F-AF4C-BE60592189CA}"/>
               </a:ext>
             </a:extLst>
           </p:cNvPr>
@@ -15024,7 +16443,7 @@
           <p:cNvPr id="4" name="rule">
             <a:extLst xmlns:a="http://schemas.openxmlformats.org/drawingml/2006/main">
               <a:ext uri="{FF2B5EF4-FFF2-40B4-BE49-F238E27FC236}">
-                <a16:creationId xmlns:a16="http://schemas.microsoft.com/office/drawing/2014/main" id="{31E0FA6F-BD67-4095-8E6D-D8EC79BD38B8}"/>
+                <a16:creationId xmlns:a16="http://schemas.microsoft.com/office/drawing/2014/main" id="{0AFE28D5-4501-46E3-BB35-C1389265D18C}"/>
               </a:ext>
             </a:extLst>
           </p:cNvPr>
@@ -15055,7 +16474,7 @@
           <p:cNvPr id="5" name="">
             <a:extLst xmlns:a="http://schemas.openxmlformats.org/drawingml/2006/main">
               <a:ext uri="{FF2B5EF4-FFF2-40B4-BE49-F238E27FC236}">
-                <a16:creationId xmlns:a16="http://schemas.microsoft.com/office/drawing/2014/main" id="{46BC1BF4-B323-4EF0-B139-A5723B702D69}"/>
+                <a16:creationId xmlns:a16="http://schemas.microsoft.com/office/drawing/2014/main" id="{2448289D-AA32-456B-9D14-9108C87CB983}"/>
               </a:ext>
             </a:extLst>
           </p:cNvPr>
@@ -15088,7 +16507,7 @@
           <p:cNvPr id="6" name="">
             <a:extLst xmlns:a="http://schemas.openxmlformats.org/drawingml/2006/main">
               <a:ext uri="{FF2B5EF4-FFF2-40B4-BE49-F238E27FC236}">
-                <a16:creationId xmlns:a16="http://schemas.microsoft.com/office/drawing/2014/main" id="{42AB2FC6-6A73-4712-870E-871FC20DF98B}"/>
+                <a16:creationId xmlns:a16="http://schemas.microsoft.com/office/drawing/2014/main" id="{519ECA52-0CEF-4371-A9C6-8F4BC65F8B9B}"/>
               </a:ext>
             </a:extLst>
           </p:cNvPr>
@@ -15144,7 +16563,7 @@
           <p:cNvPr id="7" name="">
             <a:extLst xmlns:a="http://schemas.openxmlformats.org/drawingml/2006/main">
               <a:ext uri="{FF2B5EF4-FFF2-40B4-BE49-F238E27FC236}">
-                <a16:creationId xmlns:a16="http://schemas.microsoft.com/office/drawing/2014/main" id="{24948746-6ADD-480B-8BCB-314DDE983F60}"/>
+                <a16:creationId xmlns:a16="http://schemas.microsoft.com/office/drawing/2014/main" id="{7329B4A1-A3A7-4C84-815B-917E075966BE}"/>
               </a:ext>
             </a:extLst>
           </p:cNvPr>
@@ -15200,7 +16619,7 @@
           <p:cNvPr id="8" name="">
             <a:extLst xmlns:a="http://schemas.openxmlformats.org/drawingml/2006/main">
               <a:ext uri="{FF2B5EF4-FFF2-40B4-BE49-F238E27FC236}">
-                <a16:creationId xmlns:a16="http://schemas.microsoft.com/office/drawing/2014/main" id="{A5C0B312-BFF8-466A-B01D-534E13D588BA}"/>
+                <a16:creationId xmlns:a16="http://schemas.microsoft.com/office/drawing/2014/main" id="{7A5EDAE6-B49A-4B12-BAD9-73E5B5343C6D}"/>
               </a:ext>
             </a:extLst>
           </p:cNvPr>
@@ -15279,7 +16698,7 @@
           <p:cNvPr id="9" name="">
             <a:extLst xmlns:a="http://schemas.openxmlformats.org/drawingml/2006/main">
               <a:ext uri="{FF2B5EF4-FFF2-40B4-BE49-F238E27FC236}">
-                <a16:creationId xmlns:a16="http://schemas.microsoft.com/office/drawing/2014/main" id="{DD9760AE-1EA2-4BBD-8D3C-119DC99CA344}"/>
+                <a16:creationId xmlns:a16="http://schemas.microsoft.com/office/drawing/2014/main" id="{37FBA850-1A3E-4761-8981-6A64D61A518A}"/>
               </a:ext>
             </a:extLst>
           </p:cNvPr>
@@ -15312,7 +16731,7 @@
           <p:cNvPr id="10" name="">
             <a:extLst xmlns:a="http://schemas.openxmlformats.org/drawingml/2006/main">
               <a:ext uri="{FF2B5EF4-FFF2-40B4-BE49-F238E27FC236}">
-                <a16:creationId xmlns:a16="http://schemas.microsoft.com/office/drawing/2014/main" id="{B2AFFA64-271A-4CCF-AE05-3424492DD5A9}"/>
+                <a16:creationId xmlns:a16="http://schemas.microsoft.com/office/drawing/2014/main" id="{1017E57A-29B5-4DB6-B4EB-5E637CD0E4D7}"/>
               </a:ext>
             </a:extLst>
           </p:cNvPr>
@@ -15368,7 +16787,7 @@
           <p:cNvPr id="11" name="">
             <a:extLst xmlns:a="http://schemas.openxmlformats.org/drawingml/2006/main">
               <a:ext uri="{FF2B5EF4-FFF2-40B4-BE49-F238E27FC236}">
-                <a16:creationId xmlns:a16="http://schemas.microsoft.com/office/drawing/2014/main" id="{2630EF8F-32AA-4CF4-B201-2D96C2828130}"/>
+                <a16:creationId xmlns:a16="http://schemas.microsoft.com/office/drawing/2014/main" id="{3904201A-2AB6-461F-8015-22CB2EE881D7}"/>
               </a:ext>
             </a:extLst>
           </p:cNvPr>
@@ -15424,7 +16843,7 @@
           <p:cNvPr id="12" name="">
             <a:extLst xmlns:a="http://schemas.openxmlformats.org/drawingml/2006/main">
               <a:ext uri="{FF2B5EF4-FFF2-40B4-BE49-F238E27FC236}">
-                <a16:creationId xmlns:a16="http://schemas.microsoft.com/office/drawing/2014/main" id="{37BD71F0-1E24-46F7-AD06-FADF88DC0BA7}"/>
+                <a16:creationId xmlns:a16="http://schemas.microsoft.com/office/drawing/2014/main" id="{C6B7BDFC-9FD1-4070-90F0-E64CFA5A0DA0}"/>
               </a:ext>
             </a:extLst>
           </p:cNvPr>
@@ -15503,7 +16922,7 @@
           <p:cNvPr id="13" name="">
             <a:extLst xmlns:a="http://schemas.openxmlformats.org/drawingml/2006/main">
               <a:ext uri="{FF2B5EF4-FFF2-40B4-BE49-F238E27FC236}">
-                <a16:creationId xmlns:a16="http://schemas.microsoft.com/office/drawing/2014/main" id="{FB37A94D-9A6E-4CB5-8E9E-3BCAD7579BA4}"/>
+                <a16:creationId xmlns:a16="http://schemas.microsoft.com/office/drawing/2014/main" id="{618F6482-3E0D-4250-9B0C-15F2FB45D8AF}"/>
               </a:ext>
             </a:extLst>
           </p:cNvPr>
@@ -15536,7 +16955,7 @@
           <p:cNvPr id="14" name="">
             <a:extLst xmlns:a="http://schemas.openxmlformats.org/drawingml/2006/main">
               <a:ext uri="{FF2B5EF4-FFF2-40B4-BE49-F238E27FC236}">
-                <a16:creationId xmlns:a16="http://schemas.microsoft.com/office/drawing/2014/main" id="{8D0319BB-D4C9-43A2-9352-1C9BF82ECD68}"/>
+                <a16:creationId xmlns:a16="http://schemas.microsoft.com/office/drawing/2014/main" id="{E10412C5-3375-4335-906E-617AE2E858E5}"/>
               </a:ext>
             </a:extLst>
           </p:cNvPr>
@@ -15592,7 +17011,7 @@
           <p:cNvPr id="15" name="">
             <a:extLst xmlns:a="http://schemas.openxmlformats.org/drawingml/2006/main">
               <a:ext uri="{FF2B5EF4-FFF2-40B4-BE49-F238E27FC236}">
-                <a16:creationId xmlns:a16="http://schemas.microsoft.com/office/drawing/2014/main" id="{1A2EF9AD-3FA9-4A72-A3B7-35A3FCFCE400}"/>
+                <a16:creationId xmlns:a16="http://schemas.microsoft.com/office/drawing/2014/main" id="{20E67BEB-ABBC-4B54-9C33-F25878904EA6}"/>
               </a:ext>
             </a:extLst>
           </p:cNvPr>
@@ -15648,7 +17067,7 @@
           <p:cNvPr id="16" name="">
             <a:extLst xmlns:a="http://schemas.openxmlformats.org/drawingml/2006/main">
               <a:ext uri="{FF2B5EF4-FFF2-40B4-BE49-F238E27FC236}">
-                <a16:creationId xmlns:a16="http://schemas.microsoft.com/office/drawing/2014/main" id="{17E62AC1-2932-4CF7-875F-8E335A1A0CD4}"/>
+                <a16:creationId xmlns:a16="http://schemas.microsoft.com/office/drawing/2014/main" id="{3754C088-0116-46B2-B508-F601D248E83D}"/>
               </a:ext>
             </a:extLst>
           </p:cNvPr>
@@ -15727,7 +17146,7 @@
           <p:cNvPr id="17" name="">
             <a:extLst xmlns:a="http://schemas.openxmlformats.org/drawingml/2006/main">
               <a:ext uri="{FF2B5EF4-FFF2-40B4-BE49-F238E27FC236}">
-                <a16:creationId xmlns:a16="http://schemas.microsoft.com/office/drawing/2014/main" id="{1EEE10DD-DDCD-4A46-B562-DC21E6ECCAAF}"/>
+                <a16:creationId xmlns:a16="http://schemas.microsoft.com/office/drawing/2014/main" id="{6C1B2D01-A7F6-46A2-AFC8-8D8C68D44D37}"/>
               </a:ext>
             </a:extLst>
           </p:cNvPr>
@@ -15783,7 +17202,7 @@
           <p:cNvPr id="18" name="">
             <a:extLst xmlns:a="http://schemas.openxmlformats.org/drawingml/2006/main">
               <a:ext uri="{FF2B5EF4-FFF2-40B4-BE49-F238E27FC236}">
-                <a16:creationId xmlns:a16="http://schemas.microsoft.com/office/drawing/2014/main" id="{DAC37665-0060-4742-8F76-DC2096A86622}"/>
+                <a16:creationId xmlns:a16="http://schemas.microsoft.com/office/drawing/2014/main" id="{2FAA3C1B-6FFA-4E1B-A35E-16D91114F15D}"/>
               </a:ext>
             </a:extLst>
           </p:cNvPr>
@@ -15837,7 +17256,7 @@
     </p:spTree>
     <p:extLst>
       <p:ext uri="{BB962C8B-B14F-4D97-AF65-F5344CB8AC3E}">
-        <p14:creationId xmlns:p14="http://schemas.microsoft.com/office/powerpoint/2010/main" val="932372252"/>
+        <p14:creationId xmlns:p14="http://schemas.microsoft.com/office/powerpoint/2010/main" val="1487393638"/>
       </p:ext>
     </p:extLst>
   </p:cSld>
@@ -15868,7 +17287,7 @@
           <p:cNvPr id="1" name="">
             <a:extLst xmlns:a="http://schemas.openxmlformats.org/drawingml/2006/main">
               <a:ext uri="{FF2B5EF4-FFF2-40B4-BE49-F238E27FC236}">
-                <a16:creationId xmlns:a16="http://schemas.microsoft.com/office/drawing/2014/main" id="{465F4160-97EA-47AA-8CD9-E483EE82399E}"/>
+                <a16:creationId xmlns:a16="http://schemas.microsoft.com/office/drawing/2014/main" id="{3184F5F0-2C35-46F5-904B-6827850F5688}"/>
               </a:ext>
             </a:extLst>
           </p:cNvPr>
@@ -15924,7 +17343,7 @@
           <p:cNvPr id="2" name="">
             <a:extLst xmlns:a="http://schemas.openxmlformats.org/drawingml/2006/main">
               <a:ext uri="{FF2B5EF4-FFF2-40B4-BE49-F238E27FC236}">
-                <a16:creationId xmlns:a16="http://schemas.microsoft.com/office/drawing/2014/main" id="{D89577DF-0FEA-4E5A-A2E1-A807C3B71079}"/>
+                <a16:creationId xmlns:a16="http://schemas.microsoft.com/office/drawing/2014/main" id="{05049CE5-EF30-494C-AB62-886690AEB5D1}"/>
               </a:ext>
             </a:extLst>
           </p:cNvPr>
@@ -15980,7 +17399,7 @@
           <p:cNvPr id="3" name="">
             <a:extLst xmlns:a="http://schemas.openxmlformats.org/drawingml/2006/main">
               <a:ext uri="{FF2B5EF4-FFF2-40B4-BE49-F238E27FC236}">
-                <a16:creationId xmlns:a16="http://schemas.microsoft.com/office/drawing/2014/main" id="{B921A657-4750-474F-BB29-D13C0F756465}"/>
+                <a16:creationId xmlns:a16="http://schemas.microsoft.com/office/drawing/2014/main" id="{FF07B17B-A444-4E0B-B8DD-5A1B0D28DDE3}"/>
               </a:ext>
             </a:extLst>
           </p:cNvPr>
@@ -16036,7 +17455,7 @@
           <p:cNvPr id="4" name="rule">
             <a:extLst xmlns:a="http://schemas.openxmlformats.org/drawingml/2006/main">
               <a:ext uri="{FF2B5EF4-FFF2-40B4-BE49-F238E27FC236}">
-                <a16:creationId xmlns:a16="http://schemas.microsoft.com/office/drawing/2014/main" id="{531A8D95-6196-4A5B-997E-63CA91545235}"/>
+                <a16:creationId xmlns:a16="http://schemas.microsoft.com/office/drawing/2014/main" id="{E3E0B34B-F934-4017-B35B-BD10D94A088A}"/>
               </a:ext>
             </a:extLst>
           </p:cNvPr>
@@ -16067,7 +17486,7 @@
           <p:cNvPr id="5" name="">
             <a:extLst xmlns:a="http://schemas.openxmlformats.org/drawingml/2006/main">
               <a:ext uri="{FF2B5EF4-FFF2-40B4-BE49-F238E27FC236}">
-                <a16:creationId xmlns:a16="http://schemas.microsoft.com/office/drawing/2014/main" id="{82EB25EA-2E0D-40CB-B4D0-BFF03CBA3F05}"/>
+                <a16:creationId xmlns:a16="http://schemas.microsoft.com/office/drawing/2014/main" id="{D2B03627-8112-4947-8F8B-DD9683DF0C98}"/>
               </a:ext>
             </a:extLst>
           </p:cNvPr>
@@ -16100,7 +17519,7 @@
           <p:cNvPr id="6" name="">
             <a:extLst xmlns:a="http://schemas.openxmlformats.org/drawingml/2006/main">
               <a:ext uri="{FF2B5EF4-FFF2-40B4-BE49-F238E27FC236}">
-                <a16:creationId xmlns:a16="http://schemas.microsoft.com/office/drawing/2014/main" id="{8AD613DC-A0FB-4096-823D-42EE92021366}"/>
+                <a16:creationId xmlns:a16="http://schemas.microsoft.com/office/drawing/2014/main" id="{36650A52-A659-4D02-A6D7-D006B7A0E56F}"/>
               </a:ext>
             </a:extLst>
           </p:cNvPr>
@@ -16131,7 +17550,7 @@
           <p:cNvPr id="7" name="">
             <a:extLst xmlns:a="http://schemas.openxmlformats.org/drawingml/2006/main">
               <a:ext uri="{FF2B5EF4-FFF2-40B4-BE49-F238E27FC236}">
-                <a16:creationId xmlns:a16="http://schemas.microsoft.com/office/drawing/2014/main" id="{1574B6F6-7090-4EAC-AAA2-6911F18237BE}"/>
+                <a16:creationId xmlns:a16="http://schemas.microsoft.com/office/drawing/2014/main" id="{B97F608F-7049-4EA7-9F2C-FD3339634005}"/>
               </a:ext>
             </a:extLst>
           </p:cNvPr>
@@ -16187,7 +17606,7 @@
           <p:cNvPr id="8" name="">
             <a:extLst xmlns:a="http://schemas.openxmlformats.org/drawingml/2006/main">
               <a:ext uri="{FF2B5EF4-FFF2-40B4-BE49-F238E27FC236}">
-                <a16:creationId xmlns:a16="http://schemas.microsoft.com/office/drawing/2014/main" id="{72329D0C-7426-47BF-ADFA-1689B3B3B3F9}"/>
+                <a16:creationId xmlns:a16="http://schemas.microsoft.com/office/drawing/2014/main" id="{2F7D3D41-CE43-46EF-82B6-95DA52833112}"/>
               </a:ext>
             </a:extLst>
           </p:cNvPr>
@@ -16243,7 +17662,7 @@
           <p:cNvPr id="9" name="">
             <a:extLst xmlns:a="http://schemas.openxmlformats.org/drawingml/2006/main">
               <a:ext uri="{FF2B5EF4-FFF2-40B4-BE49-F238E27FC236}">
-                <a16:creationId xmlns:a16="http://schemas.microsoft.com/office/drawing/2014/main" id="{A4A19EBE-E9A4-49D3-AB6E-41A9A6D3188D}"/>
+                <a16:creationId xmlns:a16="http://schemas.microsoft.com/office/drawing/2014/main" id="{805BEB1C-A1A9-4CE3-BC2B-B80BF76235AD}"/>
               </a:ext>
             </a:extLst>
           </p:cNvPr>
@@ -16299,7 +17718,7 @@
           <p:cNvPr id="10" name="">
             <a:extLst xmlns:a="http://schemas.openxmlformats.org/drawingml/2006/main">
               <a:ext uri="{FF2B5EF4-FFF2-40B4-BE49-F238E27FC236}">
-                <a16:creationId xmlns:a16="http://schemas.microsoft.com/office/drawing/2014/main" id="{5CDD05C5-C3C5-4571-8C98-D417A0EEE7F5}"/>
+                <a16:creationId xmlns:a16="http://schemas.microsoft.com/office/drawing/2014/main" id="{DCDB3D08-2EA1-441D-BC49-CB2D1A593C55}"/>
               </a:ext>
             </a:extLst>
           </p:cNvPr>
@@ -16332,7 +17751,7 @@
           <p:cNvPr id="11" name="">
             <a:extLst xmlns:a="http://schemas.openxmlformats.org/drawingml/2006/main">
               <a:ext uri="{FF2B5EF4-FFF2-40B4-BE49-F238E27FC236}">
-                <a16:creationId xmlns:a16="http://schemas.microsoft.com/office/drawing/2014/main" id="{A1DFC1CD-2BD6-43CC-940E-AB4258D3C377}"/>
+                <a16:creationId xmlns:a16="http://schemas.microsoft.com/office/drawing/2014/main" id="{04AE76C6-B7F6-4209-B42E-EB3DEDE6B5E4}"/>
               </a:ext>
             </a:extLst>
           </p:cNvPr>
@@ -16363,7 +17782,7 @@
           <p:cNvPr id="12" name="">
             <a:extLst xmlns:a="http://schemas.openxmlformats.org/drawingml/2006/main">
               <a:ext uri="{FF2B5EF4-FFF2-40B4-BE49-F238E27FC236}">
-                <a16:creationId xmlns:a16="http://schemas.microsoft.com/office/drawing/2014/main" id="{D8E3AAE4-F515-4B89-A55B-C9420370A38D}"/>
+                <a16:creationId xmlns:a16="http://schemas.microsoft.com/office/drawing/2014/main" id="{9264A4FD-CB56-4C4E-AF1F-645D24881E37}"/>
               </a:ext>
             </a:extLst>
           </p:cNvPr>
@@ -16419,7 +17838,7 @@
           <p:cNvPr id="13" name="">
             <a:extLst xmlns:a="http://schemas.openxmlformats.org/drawingml/2006/main">
               <a:ext uri="{FF2B5EF4-FFF2-40B4-BE49-F238E27FC236}">
-                <a16:creationId xmlns:a16="http://schemas.microsoft.com/office/drawing/2014/main" id="{617AAA91-84DB-464A-88B9-A09560D30006}"/>
+                <a16:creationId xmlns:a16="http://schemas.microsoft.com/office/drawing/2014/main" id="{19DCB5A7-34AA-4201-951C-372199833765}"/>
               </a:ext>
             </a:extLst>
           </p:cNvPr>
@@ -16475,7 +17894,7 @@
           <p:cNvPr id="14" name="">
             <a:extLst xmlns:a="http://schemas.openxmlformats.org/drawingml/2006/main">
               <a:ext uri="{FF2B5EF4-FFF2-40B4-BE49-F238E27FC236}">
-                <a16:creationId xmlns:a16="http://schemas.microsoft.com/office/drawing/2014/main" id="{E074CACB-CFCC-4E40-8485-A9CB87E21114}"/>
+                <a16:creationId xmlns:a16="http://schemas.microsoft.com/office/drawing/2014/main" id="{C32E3E34-9B0D-4EEC-A312-A19AEA8923AA}"/>
               </a:ext>
             </a:extLst>
           </p:cNvPr>
@@ -16531,7 +17950,7 @@
           <p:cNvPr id="15" name="">
             <a:extLst xmlns:a="http://schemas.openxmlformats.org/drawingml/2006/main">
               <a:ext uri="{FF2B5EF4-FFF2-40B4-BE49-F238E27FC236}">
-                <a16:creationId xmlns:a16="http://schemas.microsoft.com/office/drawing/2014/main" id="{0150044D-94A4-4F06-B960-7F50D0F8BE1B}"/>
+                <a16:creationId xmlns:a16="http://schemas.microsoft.com/office/drawing/2014/main" id="{2C0B55C9-97C5-444C-9D2B-F1B755A39148}"/>
               </a:ext>
             </a:extLst>
           </p:cNvPr>
@@ -16564,7 +17983,7 @@
           <p:cNvPr id="16" name="">
             <a:extLst xmlns:a="http://schemas.openxmlformats.org/drawingml/2006/main">
               <a:ext uri="{FF2B5EF4-FFF2-40B4-BE49-F238E27FC236}">
-                <a16:creationId xmlns:a16="http://schemas.microsoft.com/office/drawing/2014/main" id="{80B2FD68-0F8A-4E24-8984-21D5110B6AD2}"/>
+                <a16:creationId xmlns:a16="http://schemas.microsoft.com/office/drawing/2014/main" id="{EC2CCB41-9136-49A9-B953-0681F69C45C2}"/>
               </a:ext>
             </a:extLst>
           </p:cNvPr>
@@ -16595,7 +18014,7 @@
           <p:cNvPr id="17" name="">
             <a:extLst xmlns:a="http://schemas.openxmlformats.org/drawingml/2006/main">
               <a:ext uri="{FF2B5EF4-FFF2-40B4-BE49-F238E27FC236}">
-                <a16:creationId xmlns:a16="http://schemas.microsoft.com/office/drawing/2014/main" id="{E627FB14-03C0-46A3-844E-6FACB452C8F3}"/>
+                <a16:creationId xmlns:a16="http://schemas.microsoft.com/office/drawing/2014/main" id="{F29666D3-6C71-445A-AEA1-0995215440FC}"/>
               </a:ext>
             </a:extLst>
           </p:cNvPr>
@@ -16651,7 +18070,7 @@
           <p:cNvPr id="18" name="">
             <a:extLst xmlns:a="http://schemas.openxmlformats.org/drawingml/2006/main">
               <a:ext uri="{FF2B5EF4-FFF2-40B4-BE49-F238E27FC236}">
-                <a16:creationId xmlns:a16="http://schemas.microsoft.com/office/drawing/2014/main" id="{7AEE5241-8359-497D-8963-98A4DB0CBDCF}"/>
+                <a16:creationId xmlns:a16="http://schemas.microsoft.com/office/drawing/2014/main" id="{D4EB5FC4-335F-4F78-864D-44393E63D76F}"/>
               </a:ext>
             </a:extLst>
           </p:cNvPr>
@@ -16707,7 +18126,7 @@
           <p:cNvPr id="19" name="">
             <a:extLst xmlns:a="http://schemas.openxmlformats.org/drawingml/2006/main">
               <a:ext uri="{FF2B5EF4-FFF2-40B4-BE49-F238E27FC236}">
-                <a16:creationId xmlns:a16="http://schemas.microsoft.com/office/drawing/2014/main" id="{CAC14A38-CBAB-4AF9-BC93-F119BFD094D4}"/>
+                <a16:creationId xmlns:a16="http://schemas.microsoft.com/office/drawing/2014/main" id="{DE41E059-AC92-4387-949D-3D533EBC3D60}"/>
               </a:ext>
             </a:extLst>
           </p:cNvPr>
@@ -16763,7 +18182,7 @@
           <p:cNvPr id="20" name="">
             <a:extLst xmlns:a="http://schemas.openxmlformats.org/drawingml/2006/main">
               <a:ext uri="{FF2B5EF4-FFF2-40B4-BE49-F238E27FC236}">
-                <a16:creationId xmlns:a16="http://schemas.microsoft.com/office/drawing/2014/main" id="{142EC6AB-A10E-4033-B079-E5066FD5CF07}"/>
+                <a16:creationId xmlns:a16="http://schemas.microsoft.com/office/drawing/2014/main" id="{FAEADD77-6FBB-4563-BECB-3255003BAA8A}"/>
               </a:ext>
             </a:extLst>
           </p:cNvPr>
@@ -16796,7 +18215,7 @@
           <p:cNvPr id="21" name="">
             <a:extLst xmlns:a="http://schemas.openxmlformats.org/drawingml/2006/main">
               <a:ext uri="{FF2B5EF4-FFF2-40B4-BE49-F238E27FC236}">
-                <a16:creationId xmlns:a16="http://schemas.microsoft.com/office/drawing/2014/main" id="{6719CBC8-5D42-4A32-8E2F-63005DDACA61}"/>
+                <a16:creationId xmlns:a16="http://schemas.microsoft.com/office/drawing/2014/main" id="{FF3A073A-0F78-4941-A28F-658D673C2AFB}"/>
               </a:ext>
             </a:extLst>
           </p:cNvPr>
@@ -16827,7 +18246,7 @@
           <p:cNvPr id="22" name="">
             <a:extLst xmlns:a="http://schemas.openxmlformats.org/drawingml/2006/main">
               <a:ext uri="{FF2B5EF4-FFF2-40B4-BE49-F238E27FC236}">
-                <a16:creationId xmlns:a16="http://schemas.microsoft.com/office/drawing/2014/main" id="{EB50B57D-3007-47E0-B0CE-330EA15F8AEF}"/>
+                <a16:creationId xmlns:a16="http://schemas.microsoft.com/office/drawing/2014/main" id="{E3D6BB18-B52A-4023-80F8-3B5BA1A9C8B9}"/>
               </a:ext>
             </a:extLst>
           </p:cNvPr>
@@ -16883,7 +18302,7 @@
           <p:cNvPr id="23" name="">
             <a:extLst xmlns:a="http://schemas.openxmlformats.org/drawingml/2006/main">
               <a:ext uri="{FF2B5EF4-FFF2-40B4-BE49-F238E27FC236}">
-                <a16:creationId xmlns:a16="http://schemas.microsoft.com/office/drawing/2014/main" id="{DDDE180A-2AFB-4542-A019-D142611188EA}"/>
+                <a16:creationId xmlns:a16="http://schemas.microsoft.com/office/drawing/2014/main" id="{C3861CAC-59F0-4D34-976D-6DAC152CFEDE}"/>
               </a:ext>
             </a:extLst>
           </p:cNvPr>
@@ -16939,7 +18358,7 @@
           <p:cNvPr id="24" name="">
             <a:extLst xmlns:a="http://schemas.openxmlformats.org/drawingml/2006/main">
               <a:ext uri="{FF2B5EF4-FFF2-40B4-BE49-F238E27FC236}">
-                <a16:creationId xmlns:a16="http://schemas.microsoft.com/office/drawing/2014/main" id="{BB69A67B-C441-4AD1-881C-B419F5C04F33}"/>
+                <a16:creationId xmlns:a16="http://schemas.microsoft.com/office/drawing/2014/main" id="{763D4F4D-2986-42DC-9279-368C02A4FC1F}"/>
               </a:ext>
             </a:extLst>
           </p:cNvPr>
@@ -16995,7 +18414,7 @@
           <p:cNvPr id="25" name="">
             <a:extLst xmlns:a="http://schemas.openxmlformats.org/drawingml/2006/main">
               <a:ext uri="{FF2B5EF4-FFF2-40B4-BE49-F238E27FC236}">
-                <a16:creationId xmlns:a16="http://schemas.microsoft.com/office/drawing/2014/main" id="{FB31A0C7-0747-43D5-997F-31C9DB128D28}"/>
+                <a16:creationId xmlns:a16="http://schemas.microsoft.com/office/drawing/2014/main" id="{92AFB378-42AE-4FE4-B9F1-9AFD663D0B97}"/>
               </a:ext>
             </a:extLst>
           </p:cNvPr>
@@ -17028,7 +18447,7 @@
           <p:cNvPr id="26" name="">
             <a:extLst xmlns:a="http://schemas.openxmlformats.org/drawingml/2006/main">
               <a:ext uri="{FF2B5EF4-FFF2-40B4-BE49-F238E27FC236}">
-                <a16:creationId xmlns:a16="http://schemas.microsoft.com/office/drawing/2014/main" id="{BB620189-23C6-4CD8-BCBA-AAF53F3BD094}"/>
+                <a16:creationId xmlns:a16="http://schemas.microsoft.com/office/drawing/2014/main" id="{9E9561BF-FBFA-4B06-B261-45D539D419E4}"/>
               </a:ext>
             </a:extLst>
           </p:cNvPr>
@@ -17059,7 +18478,7 @@
           <p:cNvPr id="27" name="">
             <a:extLst xmlns:a="http://schemas.openxmlformats.org/drawingml/2006/main">
               <a:ext uri="{FF2B5EF4-FFF2-40B4-BE49-F238E27FC236}">
-                <a16:creationId xmlns:a16="http://schemas.microsoft.com/office/drawing/2014/main" id="{A144A2E1-A698-4358-8473-BCD7B7AA1209}"/>
+                <a16:creationId xmlns:a16="http://schemas.microsoft.com/office/drawing/2014/main" id="{16065BEA-5110-4DEE-85B7-4850F8C455ED}"/>
               </a:ext>
             </a:extLst>
           </p:cNvPr>
@@ -17115,7 +18534,7 @@
           <p:cNvPr id="28" name="">
             <a:extLst xmlns:a="http://schemas.openxmlformats.org/drawingml/2006/main">
               <a:ext uri="{FF2B5EF4-FFF2-40B4-BE49-F238E27FC236}">
-                <a16:creationId xmlns:a16="http://schemas.microsoft.com/office/drawing/2014/main" id="{0A76E9ED-8231-4374-942E-3B474917DEB0}"/>
+                <a16:creationId xmlns:a16="http://schemas.microsoft.com/office/drawing/2014/main" id="{473D6A8B-5168-47CF-987A-1EC2CA85C9B2}"/>
               </a:ext>
             </a:extLst>
           </p:cNvPr>
@@ -17171,7 +18590,7 @@
           <p:cNvPr id="29" name="">
             <a:extLst xmlns:a="http://schemas.openxmlformats.org/drawingml/2006/main">
               <a:ext uri="{FF2B5EF4-FFF2-40B4-BE49-F238E27FC236}">
-                <a16:creationId xmlns:a16="http://schemas.microsoft.com/office/drawing/2014/main" id="{C9BAFE8F-19B4-466F-B302-56FFB1D56AE1}"/>
+                <a16:creationId xmlns:a16="http://schemas.microsoft.com/office/drawing/2014/main" id="{74CFD028-008F-4BC9-B994-1589AFDB0F09}"/>
               </a:ext>
             </a:extLst>
           </p:cNvPr>
@@ -17227,7 +18646,7 @@
           <p:cNvPr id="30" name="">
             <a:extLst xmlns:a="http://schemas.openxmlformats.org/drawingml/2006/main">
               <a:ext uri="{FF2B5EF4-FFF2-40B4-BE49-F238E27FC236}">
-                <a16:creationId xmlns:a16="http://schemas.microsoft.com/office/drawing/2014/main" id="{C65547C1-F2B0-49F5-A036-60F25BF88E5C}"/>
+                <a16:creationId xmlns:a16="http://schemas.microsoft.com/office/drawing/2014/main" id="{301B6522-278D-486A-A554-CA6BAD50EBB0}"/>
               </a:ext>
             </a:extLst>
           </p:cNvPr>
@@ -17283,7 +18702,7 @@
           <p:cNvPr id="31" name="">
             <a:extLst xmlns:a="http://schemas.openxmlformats.org/drawingml/2006/main">
               <a:ext uri="{FF2B5EF4-FFF2-40B4-BE49-F238E27FC236}">
-                <a16:creationId xmlns:a16="http://schemas.microsoft.com/office/drawing/2014/main" id="{3F183644-9BF4-4ABD-9482-7B58A39ED1B6}"/>
+                <a16:creationId xmlns:a16="http://schemas.microsoft.com/office/drawing/2014/main" id="{FDADC749-15C7-4A87-AB66-4CA751E3393F}"/>
               </a:ext>
             </a:extLst>
           </p:cNvPr>
@@ -17337,7 +18756,7 @@
     </p:spTree>
     <p:extLst>
       <p:ext uri="{BB962C8B-B14F-4D97-AF65-F5344CB8AC3E}">
-        <p14:creationId xmlns:p14="http://schemas.microsoft.com/office/powerpoint/2010/main" val="630697602"/>
+        <p14:creationId xmlns:p14="http://schemas.microsoft.com/office/powerpoint/2010/main" val="1316251609"/>
       </p:ext>
     </p:extLst>
   </p:cSld>
@@ -17368,7 +18787,7 @@
           <p:cNvPr id="1" name="">
             <a:extLst xmlns:a="http://schemas.openxmlformats.org/drawingml/2006/main">
               <a:ext uri="{FF2B5EF4-FFF2-40B4-BE49-F238E27FC236}">
-                <a16:creationId xmlns:a16="http://schemas.microsoft.com/office/drawing/2014/main" id="{9AE01EBF-A95E-4D96-B820-DA063653B8D8}"/>
+                <a16:creationId xmlns:a16="http://schemas.microsoft.com/office/drawing/2014/main" id="{3A71F7C7-AFE4-48CF-A423-B753762636DE}"/>
               </a:ext>
             </a:extLst>
           </p:cNvPr>
@@ -17424,7 +18843,7 @@
           <p:cNvPr id="2" name="">
             <a:extLst xmlns:a="http://schemas.openxmlformats.org/drawingml/2006/main">
               <a:ext uri="{FF2B5EF4-FFF2-40B4-BE49-F238E27FC236}">
-                <a16:creationId xmlns:a16="http://schemas.microsoft.com/office/drawing/2014/main" id="{EE9A64CF-1C74-4BD2-8EF2-B1D6A9A2F3FC}"/>
+                <a16:creationId xmlns:a16="http://schemas.microsoft.com/office/drawing/2014/main" id="{E1CB9B22-40C0-4553-B572-4DA837A16CE4}"/>
               </a:ext>
             </a:extLst>
           </p:cNvPr>
@@ -17480,7 +18899,7 @@
           <p:cNvPr id="3" name="">
             <a:extLst xmlns:a="http://schemas.openxmlformats.org/drawingml/2006/main">
               <a:ext uri="{FF2B5EF4-FFF2-40B4-BE49-F238E27FC236}">
-                <a16:creationId xmlns:a16="http://schemas.microsoft.com/office/drawing/2014/main" id="{691FE5C5-2849-4975-894A-9DADDF6D752B}"/>
+                <a16:creationId xmlns:a16="http://schemas.microsoft.com/office/drawing/2014/main" id="{12CC148B-3BF6-47C6-9744-EAD9BB922F94}"/>
               </a:ext>
             </a:extLst>
           </p:cNvPr>
@@ -17536,7 +18955,7 @@
           <p:cNvPr id="4" name="rule">
             <a:extLst xmlns:a="http://schemas.openxmlformats.org/drawingml/2006/main">
               <a:ext uri="{FF2B5EF4-FFF2-40B4-BE49-F238E27FC236}">
-                <a16:creationId xmlns:a16="http://schemas.microsoft.com/office/drawing/2014/main" id="{171569CA-9745-4F02-AF1E-BD9AD4E14485}"/>
+                <a16:creationId xmlns:a16="http://schemas.microsoft.com/office/drawing/2014/main" id="{705C0CC0-627C-452F-9BB8-AE3F14D78B54}"/>
               </a:ext>
             </a:extLst>
           </p:cNvPr>
@@ -17567,7 +18986,7 @@
           <p:cNvPr id="5" name="">
             <a:extLst xmlns:a="http://schemas.openxmlformats.org/drawingml/2006/main">
               <a:ext uri="{FF2B5EF4-FFF2-40B4-BE49-F238E27FC236}">
-                <a16:creationId xmlns:a16="http://schemas.microsoft.com/office/drawing/2014/main" id="{33167CAA-F0F7-47DA-B44F-5CFE887F5611}"/>
+                <a16:creationId xmlns:a16="http://schemas.microsoft.com/office/drawing/2014/main" id="{A27D725B-1EA8-4280-BAAB-16ED3BE622FA}"/>
               </a:ext>
             </a:extLst>
           </p:cNvPr>
@@ -17623,7 +19042,7 @@
           <p:cNvPr id="6" name="">
             <a:extLst xmlns:a="http://schemas.openxmlformats.org/drawingml/2006/main">
               <a:ext uri="{FF2B5EF4-FFF2-40B4-BE49-F238E27FC236}">
-                <a16:creationId xmlns:a16="http://schemas.microsoft.com/office/drawing/2014/main" id="{C3C94D55-DB66-4372-A223-FFA5E7FA97A1}"/>
+                <a16:creationId xmlns:a16="http://schemas.microsoft.com/office/drawing/2014/main" id="{DD11F9B9-87D4-4C5D-B3F6-2BB334805E3A}"/>
               </a:ext>
             </a:extLst>
           </p:cNvPr>
@@ -17656,7 +19075,7 @@
           <p:cNvPr id="7" name="">
             <a:extLst xmlns:a="http://schemas.openxmlformats.org/drawingml/2006/main">
               <a:ext uri="{FF2B5EF4-FFF2-40B4-BE49-F238E27FC236}">
-                <a16:creationId xmlns:a16="http://schemas.microsoft.com/office/drawing/2014/main" id="{A95ED8ED-29FF-4A54-A69B-1E222DC667EF}"/>
+                <a16:creationId xmlns:a16="http://schemas.microsoft.com/office/drawing/2014/main" id="{89385149-803D-4806-B9EF-2C52EA23E415}"/>
               </a:ext>
             </a:extLst>
           </p:cNvPr>
@@ -17687,7 +19106,7 @@
           <p:cNvPr id="8" name="">
             <a:extLst xmlns:a="http://schemas.openxmlformats.org/drawingml/2006/main">
               <a:ext uri="{FF2B5EF4-FFF2-40B4-BE49-F238E27FC236}">
-                <a16:creationId xmlns:a16="http://schemas.microsoft.com/office/drawing/2014/main" id="{D1FAF0EE-EC5E-4B5D-8645-48D5A4315A8E}"/>
+                <a16:creationId xmlns:a16="http://schemas.microsoft.com/office/drawing/2014/main" id="{89BDA586-D84A-4823-BE99-8DDE1F29FCF0}"/>
               </a:ext>
             </a:extLst>
           </p:cNvPr>
@@ -17743,7 +19162,7 @@
           <p:cNvPr id="9" name="">
             <a:extLst xmlns:a="http://schemas.openxmlformats.org/drawingml/2006/main">
               <a:ext uri="{FF2B5EF4-FFF2-40B4-BE49-F238E27FC236}">
-                <a16:creationId xmlns:a16="http://schemas.microsoft.com/office/drawing/2014/main" id="{6F305313-D685-4365-8DDA-25ED54604541}"/>
+                <a16:creationId xmlns:a16="http://schemas.microsoft.com/office/drawing/2014/main" id="{C9483797-3F5A-4BF2-8477-15D6C8B6E485}"/>
               </a:ext>
             </a:extLst>
           </p:cNvPr>
@@ -17799,7 +19218,7 @@
           <p:cNvPr id="10" name="">
             <a:extLst xmlns:a="http://schemas.openxmlformats.org/drawingml/2006/main">
               <a:ext uri="{FF2B5EF4-FFF2-40B4-BE49-F238E27FC236}">
-                <a16:creationId xmlns:a16="http://schemas.microsoft.com/office/drawing/2014/main" id="{D541FCCE-CD79-4C23-B7B9-02D375AF5789}"/>
+                <a16:creationId xmlns:a16="http://schemas.microsoft.com/office/drawing/2014/main" id="{A54645EC-BCF8-43C2-810F-85637B404D78}"/>
               </a:ext>
             </a:extLst>
           </p:cNvPr>
@@ -17832,7 +19251,7 @@
           <p:cNvPr id="11" name="">
             <a:extLst xmlns:a="http://schemas.openxmlformats.org/drawingml/2006/main">
               <a:ext uri="{FF2B5EF4-FFF2-40B4-BE49-F238E27FC236}">
-                <a16:creationId xmlns:a16="http://schemas.microsoft.com/office/drawing/2014/main" id="{21E88AF0-CE98-497C-B205-8BC9E9F2CB49}"/>
+                <a16:creationId xmlns:a16="http://schemas.microsoft.com/office/drawing/2014/main" id="{65144277-4BB9-4D7A-A848-60C27E03B393}"/>
               </a:ext>
             </a:extLst>
           </p:cNvPr>
@@ -17863,7 +19282,7 @@
           <p:cNvPr id="12" name="">
             <a:extLst xmlns:a="http://schemas.openxmlformats.org/drawingml/2006/main">
               <a:ext uri="{FF2B5EF4-FFF2-40B4-BE49-F238E27FC236}">
-                <a16:creationId xmlns:a16="http://schemas.microsoft.com/office/drawing/2014/main" id="{6715DC5B-81F4-4280-9099-6D1E86F64D71}"/>
+                <a16:creationId xmlns:a16="http://schemas.microsoft.com/office/drawing/2014/main" id="{85826737-373C-4228-A4F0-5C46E28E1003}"/>
               </a:ext>
             </a:extLst>
           </p:cNvPr>
@@ -17919,7 +19338,7 @@
           <p:cNvPr id="13" name="">
             <a:extLst xmlns:a="http://schemas.openxmlformats.org/drawingml/2006/main">
               <a:ext uri="{FF2B5EF4-FFF2-40B4-BE49-F238E27FC236}">
-                <a16:creationId xmlns:a16="http://schemas.microsoft.com/office/drawing/2014/main" id="{CDBC9079-85FE-4274-BCF9-C418B40E53FE}"/>
+                <a16:creationId xmlns:a16="http://schemas.microsoft.com/office/drawing/2014/main" id="{4312B2B0-8B34-4D0E-AE3D-FA3DEE2BB634}"/>
               </a:ext>
             </a:extLst>
           </p:cNvPr>
@@ -17975,7 +19394,7 @@
           <p:cNvPr id="14" name="">
             <a:extLst xmlns:a="http://schemas.openxmlformats.org/drawingml/2006/main">
               <a:ext uri="{FF2B5EF4-FFF2-40B4-BE49-F238E27FC236}">
-                <a16:creationId xmlns:a16="http://schemas.microsoft.com/office/drawing/2014/main" id="{E3CE86C2-D020-4280-9DBA-B1939F65DA2F}"/>
+                <a16:creationId xmlns:a16="http://schemas.microsoft.com/office/drawing/2014/main" id="{A068FDEE-E146-4B22-BAE0-5AC975B0249D}"/>
               </a:ext>
             </a:extLst>
           </p:cNvPr>
@@ -18008,7 +19427,7 @@
           <p:cNvPr id="15" name="">
             <a:extLst xmlns:a="http://schemas.openxmlformats.org/drawingml/2006/main">
               <a:ext uri="{FF2B5EF4-FFF2-40B4-BE49-F238E27FC236}">
-                <a16:creationId xmlns:a16="http://schemas.microsoft.com/office/drawing/2014/main" id="{2EFEC027-20C0-4416-B5DE-980E8A41BC8C}"/>
+                <a16:creationId xmlns:a16="http://schemas.microsoft.com/office/drawing/2014/main" id="{B173526E-D6A0-42D0-8F15-C730C03B4CD5}"/>
               </a:ext>
             </a:extLst>
           </p:cNvPr>
@@ -18039,7 +19458,7 @@
           <p:cNvPr id="16" name="">
             <a:extLst xmlns:a="http://schemas.openxmlformats.org/drawingml/2006/main">
               <a:ext uri="{FF2B5EF4-FFF2-40B4-BE49-F238E27FC236}">
-                <a16:creationId xmlns:a16="http://schemas.microsoft.com/office/drawing/2014/main" id="{FACF7361-D157-41A3-9D4A-1B0820349E02}"/>
+                <a16:creationId xmlns:a16="http://schemas.microsoft.com/office/drawing/2014/main" id="{6B38FCC8-B8D9-4050-B531-F0894134743A}"/>
               </a:ext>
             </a:extLst>
           </p:cNvPr>
@@ -18095,7 +19514,7 @@
           <p:cNvPr id="17" name="">
             <a:extLst xmlns:a="http://schemas.openxmlformats.org/drawingml/2006/main">
               <a:ext uri="{FF2B5EF4-FFF2-40B4-BE49-F238E27FC236}">
-                <a16:creationId xmlns:a16="http://schemas.microsoft.com/office/drawing/2014/main" id="{F71BD7A6-1244-4E95-82B7-E5E7D97579EE}"/>
+                <a16:creationId xmlns:a16="http://schemas.microsoft.com/office/drawing/2014/main" id="{E0CDD17E-98E2-4E49-8484-44CC3C85047E}"/>
               </a:ext>
             </a:extLst>
           </p:cNvPr>
@@ -18151,7 +19570,7 @@
           <p:cNvPr id="18" name="">
             <a:extLst xmlns:a="http://schemas.openxmlformats.org/drawingml/2006/main">
               <a:ext uri="{FF2B5EF4-FFF2-40B4-BE49-F238E27FC236}">
-                <a16:creationId xmlns:a16="http://schemas.microsoft.com/office/drawing/2014/main" id="{20F144F9-45F1-4D20-A033-AE0AA9152FB9}"/>
+                <a16:creationId xmlns:a16="http://schemas.microsoft.com/office/drawing/2014/main" id="{3DF9F8F5-EB0F-4F1A-8EFF-923EA32F2E83}"/>
               </a:ext>
             </a:extLst>
           </p:cNvPr>
@@ -18184,7 +19603,7 @@
           <p:cNvPr id="19" name="">
             <a:extLst xmlns:a="http://schemas.openxmlformats.org/drawingml/2006/main">
               <a:ext uri="{FF2B5EF4-FFF2-40B4-BE49-F238E27FC236}">
-                <a16:creationId xmlns:a16="http://schemas.microsoft.com/office/drawing/2014/main" id="{CCB4BC14-E3CE-47D2-90DD-90705AE06DBD}"/>
+                <a16:creationId xmlns:a16="http://schemas.microsoft.com/office/drawing/2014/main" id="{FC159585-4A53-4407-A168-34402354A450}"/>
               </a:ext>
             </a:extLst>
           </p:cNvPr>
@@ -18215,7 +19634,7 @@
           <p:cNvPr id="20" name="">
             <a:extLst xmlns:a="http://schemas.openxmlformats.org/drawingml/2006/main">
               <a:ext uri="{FF2B5EF4-FFF2-40B4-BE49-F238E27FC236}">
-                <a16:creationId xmlns:a16="http://schemas.microsoft.com/office/drawing/2014/main" id="{2AA4C892-DA89-4E01-B5EE-43265210FF24}"/>
+                <a16:creationId xmlns:a16="http://schemas.microsoft.com/office/drawing/2014/main" id="{73AD038E-350B-47B1-966B-76FA3E6D3AA8}"/>
               </a:ext>
             </a:extLst>
           </p:cNvPr>
@@ -18271,7 +19690,7 @@
           <p:cNvPr id="21" name="">
             <a:extLst xmlns:a="http://schemas.openxmlformats.org/drawingml/2006/main">
               <a:ext uri="{FF2B5EF4-FFF2-40B4-BE49-F238E27FC236}">
-                <a16:creationId xmlns:a16="http://schemas.microsoft.com/office/drawing/2014/main" id="{45474B16-AD63-46E3-9B97-B0C359E1F6FC}"/>
+                <a16:creationId xmlns:a16="http://schemas.microsoft.com/office/drawing/2014/main" id="{D7638F41-C2F0-477D-92B1-3F52304FB704}"/>
               </a:ext>
             </a:extLst>
           </p:cNvPr>
@@ -18304,7 +19723,7 @@
           <p:cNvPr id="22" name="">
             <a:extLst xmlns:a="http://schemas.openxmlformats.org/drawingml/2006/main">
               <a:ext uri="{FF2B5EF4-FFF2-40B4-BE49-F238E27FC236}">
-                <a16:creationId xmlns:a16="http://schemas.microsoft.com/office/drawing/2014/main" id="{1DD88EFE-C354-4EEE-A0F7-39DC437F3CF0}"/>
+                <a16:creationId xmlns:a16="http://schemas.microsoft.com/office/drawing/2014/main" id="{7BA4A5B1-6198-462A-A6F8-BEC39E76E73B}"/>
               </a:ext>
             </a:extLst>
           </p:cNvPr>
@@ -18360,7 +19779,7 @@
           <p:cNvPr id="23" name="">
             <a:extLst xmlns:a="http://schemas.openxmlformats.org/drawingml/2006/main">
               <a:ext uri="{FF2B5EF4-FFF2-40B4-BE49-F238E27FC236}">
-                <a16:creationId xmlns:a16="http://schemas.microsoft.com/office/drawing/2014/main" id="{52C26C78-059E-45AA-9ED0-4F58BD92A17F}"/>
+                <a16:creationId xmlns:a16="http://schemas.microsoft.com/office/drawing/2014/main" id="{89817530-6D94-4BBC-AB51-1275491BB077}"/>
               </a:ext>
             </a:extLst>
           </p:cNvPr>
@@ -18416,7 +19835,7 @@
           <p:cNvPr id="24" name="">
             <a:extLst xmlns:a="http://schemas.openxmlformats.org/drawingml/2006/main">
               <a:ext uri="{FF2B5EF4-FFF2-40B4-BE49-F238E27FC236}">
-                <a16:creationId xmlns:a16="http://schemas.microsoft.com/office/drawing/2014/main" id="{6BAA425E-941D-466E-9C72-3F35611F9922}"/>
+                <a16:creationId xmlns:a16="http://schemas.microsoft.com/office/drawing/2014/main" id="{57C42716-1DBE-4542-AB4B-D7C994C0E0A1}"/>
               </a:ext>
             </a:extLst>
           </p:cNvPr>
@@ -18449,7 +19868,7 @@
           <p:cNvPr id="25" name="">
             <a:extLst xmlns:a="http://schemas.openxmlformats.org/drawingml/2006/main">
               <a:ext uri="{FF2B5EF4-FFF2-40B4-BE49-F238E27FC236}">
-                <a16:creationId xmlns:a16="http://schemas.microsoft.com/office/drawing/2014/main" id="{42454A2E-DEA9-42D1-8EF7-154C02C15DA3}"/>
+                <a16:creationId xmlns:a16="http://schemas.microsoft.com/office/drawing/2014/main" id="{DD9D4F95-1598-4AD0-8B9B-818DC8F71774}"/>
               </a:ext>
             </a:extLst>
           </p:cNvPr>
@@ -18505,7 +19924,7 @@
           <p:cNvPr id="26" name="">
             <a:extLst xmlns:a="http://schemas.openxmlformats.org/drawingml/2006/main">
               <a:ext uri="{FF2B5EF4-FFF2-40B4-BE49-F238E27FC236}">
-                <a16:creationId xmlns:a16="http://schemas.microsoft.com/office/drawing/2014/main" id="{36E3864A-3F56-453B-B810-C5ED3B95B690}"/>
+                <a16:creationId xmlns:a16="http://schemas.microsoft.com/office/drawing/2014/main" id="{EA838F8D-5383-46B4-AC01-57BA3DEBFB01}"/>
               </a:ext>
             </a:extLst>
           </p:cNvPr>
@@ -18561,7 +19980,7 @@
           <p:cNvPr id="27" name="">
             <a:extLst xmlns:a="http://schemas.openxmlformats.org/drawingml/2006/main">
               <a:ext uri="{FF2B5EF4-FFF2-40B4-BE49-F238E27FC236}">
-                <a16:creationId xmlns:a16="http://schemas.microsoft.com/office/drawing/2014/main" id="{04D35A3B-8B7A-4233-9DFB-5B388DBB4DF5}"/>
+                <a16:creationId xmlns:a16="http://schemas.microsoft.com/office/drawing/2014/main" id="{5F566DDE-6C4C-4364-A3E9-B846D47153A2}"/>
               </a:ext>
             </a:extLst>
           </p:cNvPr>
@@ -18617,7 +20036,7 @@
           <p:cNvPr id="28" name="">
             <a:extLst xmlns:a="http://schemas.openxmlformats.org/drawingml/2006/main">
               <a:ext uri="{FF2B5EF4-FFF2-40B4-BE49-F238E27FC236}">
-                <a16:creationId xmlns:a16="http://schemas.microsoft.com/office/drawing/2014/main" id="{87316218-DA72-41EE-9A8D-29668BA7E02B}"/>
+                <a16:creationId xmlns:a16="http://schemas.microsoft.com/office/drawing/2014/main" id="{FB101B66-B130-4CE5-8208-C5FCF79905D1}"/>
               </a:ext>
             </a:extLst>
           </p:cNvPr>
@@ -18650,7 +20069,7 @@
           <p:cNvPr id="29" name="">
             <a:extLst xmlns:a="http://schemas.openxmlformats.org/drawingml/2006/main">
               <a:ext uri="{FF2B5EF4-FFF2-40B4-BE49-F238E27FC236}">
-                <a16:creationId xmlns:a16="http://schemas.microsoft.com/office/drawing/2014/main" id="{EC7D07B4-62E0-4CF8-A103-F842E68DF278}"/>
+                <a16:creationId xmlns:a16="http://schemas.microsoft.com/office/drawing/2014/main" id="{DB4B34AB-A718-41CE-891A-1D34A5093056}"/>
               </a:ext>
             </a:extLst>
           </p:cNvPr>
@@ -18706,7 +20125,7 @@
           <p:cNvPr id="30" name="">
             <a:extLst xmlns:a="http://schemas.openxmlformats.org/drawingml/2006/main">
               <a:ext uri="{FF2B5EF4-FFF2-40B4-BE49-F238E27FC236}">
-                <a16:creationId xmlns:a16="http://schemas.microsoft.com/office/drawing/2014/main" id="{6832EBEF-B3AF-4D9D-8C53-B8C30335D9ED}"/>
+                <a16:creationId xmlns:a16="http://schemas.microsoft.com/office/drawing/2014/main" id="{799766DA-B3D5-45EE-8482-633139091BC7}"/>
               </a:ext>
             </a:extLst>
           </p:cNvPr>
@@ -18762,7 +20181,7 @@
           <p:cNvPr id="31" name="">
             <a:extLst xmlns:a="http://schemas.openxmlformats.org/drawingml/2006/main">
               <a:ext uri="{FF2B5EF4-FFF2-40B4-BE49-F238E27FC236}">
-                <a16:creationId xmlns:a16="http://schemas.microsoft.com/office/drawing/2014/main" id="{5F183184-DDE4-4029-9E24-F8AABE6DD08E}"/>
+                <a16:creationId xmlns:a16="http://schemas.microsoft.com/office/drawing/2014/main" id="{C9BE024C-481C-43AF-9B57-96920CB8046E}"/>
               </a:ext>
             </a:extLst>
           </p:cNvPr>
@@ -18818,7 +20237,7 @@
           <p:cNvPr id="32" name="">
             <a:extLst xmlns:a="http://schemas.openxmlformats.org/drawingml/2006/main">
               <a:ext uri="{FF2B5EF4-FFF2-40B4-BE49-F238E27FC236}">
-                <a16:creationId xmlns:a16="http://schemas.microsoft.com/office/drawing/2014/main" id="{F37A0987-6F5D-40EC-B17A-5AB29AD6B889}"/>
+                <a16:creationId xmlns:a16="http://schemas.microsoft.com/office/drawing/2014/main" id="{F6192E8F-01D3-4A55-99CF-69DC3F816D4A}"/>
               </a:ext>
             </a:extLst>
           </p:cNvPr>
@@ -18872,7 +20291,7 @@
     </p:spTree>
     <p:extLst>
       <p:ext uri="{BB962C8B-B14F-4D97-AF65-F5344CB8AC3E}">
-        <p14:creationId xmlns:p14="http://schemas.microsoft.com/office/powerpoint/2010/main" val="329372419"/>
+        <p14:creationId xmlns:p14="http://schemas.microsoft.com/office/powerpoint/2010/main" val="773372785"/>
       </p:ext>
     </p:extLst>
   </p:cSld>

</xml_diff>